<commit_message>
docs(presentation): add request flow step-by-step slide
Explains the six steps of the unified-health request (telemetry check,
P1-P7, Wave 2 signals, DST fusion, logging) with speaker notes.

Co-Authored-By: Claude Opus 5.5 <noreply@anthropic.com>
Claude-Session: https://claude.ai/code/session_01F96Sh6kL5Mvj9m6qX6kkqv
</commit_message>
<xml_diff>
--- a/presentation/technical_defense_final_v2.pptx
+++ b/presentation/technical_defense_final_v2.pptx
@@ -26,8 +26,9 @@
     <p:sldId id="272" r:id="rId17"/>
     <p:sldId id="273" r:id="rId18"/>
     <p:sldId id="274" r:id="rId19"/>
+    <p:sldId id="294" r:id="rId44"/>
+    <p:sldId id="275" r:id="rId20"/>
     <p:sldId id="293" r:id="rId43"/>
-    <p:sldId id="275" r:id="rId20"/>
     <p:sldId id="276" r:id="rId21"/>
     <p:sldId id="292" r:id="rId42"/>
     <p:sldId id="277" r:id="rId22"/>
@@ -927,6 +928,76 @@
 </file>
 
 <file path=ppt/notesSlides/notesSlide6.xml><?xml version="1.0" encoding="utf-8"?>
+<p:notes xmlns:a="http://schemas.openxmlformats.org/drawingml/2006/main" xmlns:p="http://schemas.openxmlformats.org/presentationml/2006/main" xmlns:r="http://schemas.openxmlformats.org/officeDocument/2006/relationships">
+  <p:cSld>
+    <p:spTree>
+      <p:nvGrpSpPr>
+        <p:cNvPr id="1" name=""/>
+        <p:cNvGrpSpPr/>
+        <p:nvPr/>
+      </p:nvGrpSpPr>
+      <p:grpSpPr>
+        <a:xfrm>
+          <a:off x="0" y="0"/>
+          <a:ext cx="0" cy="0"/>
+          <a:chOff x="0" y="0"/>
+          <a:chExt cx="0" cy="0"/>
+        </a:xfrm>
+      </p:grpSpPr>
+      <p:sp>
+        <p:nvSpPr>
+          <p:cNvPr id="2" name="Slide Image Placeholder 1"/>
+          <p:cNvSpPr>
+            <a:spLocks noGrp="1"/>
+          </p:cNvSpPr>
+          <p:nvPr>
+            <p:ph type="sldImg" idx="2"/>
+          </p:nvPr>
+        </p:nvSpPr>
+        <p:spPr/>
+      </p:sp>
+      <p:sp>
+        <p:nvSpPr>
+          <p:cNvPr id="3" name="Notes Placeholder 2"/>
+          <p:cNvSpPr>
+            <a:spLocks noGrp="1"/>
+          </p:cNvSpPr>
+          <p:nvPr>
+            <p:ph type="body" idx="3" sz="quarter"/>
+          </p:nvPr>
+        </p:nvSpPr>
+        <p:spPr/>
+        <p:txBody>
+          <a:bodyPr/>
+          <a:lstStyle/>
+          <a:p>
+            <a:r>
+              <a:t>This is what happens when a user opens a machine's ML Intelligence panel. The frontend sends GET /machines/{id}/unified-health to the backend. The backend first loads the machine's latest real sensor readings. If there are none, it sets telemetry_available to false and does not call the models: it never substitutes placeholder values, because fabricated inputs would give every machine the same meaningless prediction. With telemetry, two things run concurrently: the ML microservice runs the seven P1-P7 models on the current sensor snapshot, and the Wave 2 signals (CUSUM and Kalman for drift, Cox PH for survival, Mahalanobis for distance from normal behaviour, and the PINN) analyse the telemetry history. Dempster-Shafer fusion then combines all these signals into a single 0-100 health score and a verdict: Healthy, Degrading, Critical or Unknown. When the models strongly disagree, Yager's rule moves that conflict to Unknown instead of forcing a confident answer. Finally the result is logged in ml_prediction_logs, so predictions can be audited and compared with real interventions, and the panel updates. Without telemetry the platform still answers, using a score computed from the maintenance history only.</a:t>
+            </a:r>
+          </a:p>
+        </p:txBody>
+      </p:sp>
+      <p:sp>
+        <p:nvSpPr>
+          <p:cNvPr id="4" name="Slide Number Placeholder 3"/>
+          <p:cNvSpPr>
+            <a:spLocks noGrp="1"/>
+          </p:cNvSpPr>
+          <p:nvPr>
+            <p:ph type="sldNum" idx="5" sz="quarter"/>
+          </p:nvPr>
+        </p:nvSpPr>
+        <p:spPr/>
+      </p:sp>
+    </p:spTree>
+  </p:cSld>
+  <p:clrMapOvr>
+    <a:masterClrMapping/>
+  </p:clrMapOvr>
+</p:notes>
+</file>
+
+<file path=ppt/notesSlides/notesSlide7.xml><?xml version="1.0" encoding="utf-8"?>
 <p:notes xmlns:a="http://schemas.openxmlformats.org/drawingml/2006/main" xmlns:p="http://schemas.openxmlformats.org/presentationml/2006/main" xmlns:r="http://schemas.openxmlformats.org/officeDocument/2006/relationships">
   <p:cSld>
     <p:spTree>
@@ -16620,7 +16691,7 @@
                 </a:solidFill>
                 <a:latin typeface="Arial"/>
               </a:rPr>
-              <a:t>21</a:t>
+              <a:t>22</a:t>
             </a:r>
           </a:p>
         </p:txBody>
@@ -19245,7 +19316,7 @@
                 </a:solidFill>
                 <a:latin typeface="Arial"/>
               </a:rPr>
-              <a:t>23</a:t>
+              <a:t>24</a:t>
             </a:r>
           </a:p>
         </p:txBody>
@@ -22065,7 +22136,7 @@
                 </a:solidFill>
                 <a:latin typeface="Arial"/>
               </a:rPr>
-              <a:t>25</a:t>
+              <a:t>26</a:t>
             </a:r>
           </a:p>
         </p:txBody>
@@ -23682,7 +23753,7 @@
                 </a:solidFill>
                 <a:latin typeface="Arial"/>
               </a:rPr>
-              <a:t>26</a:t>
+              <a:t>27</a:t>
             </a:r>
           </a:p>
         </p:txBody>
@@ -24060,7 +24131,7 @@
                 </a:solidFill>
                 <a:latin typeface="Arial"/>
               </a:rPr>
-              <a:t>27</a:t>
+              <a:t>28</a:t>
             </a:r>
           </a:p>
         </p:txBody>
@@ -25479,7 +25550,7 @@
                 </a:solidFill>
                 <a:latin typeface="Arial"/>
               </a:rPr>
-              <a:t>28</a:t>
+              <a:t>29</a:t>
             </a:r>
           </a:p>
         </p:txBody>
@@ -26428,7 +26499,7 @@
                 </a:solidFill>
                 <a:latin typeface="Arial"/>
               </a:rPr>
-              <a:t>29</a:t>
+              <a:t>30</a:t>
             </a:r>
           </a:p>
         </p:txBody>
@@ -27984,7 +28055,7 @@
                 </a:solidFill>
                 <a:latin typeface="Arial"/>
               </a:rPr>
-              <a:t>30</a:t>
+              <a:t>31</a:t>
             </a:r>
           </a:p>
         </p:txBody>
@@ -28179,7 +28250,7 @@
                 </a:solidFill>
                 <a:latin typeface="Arial"/>
               </a:rPr>
-              <a:t>31</a:t>
+              <a:t>32</a:t>
             </a:r>
           </a:p>
         </p:txBody>
@@ -28346,7 +28417,7 @@
                 </a:solidFill>
                 <a:latin typeface="Arial"/>
               </a:rPr>
-              <a:t>32</a:t>
+              <a:t>33</a:t>
             </a:r>
           </a:p>
         </p:txBody>
@@ -28667,7 +28738,7 @@
                 </a:solidFill>
                 <a:latin typeface="Arial"/>
               </a:rPr>
-              <a:t>33</a:t>
+              <a:t>34</a:t>
             </a:r>
           </a:p>
         </p:txBody>
@@ -29969,7 +30040,7 @@
                 </a:solidFill>
                 <a:latin typeface="Arial"/>
               </a:rPr>
-              <a:t>34</a:t>
+              <a:t>35</a:t>
             </a:r>
           </a:p>
         </p:txBody>
@@ -30127,7 +30198,7 @@
                 </a:solidFill>
                 <a:latin typeface="Arial"/>
               </a:rPr>
-              <a:t>35</a:t>
+              <a:t>36</a:t>
             </a:r>
           </a:p>
         </p:txBody>
@@ -30684,7 +30755,7 @@
                 </a:solidFill>
                 <a:latin typeface="Arial"/>
               </a:rPr>
-              <a:t>36</a:t>
+              <a:t>37</a:t>
             </a:r>
           </a:p>
         </p:txBody>
@@ -31403,7 +31474,7 @@
                 </a:solidFill>
                 <a:latin typeface="Arial"/>
               </a:rPr>
-              <a:t>37</a:t>
+              <a:t>38</a:t>
             </a:r>
           </a:p>
         </p:txBody>
@@ -31562,7 +31633,7 @@
                 </a:solidFill>
                 <a:latin typeface="Arial"/>
               </a:rPr>
-              <a:t>24</a:t>
+              <a:t>25</a:t>
             </a:r>
           </a:p>
         </p:txBody>
@@ -33204,7 +33275,7 @@
                 </a:solidFill>
                 <a:latin typeface="Arial"/>
               </a:rPr>
-              <a:t>22</a:t>
+              <a:t>23</a:t>
             </a:r>
           </a:p>
         </p:txBody>
@@ -34393,6 +34464,1304 @@
 </file>
 
 <file path=ppt/slides/slide37.xml><?xml version="1.0" encoding="utf-8"?>
+<p:sld xmlns:a="http://schemas.openxmlformats.org/drawingml/2006/main" xmlns:p="http://schemas.openxmlformats.org/presentationml/2006/main" xmlns:r="http://schemas.openxmlformats.org/officeDocument/2006/relationships">
+  <p:cSld>
+    <p:spTree>
+      <p:nvGrpSpPr>
+        <p:cNvPr id="1" name=""/>
+        <p:cNvGrpSpPr/>
+        <p:nvPr/>
+      </p:nvGrpSpPr>
+      <p:grpSpPr/>
+      <p:sp>
+        <p:nvSpPr>
+          <p:cNvPr id="2" name="Section label"/>
+          <p:cNvSpPr txBox="1"/>
+          <p:nvPr/>
+        </p:nvSpPr>
+        <p:spPr>
+          <a:xfrm>
+            <a:off x="457200" y="201168"/>
+            <a:ext cx="8229600" cy="365760"/>
+          </a:xfrm>
+          <a:prstGeom prst="rect">
+            <a:avLst/>
+          </a:prstGeom>
+          <a:noFill/>
+        </p:spPr>
+        <p:txBody>
+          <a:bodyPr wrap="square" lIns="45720" rIns="45720" tIns="18288" bIns="18288" anchor="ctr">
+            <a:spAutoFit/>
+          </a:bodyPr>
+          <a:lstStyle/>
+          <a:p>
+            <a:pPr algn="l"/>
+            <a:r>
+              <a:rPr sz="1400" b="1" spc="200">
+                <a:solidFill>
+                  <a:srgbClr val="D0101A"/>
+                </a:solidFill>
+                <a:latin typeface="Arial"/>
+              </a:rPr>
+              <a:t>04. Design: Logical Architecture</a:t>
+            </a:r>
+          </a:p>
+        </p:txBody>
+      </p:sp>
+      <p:cxnSp>
+        <p:nvCxnSpPr>
+          <p:cNvPr id="3" name="Connector 2"/>
+          <p:cNvCxnSpPr/>
+          <p:nvPr/>
+        </p:nvCxnSpPr>
+        <p:spPr>
+          <a:xfrm>
+            <a:off x="457200" y="685800"/>
+            <a:ext cx="11274552" cy="0"/>
+          </a:xfrm>
+          <a:prstGeom prst="line">
+            <a:avLst/>
+          </a:prstGeom>
+          <a:ln w="12700">
+            <a:solidFill>
+              <a:srgbClr val="000000"/>
+            </a:solidFill>
+          </a:ln>
+          <a:effectLst/>
+        </p:spPr>
+        <p:style>
+          <a:lnRef idx="2">
+            <a:schemeClr val="accent1"/>
+          </a:lnRef>
+          <a:fillRef idx="0">
+            <a:schemeClr val="accent1"/>
+          </a:fillRef>
+          <a:effectRef idx="1">
+            <a:schemeClr val="accent1"/>
+          </a:effectRef>
+          <a:fontRef idx="minor">
+            <a:schemeClr val="tx1"/>
+          </a:fontRef>
+        </p:style>
+      </p:cxnSp>
+      <p:sp>
+        <p:nvSpPr>
+          <p:cNvPr id="4" name="Title"/>
+          <p:cNvSpPr txBox="1"/>
+          <p:nvPr/>
+        </p:nvSpPr>
+        <p:spPr>
+          <a:xfrm>
+            <a:off x="457200" y="749808"/>
+            <a:ext cx="11274552" cy="685800"/>
+          </a:xfrm>
+          <a:prstGeom prst="rect">
+            <a:avLst/>
+          </a:prstGeom>
+          <a:noFill/>
+        </p:spPr>
+        <p:txBody>
+          <a:bodyPr wrap="square" lIns="45720" rIns="45720" tIns="18288" bIns="18288" anchor="ctr">
+            <a:spAutoFit/>
+          </a:bodyPr>
+          <a:lstStyle/>
+          <a:p>
+            <a:pPr algn="ctr"/>
+            <a:r>
+              <a:rPr sz="2600" b="0">
+                <a:solidFill>
+                  <a:srgbClr val="0A1045"/>
+                </a:solidFill>
+                <a:latin typeface="Arial Black"/>
+              </a:rPr>
+              <a:t>Request Flow: Step by Step</a:t>
+            </a:r>
+          </a:p>
+        </p:txBody>
+      </p:sp>
+      <p:sp>
+        <p:nvSpPr>
+          <p:cNvPr id="5" name="Page number"/>
+          <p:cNvSpPr txBox="1"/>
+          <p:nvPr/>
+        </p:nvSpPr>
+        <p:spPr>
+          <a:xfrm>
+            <a:off x="11247120" y="6446520"/>
+            <a:ext cx="640080" cy="274320"/>
+          </a:xfrm>
+          <a:prstGeom prst="rect">
+            <a:avLst/>
+          </a:prstGeom>
+          <a:noFill/>
+        </p:spPr>
+        <p:txBody>
+          <a:bodyPr wrap="square" lIns="45720" rIns="45720" tIns="18288" bIns="18288" anchor="ctr">
+            <a:spAutoFit/>
+          </a:bodyPr>
+          <a:lstStyle/>
+          <a:p>
+            <a:pPr algn="r"/>
+            <a:r>
+              <a:rPr sz="1200" b="0">
+                <a:solidFill>
+                  <a:srgbClr val="000000"/>
+                </a:solidFill>
+                <a:latin typeface="Arial"/>
+              </a:rPr>
+              <a:t>21</a:t>
+            </a:r>
+          </a:p>
+        </p:txBody>
+      </p:sp>
+      <p:sp>
+        <p:nvSpPr>
+          <p:cNvPr id="6" name="Card 1"/>
+          <p:cNvSpPr/>
+          <p:nvPr/>
+        </p:nvSpPr>
+        <p:spPr>
+          <a:xfrm>
+            <a:off x="457200" y="1760220"/>
+            <a:ext cx="3666744" cy="1645920"/>
+          </a:xfrm>
+          <a:prstGeom prst="roundRect">
+            <a:avLst>
+              <a:gd name="adj" fmla="val 12000"/>
+            </a:avLst>
+          </a:prstGeom>
+          <a:noFill/>
+          <a:ln w="25400">
+            <a:solidFill>
+              <a:srgbClr val="5B5243"/>
+            </a:solidFill>
+          </a:ln>
+          <a:effectLst/>
+        </p:spPr>
+        <p:style>
+          <a:lnRef idx="1">
+            <a:schemeClr val="accent1"/>
+          </a:lnRef>
+          <a:fillRef idx="3">
+            <a:schemeClr val="accent1"/>
+          </a:fillRef>
+          <a:effectRef idx="2">
+            <a:schemeClr val="accent1"/>
+          </a:effectRef>
+          <a:fontRef idx="minor">
+            <a:schemeClr val="lt1"/>
+          </a:fontRef>
+        </p:style>
+        <p:txBody>
+          <a:bodyPr rtlCol="0" anchor="ctr"/>
+          <a:lstStyle/>
+          <a:p>
+            <a:pPr algn="ctr"/>
+          </a:p>
+        </p:txBody>
+      </p:sp>
+      <p:sp>
+        <p:nvSpPr>
+          <p:cNvPr id="7" name="Chip 1"/>
+          <p:cNvSpPr/>
+          <p:nvPr/>
+        </p:nvSpPr>
+        <p:spPr>
+          <a:xfrm>
+            <a:off x="918972" y="1554480"/>
+            <a:ext cx="2743200" cy="411480"/>
+          </a:xfrm>
+          <a:prstGeom prst="roundRect">
+            <a:avLst>
+              <a:gd name="adj" fmla="val 40000"/>
+            </a:avLst>
+          </a:prstGeom>
+          <a:solidFill>
+            <a:srgbClr val="FDE8E8"/>
+          </a:solidFill>
+          <a:ln>
+            <a:noFill/>
+          </a:ln>
+          <a:effectLst/>
+        </p:spPr>
+        <p:style>
+          <a:lnRef idx="1">
+            <a:schemeClr val="accent1"/>
+          </a:lnRef>
+          <a:fillRef idx="3">
+            <a:schemeClr val="accent1"/>
+          </a:fillRef>
+          <a:effectRef idx="2">
+            <a:schemeClr val="accent1"/>
+          </a:effectRef>
+          <a:fontRef idx="minor">
+            <a:schemeClr val="lt1"/>
+          </a:fontRef>
+        </p:style>
+        <p:txBody>
+          <a:bodyPr rtlCol="0" anchor="ctr" lIns="45720" rIns="45720"/>
+          <a:lstStyle/>
+          <a:p>
+            <a:pPr algn="ctr"/>
+            <a:r>
+              <a:rPr sz="1300" b="1">
+                <a:solidFill>
+                  <a:srgbClr val="000000"/>
+                </a:solidFill>
+                <a:latin typeface="Arial"/>
+              </a:rPr>
+              <a:t>1 · Frontend asks</a:t>
+            </a:r>
+          </a:p>
+        </p:txBody>
+      </p:sp>
+      <p:sp>
+        <p:nvSpPr>
+          <p:cNvPr id="8" name="Card text 1"/>
+          <p:cNvSpPr txBox="1"/>
+          <p:nvPr/>
+        </p:nvSpPr>
+        <p:spPr>
+          <a:xfrm>
+            <a:off x="548640" y="2011680"/>
+            <a:ext cx="3483864" cy="1348740"/>
+          </a:xfrm>
+          <a:prstGeom prst="rect">
+            <a:avLst/>
+          </a:prstGeom>
+          <a:noFill/>
+        </p:spPr>
+        <p:txBody>
+          <a:bodyPr wrap="square" lIns="45720" rIns="45720" tIns="18288" bIns="18288" anchor="ctr">
+            <a:spAutoFit/>
+          </a:bodyPr>
+          <a:lstStyle/>
+          <a:p>
+            <a:pPr algn="l"/>
+            <a:r>
+              <a:rPr sz="1400" b="0">
+                <a:solidFill>
+                  <a:srgbClr val="333333"/>
+                </a:solidFill>
+                <a:latin typeface="Arial"/>
+              </a:rPr>
+              <a:t>Opening a machine's ML panel sends </a:t>
+            </a:r>
+            <a:r>
+              <a:rPr sz="1400" b="1">
+                <a:solidFill>
+                  <a:srgbClr val="000000"/>
+                </a:solidFill>
+                <a:latin typeface="Arial"/>
+              </a:rPr>
+              <a:t>GET /machines/{id}/unified-health</a:t>
+            </a:r>
+            <a:r>
+              <a:rPr sz="1400" b="0">
+                <a:solidFill>
+                  <a:srgbClr val="333333"/>
+                </a:solidFill>
+                <a:latin typeface="Arial"/>
+              </a:rPr>
+              <a:t> to the backend: a REST call that carries the user's </a:t>
+            </a:r>
+            <a:r>
+              <a:rPr sz="1400" b="1">
+                <a:solidFill>
+                  <a:srgbClr val="000000"/>
+                </a:solidFill>
+                <a:latin typeface="Arial"/>
+              </a:rPr>
+              <a:t>JWT</a:t>
+            </a:r>
+            <a:r>
+              <a:rPr sz="1400" b="0">
+                <a:solidFill>
+                  <a:srgbClr val="333333"/>
+                </a:solidFill>
+                <a:latin typeface="Arial"/>
+              </a:rPr>
+              <a:t>.</a:t>
+            </a:r>
+          </a:p>
+        </p:txBody>
+      </p:sp>
+      <p:sp>
+        <p:nvSpPr>
+          <p:cNvPr id="9" name="Card 2"/>
+          <p:cNvSpPr/>
+          <p:nvPr/>
+        </p:nvSpPr>
+        <p:spPr>
+          <a:xfrm>
+            <a:off x="4261104" y="1760220"/>
+            <a:ext cx="3666744" cy="1645920"/>
+          </a:xfrm>
+          <a:prstGeom prst="roundRect">
+            <a:avLst>
+              <a:gd name="adj" fmla="val 12000"/>
+            </a:avLst>
+          </a:prstGeom>
+          <a:noFill/>
+          <a:ln w="25400">
+            <a:solidFill>
+              <a:srgbClr val="5B5243"/>
+            </a:solidFill>
+          </a:ln>
+          <a:effectLst/>
+        </p:spPr>
+        <p:style>
+          <a:lnRef idx="1">
+            <a:schemeClr val="accent1"/>
+          </a:lnRef>
+          <a:fillRef idx="3">
+            <a:schemeClr val="accent1"/>
+          </a:fillRef>
+          <a:effectRef idx="2">
+            <a:schemeClr val="accent1"/>
+          </a:effectRef>
+          <a:fontRef idx="minor">
+            <a:schemeClr val="lt1"/>
+          </a:fontRef>
+        </p:style>
+        <p:txBody>
+          <a:bodyPr rtlCol="0" anchor="ctr"/>
+          <a:lstStyle/>
+          <a:p>
+            <a:pPr algn="ctr"/>
+          </a:p>
+        </p:txBody>
+      </p:sp>
+      <p:sp>
+        <p:nvSpPr>
+          <p:cNvPr id="10" name="Chip 2"/>
+          <p:cNvSpPr/>
+          <p:nvPr/>
+        </p:nvSpPr>
+        <p:spPr>
+          <a:xfrm>
+            <a:off x="4722876" y="1554480"/>
+            <a:ext cx="2743200" cy="411480"/>
+          </a:xfrm>
+          <a:prstGeom prst="roundRect">
+            <a:avLst>
+              <a:gd name="adj" fmla="val 40000"/>
+            </a:avLst>
+          </a:prstGeom>
+          <a:solidFill>
+            <a:srgbClr val="FDE8E8"/>
+          </a:solidFill>
+          <a:ln>
+            <a:noFill/>
+          </a:ln>
+          <a:effectLst/>
+        </p:spPr>
+        <p:style>
+          <a:lnRef idx="1">
+            <a:schemeClr val="accent1"/>
+          </a:lnRef>
+          <a:fillRef idx="3">
+            <a:schemeClr val="accent1"/>
+          </a:fillRef>
+          <a:effectRef idx="2">
+            <a:schemeClr val="accent1"/>
+          </a:effectRef>
+          <a:fontRef idx="minor">
+            <a:schemeClr val="lt1"/>
+          </a:fontRef>
+        </p:style>
+        <p:txBody>
+          <a:bodyPr rtlCol="0" anchor="ctr" lIns="45720" rIns="45720"/>
+          <a:lstStyle/>
+          <a:p>
+            <a:pPr algn="ctr"/>
+            <a:r>
+              <a:rPr sz="1300" b="1">
+                <a:solidFill>
+                  <a:srgbClr val="000000"/>
+                </a:solidFill>
+                <a:latin typeface="Arial"/>
+              </a:rPr>
+              <a:t>2 · Backend reads telemetry</a:t>
+            </a:r>
+          </a:p>
+        </p:txBody>
+      </p:sp>
+      <p:sp>
+        <p:nvSpPr>
+          <p:cNvPr id="11" name="Card text 2"/>
+          <p:cNvSpPr txBox="1"/>
+          <p:nvPr/>
+        </p:nvSpPr>
+        <p:spPr>
+          <a:xfrm>
+            <a:off x="4352544" y="2011680"/>
+            <a:ext cx="3483864" cy="1348740"/>
+          </a:xfrm>
+          <a:prstGeom prst="rect">
+            <a:avLst/>
+          </a:prstGeom>
+          <a:noFill/>
+        </p:spPr>
+        <p:txBody>
+          <a:bodyPr wrap="square" lIns="45720" rIns="45720" tIns="18288" bIns="18288" anchor="ctr">
+            <a:spAutoFit/>
+          </a:bodyPr>
+          <a:lstStyle/>
+          <a:p>
+            <a:pPr algn="l"/>
+            <a:r>
+              <a:rPr sz="1400" b="0">
+                <a:solidFill>
+                  <a:srgbClr val="333333"/>
+                </a:solidFill>
+                <a:latin typeface="Arial"/>
+              </a:rPr>
+              <a:t>It loads the latest </a:t>
+            </a:r>
+            <a:r>
+              <a:rPr sz="1400" b="1">
+                <a:solidFill>
+                  <a:srgbClr val="000000"/>
+                </a:solidFill>
+                <a:latin typeface="Arial"/>
+              </a:rPr>
+              <a:t>real sensor readings</a:t>
+            </a:r>
+            <a:r>
+              <a:rPr sz="1400" b="0">
+                <a:solidFill>
+                  <a:srgbClr val="333333"/>
+                </a:solidFill>
+                <a:latin typeface="Arial"/>
+              </a:rPr>
+              <a:t> (temperatures, speed, torque, tool wear). If none are on record, </a:t>
+            </a:r>
+            <a:r>
+              <a:rPr sz="1400" b="1">
+                <a:solidFill>
+                  <a:srgbClr val="000000"/>
+                </a:solidFill>
+                <a:latin typeface="Arial"/>
+              </a:rPr>
+              <a:t>telemetry_available</a:t>
+            </a:r>
+            <a:r>
+              <a:rPr sz="1400" b="0">
+                <a:solidFill>
+                  <a:srgbClr val="333333"/>
+                </a:solidFill>
+                <a:latin typeface="Arial"/>
+              </a:rPr>
+              <a:t> is set to false and no model is called.</a:t>
+            </a:r>
+          </a:p>
+        </p:txBody>
+      </p:sp>
+      <p:sp>
+        <p:nvSpPr>
+          <p:cNvPr id="12" name="Card 3"/>
+          <p:cNvSpPr/>
+          <p:nvPr/>
+        </p:nvSpPr>
+        <p:spPr>
+          <a:xfrm>
+            <a:off x="8065008" y="1760220"/>
+            <a:ext cx="3666744" cy="1645920"/>
+          </a:xfrm>
+          <a:prstGeom prst="roundRect">
+            <a:avLst>
+              <a:gd name="adj" fmla="val 12000"/>
+            </a:avLst>
+          </a:prstGeom>
+          <a:noFill/>
+          <a:ln w="25400">
+            <a:solidFill>
+              <a:srgbClr val="5B5243"/>
+            </a:solidFill>
+          </a:ln>
+          <a:effectLst/>
+        </p:spPr>
+        <p:style>
+          <a:lnRef idx="1">
+            <a:schemeClr val="accent1"/>
+          </a:lnRef>
+          <a:fillRef idx="3">
+            <a:schemeClr val="accent1"/>
+          </a:fillRef>
+          <a:effectRef idx="2">
+            <a:schemeClr val="accent1"/>
+          </a:effectRef>
+          <a:fontRef idx="minor">
+            <a:schemeClr val="lt1"/>
+          </a:fontRef>
+        </p:style>
+        <p:txBody>
+          <a:bodyPr rtlCol="0" anchor="ctr"/>
+          <a:lstStyle/>
+          <a:p>
+            <a:pPr algn="ctr"/>
+          </a:p>
+        </p:txBody>
+      </p:sp>
+      <p:sp>
+        <p:nvSpPr>
+          <p:cNvPr id="13" name="Chip 3"/>
+          <p:cNvSpPr/>
+          <p:nvPr/>
+        </p:nvSpPr>
+        <p:spPr>
+          <a:xfrm>
+            <a:off x="8526780" y="1554480"/>
+            <a:ext cx="2743200" cy="411480"/>
+          </a:xfrm>
+          <a:prstGeom prst="roundRect">
+            <a:avLst>
+              <a:gd name="adj" fmla="val 40000"/>
+            </a:avLst>
+          </a:prstGeom>
+          <a:solidFill>
+            <a:srgbClr val="FDE8E8"/>
+          </a:solidFill>
+          <a:ln>
+            <a:noFill/>
+          </a:ln>
+          <a:effectLst/>
+        </p:spPr>
+        <p:style>
+          <a:lnRef idx="1">
+            <a:schemeClr val="accent1"/>
+          </a:lnRef>
+          <a:fillRef idx="3">
+            <a:schemeClr val="accent1"/>
+          </a:fillRef>
+          <a:effectRef idx="2">
+            <a:schemeClr val="accent1"/>
+          </a:effectRef>
+          <a:fontRef idx="minor">
+            <a:schemeClr val="lt1"/>
+          </a:fontRef>
+        </p:style>
+        <p:txBody>
+          <a:bodyPr rtlCol="0" anchor="ctr" lIns="45720" rIns="45720"/>
+          <a:lstStyle/>
+          <a:p>
+            <a:pPr algn="ctr"/>
+            <a:r>
+              <a:rPr sz="1300" b="1">
+                <a:solidFill>
+                  <a:srgbClr val="000000"/>
+                </a:solidFill>
+                <a:latin typeface="Arial"/>
+              </a:rPr>
+              <a:t>3 · ML microservice</a:t>
+            </a:r>
+          </a:p>
+        </p:txBody>
+      </p:sp>
+      <p:sp>
+        <p:nvSpPr>
+          <p:cNvPr id="14" name="Card text 3"/>
+          <p:cNvSpPr txBox="1"/>
+          <p:nvPr/>
+        </p:nvSpPr>
+        <p:spPr>
+          <a:xfrm>
+            <a:off x="8156448" y="2011680"/>
+            <a:ext cx="3483864" cy="1348740"/>
+          </a:xfrm>
+          <a:prstGeom prst="rect">
+            <a:avLst/>
+          </a:prstGeom>
+          <a:noFill/>
+        </p:spPr>
+        <p:txBody>
+          <a:bodyPr wrap="square" lIns="45720" rIns="45720" tIns="18288" bIns="18288" anchor="ctr">
+            <a:spAutoFit/>
+          </a:bodyPr>
+          <a:lstStyle/>
+          <a:p>
+            <a:pPr algn="l"/>
+            <a:r>
+              <a:rPr sz="1400" b="0">
+                <a:solidFill>
+                  <a:srgbClr val="333333"/>
+                </a:solidFill>
+                <a:latin typeface="Arial"/>
+              </a:rPr>
+              <a:t>The backend calls </a:t>
+            </a:r>
+            <a:r>
+              <a:rPr sz="1400" b="1">
+                <a:solidFill>
+                  <a:srgbClr val="000000"/>
+                </a:solidFill>
+                <a:latin typeface="Arial"/>
+              </a:rPr>
+              <a:t>/predict</a:t>
+            </a:r>
+            <a:r>
+              <a:rPr sz="1400" b="0">
+                <a:solidFill>
+                  <a:srgbClr val="333333"/>
+                </a:solidFill>
+                <a:latin typeface="Arial"/>
+              </a:rPr>
+              <a:t> with the sensor snapshot. </a:t>
+            </a:r>
+            <a:r>
+              <a:rPr sz="1400" b="1">
+                <a:solidFill>
+                  <a:srgbClr val="000000"/>
+                </a:solidFill>
+                <a:latin typeface="Arial"/>
+              </a:rPr>
+              <a:t>P1-P7</a:t>
+            </a:r>
+            <a:r>
+              <a:rPr sz="1400" b="0">
+                <a:solidFill>
+                  <a:srgbClr val="333333"/>
+                </a:solidFill>
+                <a:latin typeface="Arial"/>
+              </a:rPr>
+              <a:t> run in parallel: failure chance, failure type, remaining life, anomaly, priority, schedule, parts.</a:t>
+            </a:r>
+          </a:p>
+        </p:txBody>
+      </p:sp>
+      <p:sp>
+        <p:nvSpPr>
+          <p:cNvPr id="15" name="Card 4"/>
+          <p:cNvSpPr/>
+          <p:nvPr/>
+        </p:nvSpPr>
+        <p:spPr>
+          <a:xfrm>
+            <a:off x="457200" y="3931920"/>
+            <a:ext cx="3666744" cy="1645920"/>
+          </a:xfrm>
+          <a:prstGeom prst="roundRect">
+            <a:avLst>
+              <a:gd name="adj" fmla="val 12000"/>
+            </a:avLst>
+          </a:prstGeom>
+          <a:noFill/>
+          <a:ln w="25400">
+            <a:solidFill>
+              <a:srgbClr val="5B5243"/>
+            </a:solidFill>
+          </a:ln>
+          <a:effectLst/>
+        </p:spPr>
+        <p:style>
+          <a:lnRef idx="1">
+            <a:schemeClr val="accent1"/>
+          </a:lnRef>
+          <a:fillRef idx="3">
+            <a:schemeClr val="accent1"/>
+          </a:fillRef>
+          <a:effectRef idx="2">
+            <a:schemeClr val="accent1"/>
+          </a:effectRef>
+          <a:fontRef idx="minor">
+            <a:schemeClr val="lt1"/>
+          </a:fontRef>
+        </p:style>
+        <p:txBody>
+          <a:bodyPr rtlCol="0" anchor="ctr"/>
+          <a:lstStyle/>
+          <a:p>
+            <a:pPr algn="ctr"/>
+          </a:p>
+        </p:txBody>
+      </p:sp>
+      <p:sp>
+        <p:nvSpPr>
+          <p:cNvPr id="16" name="Chip 4"/>
+          <p:cNvSpPr/>
+          <p:nvPr/>
+        </p:nvSpPr>
+        <p:spPr>
+          <a:xfrm>
+            <a:off x="918972" y="3726180"/>
+            <a:ext cx="2743200" cy="411480"/>
+          </a:xfrm>
+          <a:prstGeom prst="roundRect">
+            <a:avLst>
+              <a:gd name="adj" fmla="val 40000"/>
+            </a:avLst>
+          </a:prstGeom>
+          <a:solidFill>
+            <a:srgbClr val="FDE8E8"/>
+          </a:solidFill>
+          <a:ln>
+            <a:noFill/>
+          </a:ln>
+          <a:effectLst/>
+        </p:spPr>
+        <p:style>
+          <a:lnRef idx="1">
+            <a:schemeClr val="accent1"/>
+          </a:lnRef>
+          <a:fillRef idx="3">
+            <a:schemeClr val="accent1"/>
+          </a:fillRef>
+          <a:effectRef idx="2">
+            <a:schemeClr val="accent1"/>
+          </a:effectRef>
+          <a:fontRef idx="minor">
+            <a:schemeClr val="lt1"/>
+          </a:fontRef>
+        </p:style>
+        <p:txBody>
+          <a:bodyPr rtlCol="0" anchor="ctr" lIns="45720" rIns="45720"/>
+          <a:lstStyle/>
+          <a:p>
+            <a:pPr algn="ctr"/>
+            <a:r>
+              <a:rPr sz="1300" b="1">
+                <a:solidFill>
+                  <a:srgbClr val="000000"/>
+                </a:solidFill>
+                <a:latin typeface="Arial"/>
+              </a:rPr>
+              <a:t>4 · Wave 2 signals</a:t>
+            </a:r>
+          </a:p>
+        </p:txBody>
+      </p:sp>
+      <p:sp>
+        <p:nvSpPr>
+          <p:cNvPr id="17" name="Card text 4"/>
+          <p:cNvSpPr txBox="1"/>
+          <p:nvPr/>
+        </p:nvSpPr>
+        <p:spPr>
+          <a:xfrm>
+            <a:off x="548640" y="4183380"/>
+            <a:ext cx="3483864" cy="1348740"/>
+          </a:xfrm>
+          <a:prstGeom prst="rect">
+            <a:avLst/>
+          </a:prstGeom>
+          <a:noFill/>
+        </p:spPr>
+        <p:txBody>
+          <a:bodyPr wrap="square" lIns="45720" rIns="45720" tIns="18288" bIns="18288" anchor="ctr">
+            <a:spAutoFit/>
+          </a:bodyPr>
+          <a:lstStyle/>
+          <a:p>
+            <a:pPr algn="l"/>
+            <a:r>
+              <a:rPr sz="1400" b="0">
+                <a:solidFill>
+                  <a:srgbClr val="333333"/>
+                </a:solidFill>
+                <a:latin typeface="Arial"/>
+              </a:rPr>
+              <a:t>At the same time, models read the </a:t>
+            </a:r>
+            <a:r>
+              <a:rPr sz="1400" b="1">
+                <a:solidFill>
+                  <a:srgbClr val="000000"/>
+                </a:solidFill>
+                <a:latin typeface="Arial"/>
+              </a:rPr>
+              <a:t>telemetry history</a:t>
+            </a:r>
+            <a:r>
+              <a:rPr sz="1400" b="0">
+                <a:solidFill>
+                  <a:srgbClr val="333333"/>
+                </a:solidFill>
+                <a:latin typeface="Arial"/>
+              </a:rPr>
+              <a:t> for trends: </a:t>
+            </a:r>
+            <a:r>
+              <a:rPr sz="1400" b="1">
+                <a:solidFill>
+                  <a:srgbClr val="000000"/>
+                </a:solidFill>
+                <a:latin typeface="Arial"/>
+              </a:rPr>
+              <a:t>CUSUM + Kalman</a:t>
+            </a:r>
+            <a:r>
+              <a:rPr sz="1400" b="0">
+                <a:solidFill>
+                  <a:srgbClr val="333333"/>
+                </a:solidFill>
+                <a:latin typeface="Arial"/>
+              </a:rPr>
+              <a:t> (slow drift), </a:t>
+            </a:r>
+            <a:r>
+              <a:rPr sz="1400" b="1">
+                <a:solidFill>
+                  <a:srgbClr val="000000"/>
+                </a:solidFill>
+                <a:latin typeface="Arial"/>
+              </a:rPr>
+              <a:t>Cox PH</a:t>
+            </a:r>
+            <a:r>
+              <a:rPr sz="1400" b="0">
+                <a:solidFill>
+                  <a:srgbClr val="333333"/>
+                </a:solidFill>
+                <a:latin typeface="Arial"/>
+              </a:rPr>
+              <a:t> (survival), </a:t>
+            </a:r>
+            <a:r>
+              <a:rPr sz="1400" b="1">
+                <a:solidFill>
+                  <a:srgbClr val="000000"/>
+                </a:solidFill>
+                <a:latin typeface="Arial"/>
+              </a:rPr>
+              <a:t>Mahalanobis</a:t>
+            </a:r>
+            <a:r>
+              <a:rPr sz="1400" b="0">
+                <a:solidFill>
+                  <a:srgbClr val="333333"/>
+                </a:solidFill>
+                <a:latin typeface="Arial"/>
+              </a:rPr>
+              <a:t> (distance from normal), </a:t>
+            </a:r>
+            <a:r>
+              <a:rPr sz="1400" b="1">
+                <a:solidFill>
+                  <a:srgbClr val="000000"/>
+                </a:solidFill>
+                <a:latin typeface="Arial"/>
+              </a:rPr>
+              <a:t>PINN</a:t>
+            </a:r>
+            <a:r>
+              <a:rPr sz="1400" b="0">
+                <a:solidFill>
+                  <a:srgbClr val="333333"/>
+                </a:solidFill>
+                <a:latin typeface="Arial"/>
+              </a:rPr>
+              <a:t>.</a:t>
+            </a:r>
+          </a:p>
+        </p:txBody>
+      </p:sp>
+      <p:sp>
+        <p:nvSpPr>
+          <p:cNvPr id="18" name="Card 5"/>
+          <p:cNvSpPr/>
+          <p:nvPr/>
+        </p:nvSpPr>
+        <p:spPr>
+          <a:xfrm>
+            <a:off x="4261104" y="3931920"/>
+            <a:ext cx="3666744" cy="1645920"/>
+          </a:xfrm>
+          <a:prstGeom prst="roundRect">
+            <a:avLst>
+              <a:gd name="adj" fmla="val 12000"/>
+            </a:avLst>
+          </a:prstGeom>
+          <a:noFill/>
+          <a:ln w="25400">
+            <a:solidFill>
+              <a:srgbClr val="5B5243"/>
+            </a:solidFill>
+          </a:ln>
+          <a:effectLst/>
+        </p:spPr>
+        <p:style>
+          <a:lnRef idx="1">
+            <a:schemeClr val="accent1"/>
+          </a:lnRef>
+          <a:fillRef idx="3">
+            <a:schemeClr val="accent1"/>
+          </a:fillRef>
+          <a:effectRef idx="2">
+            <a:schemeClr val="accent1"/>
+          </a:effectRef>
+          <a:fontRef idx="minor">
+            <a:schemeClr val="lt1"/>
+          </a:fontRef>
+        </p:style>
+        <p:txBody>
+          <a:bodyPr rtlCol="0" anchor="ctr"/>
+          <a:lstStyle/>
+          <a:p>
+            <a:pPr algn="ctr"/>
+          </a:p>
+        </p:txBody>
+      </p:sp>
+      <p:sp>
+        <p:nvSpPr>
+          <p:cNvPr id="19" name="Chip 5"/>
+          <p:cNvSpPr/>
+          <p:nvPr/>
+        </p:nvSpPr>
+        <p:spPr>
+          <a:xfrm>
+            <a:off x="4722876" y="3726180"/>
+            <a:ext cx="2743200" cy="411480"/>
+          </a:xfrm>
+          <a:prstGeom prst="roundRect">
+            <a:avLst>
+              <a:gd name="adj" fmla="val 40000"/>
+            </a:avLst>
+          </a:prstGeom>
+          <a:solidFill>
+            <a:srgbClr val="FDE8E8"/>
+          </a:solidFill>
+          <a:ln>
+            <a:noFill/>
+          </a:ln>
+          <a:effectLst/>
+        </p:spPr>
+        <p:style>
+          <a:lnRef idx="1">
+            <a:schemeClr val="accent1"/>
+          </a:lnRef>
+          <a:fillRef idx="3">
+            <a:schemeClr val="accent1"/>
+          </a:fillRef>
+          <a:effectRef idx="2">
+            <a:schemeClr val="accent1"/>
+          </a:effectRef>
+          <a:fontRef idx="minor">
+            <a:schemeClr val="lt1"/>
+          </a:fontRef>
+        </p:style>
+        <p:txBody>
+          <a:bodyPr rtlCol="0" anchor="ctr" lIns="45720" rIns="45720"/>
+          <a:lstStyle/>
+          <a:p>
+            <a:pPr algn="ctr"/>
+            <a:r>
+              <a:rPr sz="1300" b="1">
+                <a:solidFill>
+                  <a:srgbClr val="000000"/>
+                </a:solidFill>
+                <a:latin typeface="Arial"/>
+              </a:rPr>
+              <a:t>5 · DST fusion</a:t>
+            </a:r>
+          </a:p>
+        </p:txBody>
+      </p:sp>
+      <p:sp>
+        <p:nvSpPr>
+          <p:cNvPr id="20" name="Card text 5"/>
+          <p:cNvSpPr txBox="1"/>
+          <p:nvPr/>
+        </p:nvSpPr>
+        <p:spPr>
+          <a:xfrm>
+            <a:off x="4352544" y="4183380"/>
+            <a:ext cx="3483864" cy="1348740"/>
+          </a:xfrm>
+          <a:prstGeom prst="rect">
+            <a:avLst/>
+          </a:prstGeom>
+          <a:noFill/>
+        </p:spPr>
+        <p:txBody>
+          <a:bodyPr wrap="square" lIns="45720" rIns="45720" tIns="18288" bIns="18288" anchor="ctr">
+            <a:spAutoFit/>
+          </a:bodyPr>
+          <a:lstStyle/>
+          <a:p>
+            <a:pPr algn="l"/>
+            <a:r>
+              <a:rPr sz="1400" b="1">
+                <a:solidFill>
+                  <a:srgbClr val="000000"/>
+                </a:solidFill>
+                <a:latin typeface="Arial"/>
+              </a:rPr>
+              <a:t>Dempster-Shafer</a:t>
+            </a:r>
+            <a:r>
+              <a:rPr sz="1400" b="0">
+                <a:solidFill>
+                  <a:srgbClr val="333333"/>
+                </a:solidFill>
+                <a:latin typeface="Arial"/>
+              </a:rPr>
+              <a:t> merges every signal into one </a:t>
+            </a:r>
+            <a:r>
+              <a:rPr sz="1400" b="1">
+                <a:solidFill>
+                  <a:srgbClr val="000000"/>
+                </a:solidFill>
+                <a:latin typeface="Arial"/>
+              </a:rPr>
+              <a:t>0-100 score</a:t>
+            </a:r>
+            <a:r>
+              <a:rPr sz="1400" b="0">
+                <a:solidFill>
+                  <a:srgbClr val="333333"/>
+                </a:solidFill>
+                <a:latin typeface="Arial"/>
+              </a:rPr>
+              <a:t> and a verdict: Healthy, Degrading, Critical or </a:t>
+            </a:r>
+            <a:r>
+              <a:rPr sz="1400" b="1">
+                <a:solidFill>
+                  <a:srgbClr val="000000"/>
+                </a:solidFill>
+                <a:latin typeface="Arial"/>
+              </a:rPr>
+              <a:t>Unknown</a:t>
+            </a:r>
+            <a:r>
+              <a:rPr sz="1400" b="0">
+                <a:solidFill>
+                  <a:srgbClr val="333333"/>
+                </a:solidFill>
+                <a:latin typeface="Arial"/>
+              </a:rPr>
+              <a:t>. If the models disagree, </a:t>
+            </a:r>
+            <a:r>
+              <a:rPr sz="1400" b="1">
+                <a:solidFill>
+                  <a:srgbClr val="000000"/>
+                </a:solidFill>
+                <a:latin typeface="Arial"/>
+              </a:rPr>
+              <a:t>Yager's rule</a:t>
+            </a:r>
+            <a:r>
+              <a:rPr sz="1400" b="0">
+                <a:solidFill>
+                  <a:srgbClr val="333333"/>
+                </a:solidFill>
+                <a:latin typeface="Arial"/>
+              </a:rPr>
+              <a:t> keeps the answer cautious.</a:t>
+            </a:r>
+          </a:p>
+        </p:txBody>
+      </p:sp>
+      <p:sp>
+        <p:nvSpPr>
+          <p:cNvPr id="21" name="Card 6"/>
+          <p:cNvSpPr/>
+          <p:nvPr/>
+        </p:nvSpPr>
+        <p:spPr>
+          <a:xfrm>
+            <a:off x="8065008" y="3931920"/>
+            <a:ext cx="3666744" cy="1645920"/>
+          </a:xfrm>
+          <a:prstGeom prst="roundRect">
+            <a:avLst>
+              <a:gd name="adj" fmla="val 12000"/>
+            </a:avLst>
+          </a:prstGeom>
+          <a:noFill/>
+          <a:ln w="25400">
+            <a:solidFill>
+              <a:srgbClr val="5B5243"/>
+            </a:solidFill>
+          </a:ln>
+          <a:effectLst/>
+        </p:spPr>
+        <p:style>
+          <a:lnRef idx="1">
+            <a:schemeClr val="accent1"/>
+          </a:lnRef>
+          <a:fillRef idx="3">
+            <a:schemeClr val="accent1"/>
+          </a:fillRef>
+          <a:effectRef idx="2">
+            <a:schemeClr val="accent1"/>
+          </a:effectRef>
+          <a:fontRef idx="minor">
+            <a:schemeClr val="lt1"/>
+          </a:fontRef>
+        </p:style>
+        <p:txBody>
+          <a:bodyPr rtlCol="0" anchor="ctr"/>
+          <a:lstStyle/>
+          <a:p>
+            <a:pPr algn="ctr"/>
+          </a:p>
+        </p:txBody>
+      </p:sp>
+      <p:sp>
+        <p:nvSpPr>
+          <p:cNvPr id="22" name="Chip 6"/>
+          <p:cNvSpPr/>
+          <p:nvPr/>
+        </p:nvSpPr>
+        <p:spPr>
+          <a:xfrm>
+            <a:off x="8526780" y="3726180"/>
+            <a:ext cx="2743200" cy="411480"/>
+          </a:xfrm>
+          <a:prstGeom prst="roundRect">
+            <a:avLst>
+              <a:gd name="adj" fmla="val 40000"/>
+            </a:avLst>
+          </a:prstGeom>
+          <a:solidFill>
+            <a:srgbClr val="FDE8E8"/>
+          </a:solidFill>
+          <a:ln>
+            <a:noFill/>
+          </a:ln>
+          <a:effectLst/>
+        </p:spPr>
+        <p:style>
+          <a:lnRef idx="1">
+            <a:schemeClr val="accent1"/>
+          </a:lnRef>
+          <a:fillRef idx="3">
+            <a:schemeClr val="accent1"/>
+          </a:fillRef>
+          <a:effectRef idx="2">
+            <a:schemeClr val="accent1"/>
+          </a:effectRef>
+          <a:fontRef idx="minor">
+            <a:schemeClr val="lt1"/>
+          </a:fontRef>
+        </p:style>
+        <p:txBody>
+          <a:bodyPr rtlCol="0" anchor="ctr" lIns="45720" rIns="45720"/>
+          <a:lstStyle/>
+          <a:p>
+            <a:pPr algn="ctr"/>
+            <a:r>
+              <a:rPr sz="1300" b="1">
+                <a:solidFill>
+                  <a:srgbClr val="000000"/>
+                </a:solidFill>
+                <a:latin typeface="Arial"/>
+              </a:rPr>
+              <a:t>6 · Log &amp; render</a:t>
+            </a:r>
+          </a:p>
+        </p:txBody>
+      </p:sp>
+      <p:sp>
+        <p:nvSpPr>
+          <p:cNvPr id="23" name="Card text 6"/>
+          <p:cNvSpPr txBox="1"/>
+          <p:nvPr/>
+        </p:nvSpPr>
+        <p:spPr>
+          <a:xfrm>
+            <a:off x="8156448" y="4183380"/>
+            <a:ext cx="3483864" cy="1348740"/>
+          </a:xfrm>
+          <a:prstGeom prst="rect">
+            <a:avLst/>
+          </a:prstGeom>
+          <a:noFill/>
+        </p:spPr>
+        <p:txBody>
+          <a:bodyPr wrap="square" lIns="45720" rIns="45720" tIns="18288" bIns="18288" anchor="ctr">
+            <a:spAutoFit/>
+          </a:bodyPr>
+          <a:lstStyle/>
+          <a:p>
+            <a:pPr algn="l"/>
+            <a:r>
+              <a:rPr sz="1400" b="0">
+                <a:solidFill>
+                  <a:srgbClr val="333333"/>
+                </a:solidFill>
+                <a:latin typeface="Arial"/>
+              </a:rPr>
+              <a:t>The result is stored in </a:t>
+            </a:r>
+            <a:r>
+              <a:rPr sz="1400" b="1">
+                <a:solidFill>
+                  <a:srgbClr val="000000"/>
+                </a:solidFill>
+                <a:latin typeface="Arial"/>
+              </a:rPr>
+              <a:t>ml_prediction_logs</a:t>
+            </a:r>
+            <a:r>
+              <a:rPr sz="1400" b="0">
+                <a:solidFill>
+                  <a:srgbClr val="333333"/>
+                </a:solidFill>
+                <a:latin typeface="Arial"/>
+              </a:rPr>
+              <a:t>, for audit and to compare predictions with what really happened. Then the panel updates.</a:t>
+            </a:r>
+          </a:p>
+        </p:txBody>
+      </p:sp>
+      <p:sp>
+        <p:nvSpPr>
+          <p:cNvPr id="24" name="Key takeaway"/>
+          <p:cNvSpPr txBox="1"/>
+          <p:nvPr/>
+        </p:nvSpPr>
+        <p:spPr>
+          <a:xfrm>
+            <a:off x="457200" y="5760720"/>
+            <a:ext cx="11274552" cy="411480"/>
+          </a:xfrm>
+          <a:prstGeom prst="rect">
+            <a:avLst/>
+          </a:prstGeom>
+          <a:noFill/>
+        </p:spPr>
+        <p:txBody>
+          <a:bodyPr wrap="square" lIns="45720" rIns="45720" tIns="18288" bIns="18288" anchor="ctr">
+            <a:spAutoFit/>
+          </a:bodyPr>
+          <a:lstStyle/>
+          <a:p>
+            <a:pPr algn="ctr"/>
+            <a:r>
+              <a:rPr sz="1300" b="1">
+                <a:solidFill>
+                  <a:srgbClr val="D0101A"/>
+                </a:solidFill>
+                <a:latin typeface="Arial"/>
+              </a:rPr>
+              <a:t>Graceful degradation:</a:t>
+            </a:r>
+            <a:r>
+              <a:rPr sz="1300" b="0">
+                <a:solidFill>
+                  <a:srgbClr val="000000"/>
+                </a:solidFill>
+                <a:latin typeface="Arial"/>
+              </a:rPr>
+              <a:t> no telemetry means a maintenance-history-only score, never a fabricated prediction.</a:t>
+            </a:r>
+          </a:p>
+        </p:txBody>
+      </p:sp>
+    </p:spTree>
+  </p:cSld>
+  <p:clrMapOvr>
+    <a:masterClrMapping/>
+  </p:clrMapOvr>
+</p:sld>
+</file>
+
+<file path=ppt/slides/slide38.xml><?xml version="1.0" encoding="utf-8"?>
 <p:sld xmlns:a="http://schemas.openxmlformats.org/drawingml/2006/main" xmlns:p="http://schemas.openxmlformats.org/presentationml/2006/main" xmlns:r="http://schemas.openxmlformats.org/officeDocument/2006/relationships">
   <p:cSld>
     <p:spTree>

</xml_diff>

<commit_message>
docs(presentation): plain-language wording for Wave 2 and DST steps
Co-Authored-By: Claude Opus 5.5 <noreply@anthropic.com>
Claude-Session: https://claude.ai/code/session_01F96Sh6kL5Mvj9m6qX6kkqv
</commit_message>
<xml_diff>
--- a/presentation/technical_defense_final_v2.pptx
+++ b/presentation/technical_defense_final_v2.pptx
@@ -972,7 +972,7 @@
           <a:lstStyle/>
           <a:p>
             <a:r>
-              <a:t>This is what happens when a user opens a machine's ML Intelligence panel. The frontend sends GET /machines/{id}/unified-health to the backend. The backend first loads the machine's latest real sensor readings. If there are none, it sets telemetry_available to false and does not call the models: it never substitutes placeholder values, because fabricated inputs would give every machine the same meaningless prediction. With telemetry, two things run concurrently: the ML microservice runs the seven P1-P7 models on the current sensor snapshot, and the Wave 2 signals (CUSUM and Kalman for drift, Cox PH for survival, Mahalanobis for distance from normal behaviour, and the PINN) analyse the telemetry history. Dempster-Shafer fusion then combines all these signals into a single 0-100 health score and a verdict: Healthy, Degrading, Critical or Unknown. When the models strongly disagree, Yager's rule moves that conflict to Unknown instead of forcing a confident answer. Finally the result is logged in ml_prediction_logs, so predictions can be audited and compared with real interventions, and the panel updates. Without telemetry the platform still answers, using a score computed from the maintenance history only.</a:t>
+              <a:t>This is what happens when a user opens a machine's ML Intelligence panel. The frontend sends GET /machines/{id}/unified-health to the backend. The backend first loads the machine's latest real sensor readings. If there are none, it sets telemetry_available to false and does not call the models: it never substitutes placeholder values, because fabricated inputs would give every machine the same meaningless prediction. With telemetry, two things run concurrently: the ML microservice runs the seven P1-P7 models on the current sensor snapshot, and the Wave 2 signals analyse the telemetry history: CUSUM and a Kalman filter detect a slow decline over time, the Cox survival model estimates how long the machine can keep running, the Mahalanobis index measures how far it has drifted from its own normal behaviour, and the physics-informed network (PINN) keeps the estimates physically realistic. Dempster-Shafer fusion then combines all these signals into a single 0-100 health score and a verdict: Healthy, Degrading, Critical or Unknown. When the models strongly disagree, Yager's rule moves that conflict to Unknown instead of forcing a confident answer. Finally the result is logged in ml_prediction_logs, so predictions can be audited and compared with real interventions, and the panel updates. Without telemetry the platform still answers, using a score computed from the maintenance history only.</a:t>
             </a:r>
           </a:p>
         </p:txBody>
@@ -35261,7 +35261,7 @@
                 </a:solidFill>
                 <a:latin typeface="Arial"/>
               </a:rPr>
-              <a:t>At the same time, models read the </a:t>
+              <a:t>A second group of models studies the machine's </a:t>
             </a:r>
             <a:r>
               <a:rPr sz="1400" b="1">
@@ -35270,7 +35270,7 @@
                 </a:solidFill>
                 <a:latin typeface="Arial"/>
               </a:rPr>
-              <a:t>telemetry history</a:t>
+              <a:t>past readings</a:t>
             </a:r>
             <a:r>
               <a:rPr sz="1400" b="0">
@@ -35279,7 +35279,7 @@
                 </a:solidFill>
                 <a:latin typeface="Arial"/>
               </a:rPr>
-              <a:t> for trends: </a:t>
+              <a:t>. They catch a </a:t>
             </a:r>
             <a:r>
               <a:rPr sz="1400" b="1">
@@ -35288,7 +35288,7 @@
                 </a:solidFill>
                 <a:latin typeface="Arial"/>
               </a:rPr>
-              <a:t>CUSUM + Kalman</a:t>
+              <a:t>slow decline over time</a:t>
             </a:r>
             <a:r>
               <a:rPr sz="1400" b="0">
@@ -35297,7 +35297,7 @@
                 </a:solidFill>
                 <a:latin typeface="Arial"/>
               </a:rPr>
-              <a:t> (slow drift), </a:t>
+              <a:t>, estimate how long it can </a:t>
             </a:r>
             <a:r>
               <a:rPr sz="1400" b="1">
@@ -35306,7 +35306,7 @@
                 </a:solidFill>
                 <a:latin typeface="Arial"/>
               </a:rPr>
-              <a:t>Cox PH</a:t>
+              <a:t>keep running</a:t>
             </a:r>
             <a:r>
               <a:rPr sz="1400" b="0">
@@ -35315,7 +35315,7 @@
                 </a:solidFill>
                 <a:latin typeface="Arial"/>
               </a:rPr>
-              <a:t> (survival), </a:t>
+              <a:t>, and spot when it </a:t>
             </a:r>
             <a:r>
               <a:rPr sz="1400" b="1">
@@ -35324,25 +35324,7 @@
                 </a:solidFill>
                 <a:latin typeface="Arial"/>
               </a:rPr>
-              <a:t>Mahalanobis</a:t>
-            </a:r>
-            <a:r>
-              <a:rPr sz="1400" b="0">
-                <a:solidFill>
-                  <a:srgbClr val="333333"/>
-                </a:solidFill>
-                <a:latin typeface="Arial"/>
-              </a:rPr>
-              <a:t> (distance from normal), </a:t>
-            </a:r>
-            <a:r>
-              <a:rPr sz="1400" b="1">
-                <a:solidFill>
-                  <a:srgbClr val="000000"/>
-                </a:solidFill>
-                <a:latin typeface="Arial"/>
-              </a:rPr>
-              <a:t>PINN</a:t>
+              <a:t>drifts from its usual behavior</a:t>
             </a:r>
             <a:r>
               <a:rPr sz="1400" b="0">
@@ -35532,25 +35514,7 @@
                 </a:solidFill>
                 <a:latin typeface="Arial"/>
               </a:rPr>
-              <a:t>. If the models disagree, </a:t>
-            </a:r>
-            <a:r>
-              <a:rPr sz="1400" b="1">
-                <a:solidFill>
-                  <a:srgbClr val="000000"/>
-                </a:solidFill>
-                <a:latin typeface="Arial"/>
-              </a:rPr>
-              <a:t>Yager's rule</a:t>
-            </a:r>
-            <a:r>
-              <a:rPr sz="1400" b="0">
-                <a:solidFill>
-                  <a:srgbClr val="333333"/>
-                </a:solidFill>
-                <a:latin typeface="Arial"/>
-              </a:rPr>
-              <a:t> keeps the answer cautious.</a:t>
+              <a:t>. If the models strongly disagree, it answers Unknown instead of guessing.</a:t>
             </a:r>
           </a:p>
         </p:txBody>

</xml_diff>

<commit_message>
docs(presentation): plain-language wording for Docker and AKS concept slides
Co-Authored-By: Claude Opus 5.5 <noreply@anthropic.com>
Claude-Session: https://claude.ai/code/session_01F96Sh6kL5Mvj9m6qX6kkqv
</commit_message>
<xml_diff>
--- a/presentation/technical_defense_final_v2.pptx
+++ b/presentation/technical_defense_final_v2.pptx
@@ -31769,7 +31769,7 @@
                 </a:solidFill>
                 <a:latin typeface="Arial"/>
               </a:rPr>
-              <a:t>Runs containers (in </a:t>
+              <a:t>Runs our containers across </a:t>
             </a:r>
             <a:r>
               <a:rPr sz="1300" b="1">
@@ -31778,7 +31778,7 @@
                 </a:solidFill>
                 <a:latin typeface="Arial"/>
               </a:rPr>
-              <a:t>pods</a:t>
+              <a:t>several machines</a:t>
             </a:r>
             <a:r>
               <a:rPr sz="1300" b="0">
@@ -31787,7 +31787,7 @@
                 </a:solidFill>
                 <a:latin typeface="Arial"/>
               </a:rPr>
-              <a:t>) across a cluster of VMs, </a:t>
+              <a:t>. A crashed service is </a:t>
             </a:r>
             <a:r>
               <a:rPr sz="1300" b="1">
@@ -31796,7 +31796,7 @@
                 </a:solidFill>
                 <a:latin typeface="Arial"/>
               </a:rPr>
-              <a:t>restarts</a:t>
+              <a:t>restarted automatically</a:t>
             </a:r>
             <a:r>
               <a:rPr sz="1300" b="0">
@@ -31805,7 +31805,7 @@
                 </a:solidFill>
                 <a:latin typeface="Arial"/>
               </a:rPr>
-              <a:t> any that fail and </a:t>
+              <a:t>, and capacity </a:t>
             </a:r>
             <a:r>
               <a:rPr sz="1300" b="1">
@@ -31814,7 +31814,7 @@
                 </a:solidFill>
                 <a:latin typeface="Arial"/>
               </a:rPr>
-              <a:t>scales</a:t>
+              <a:t>grows with traffic</a:t>
             </a:r>
             <a:r>
               <a:rPr sz="1300" b="0">
@@ -31823,7 +31823,7 @@
                 </a:solidFill>
                 <a:latin typeface="Arial"/>
               </a:rPr>
-              <a:t> with load. AKS is Azure's managed Kubernetes.</a:t>
+              <a:t>.</a:t>
             </a:r>
           </a:p>
         </p:txBody>
@@ -31953,13 +31953,22 @@
           <a:p>
             <a:pPr algn="l"/>
             <a:r>
+              <a:rPr sz="1300" b="0">
+                <a:solidFill>
+                  <a:srgbClr val="333333"/>
+                </a:solidFill>
+                <a:latin typeface="Arial"/>
+              </a:rPr>
+              <a:t>Two groups of machines: one for </a:t>
+            </a:r>
+            <a:r>
               <a:rPr sz="1300" b="1">
                 <a:solidFill>
                   <a:srgbClr val="000000"/>
                 </a:solidFill>
                 <a:latin typeface="Arial"/>
               </a:rPr>
-              <a:t>System pool</a:t>
+              <a:t>Kubernetes itself</a:t>
             </a:r>
             <a:r>
               <a:rPr sz="1300" b="0">
@@ -31968,7 +31977,7 @@
                 </a:solidFill>
                 <a:latin typeface="Arial"/>
               </a:rPr>
-              <a:t>: Kubernetes' own components only. </a:t>
+              <a:t>, one for </a:t>
             </a:r>
             <a:r>
               <a:rPr sz="1300" b="1">
@@ -31977,7 +31986,7 @@
                 </a:solidFill>
                 <a:latin typeface="Arial"/>
               </a:rPr>
-              <a:t>User pool</a:t>
+              <a:t>our app</a:t>
             </a:r>
             <a:r>
               <a:rPr sz="1300" b="0">
@@ -31986,7 +31995,7 @@
                 </a:solidFill>
                 <a:latin typeface="Arial"/>
               </a:rPr>
-              <a:t>: our application, </a:t>
+              <a:t>, which grows from </a:t>
             </a:r>
             <a:r>
               <a:rPr sz="1300" b="1">
@@ -31995,7 +32004,7 @@
                 </a:solidFill>
                 <a:latin typeface="Arial"/>
               </a:rPr>
-              <a:t>autoscaling 2 to 4 VMs</a:t>
+              <a:t>2 to 4 machines</a:t>
             </a:r>
             <a:r>
               <a:rPr sz="1300" b="0">
@@ -32105,7 +32114,7 @@
                 </a:solidFill>
                 <a:latin typeface="Arial"/>
               </a:rPr>
-              <a:t>Namespaces</a:t>
+              <a:t>Staging &amp; production</a:t>
             </a:r>
           </a:p>
         </p:txBody>
@@ -32140,7 +32149,7 @@
                 </a:solidFill>
                 <a:latin typeface="Arial"/>
               </a:rPr>
-              <a:t>Logical partitions of the cluster: </a:t>
+              <a:t>Two identical copies of the app: </a:t>
             </a:r>
             <a:r>
               <a:rPr sz="1300" b="1">
@@ -32149,7 +32158,7 @@
                 </a:solidFill>
                 <a:latin typeface="Arial"/>
               </a:rPr>
-              <a:t>eam-staging</a:t>
+              <a:t>staging</a:t>
             </a:r>
             <a:r>
               <a:rPr sz="1300" b="0">
@@ -32167,7 +32176,7 @@
                 </a:solidFill>
                 <a:latin typeface="Arial"/>
               </a:rPr>
-              <a:t>eam-prod</a:t>
+              <a:t>production</a:t>
             </a:r>
             <a:r>
               <a:rPr sz="1300" b="0">
@@ -32176,7 +32185,7 @@
                 </a:solidFill>
                 <a:latin typeface="Arial"/>
               </a:rPr>
-              <a:t> for real users, with the same layout.</a:t>
+              <a:t> for real users.</a:t>
             </a:r>
           </a:p>
         </p:txBody>
@@ -32312,7 +32321,7 @@
                 </a:solidFill>
                 <a:latin typeface="Arial"/>
               </a:rPr>
-              <a:t>Private </a:t>
+              <a:t>Everything sits on a </a:t>
             </a:r>
             <a:r>
               <a:rPr sz="1300" b="1">
@@ -32321,7 +32330,7 @@
                 </a:solidFill>
                 <a:latin typeface="Arial"/>
               </a:rPr>
-              <a:t>VNet</a:t>
+              <a:t>private network</a:t>
             </a:r>
             <a:r>
               <a:rPr sz="1300" b="0">
@@ -32339,7 +32348,7 @@
                 </a:solidFill>
                 <a:latin typeface="Arial"/>
               </a:rPr>
-              <a:t>Network policies</a:t>
+              <a:t>Firewall rules</a:t>
             </a:r>
             <a:r>
               <a:rPr sz="1300" b="0">
@@ -32348,7 +32357,7 @@
                 </a:solidFill>
                 <a:latin typeface="Arial"/>
               </a:rPr>
-              <a:t> act as firewall rules between pods; </a:t>
+              <a:t> limit who talks to whom, and </a:t>
             </a:r>
             <a:r>
               <a:rPr sz="1300" b="1">
@@ -32357,7 +32366,7 @@
                 </a:solidFill>
                 <a:latin typeface="Arial"/>
               </a:rPr>
-              <a:t>workload identity</a:t>
+              <a:t>no passwords</a:t>
             </a:r>
             <a:r>
               <a:rPr sz="1300" b="0">
@@ -32366,7 +32375,7 @@
                 </a:solidFill>
                 <a:latin typeface="Arial"/>
               </a:rPr>
-              <a:t> lets pods reach Azure without stored credentials.</a:t>
+              <a:t> are stored to reach Azure.</a:t>
             </a:r>
           </a:p>
         </p:txBody>
@@ -32467,7 +32476,7 @@
                 </a:solidFill>
                 <a:latin typeface="Arial"/>
               </a:rPr>
-              <a:t>Managed services</a:t>
+              <a:t>Managed by Azure</a:t>
             </a:r>
           </a:p>
         </p:txBody>
@@ -32496,13 +32505,22 @@
           <a:p>
             <a:pPr algn="l"/>
             <a:r>
+              <a:rPr sz="1300" b="0">
+                <a:solidFill>
+                  <a:srgbClr val="333333"/>
+                </a:solidFill>
+                <a:latin typeface="Arial"/>
+              </a:rPr>
+              <a:t>Azure runs the </a:t>
+            </a:r>
+            <a:r>
               <a:rPr sz="1300" b="1">
                 <a:solidFill>
                   <a:srgbClr val="000000"/>
                 </a:solidFill>
                 <a:latin typeface="Arial"/>
               </a:rPr>
-              <a:t>PostgreSQL Flexible Server</a:t>
+              <a:t>database</a:t>
             </a:r>
             <a:r>
               <a:rPr sz="1300" b="0">
@@ -32511,7 +32529,7 @@
                 </a:solidFill>
                 <a:latin typeface="Arial"/>
               </a:rPr>
-              <a:t>: Azure runs backups and patching. </a:t>
+              <a:t> for us (backups, updates) and stores our </a:t>
             </a:r>
             <a:r>
               <a:rPr sz="1300" b="1">
@@ -32520,7 +32538,7 @@
                 </a:solidFill>
                 <a:latin typeface="Arial"/>
               </a:rPr>
-              <a:t>ACR</a:t>
+              <a:t>container images</a:t>
             </a:r>
             <a:r>
               <a:rPr sz="1300" b="0">
@@ -32529,7 +32547,7 @@
                 </a:solidFill>
                 <a:latin typeface="Arial"/>
               </a:rPr>
-              <a:t> stores the images. MinIO keeps files on a </a:t>
+              <a:t>. Files are kept on a </a:t>
             </a:r>
             <a:r>
               <a:rPr sz="1300" b="1">
@@ -32538,7 +32556,7 @@
                 </a:solidFill>
                 <a:latin typeface="Arial"/>
               </a:rPr>
-              <a:t>persistent volume</a:t>
+              <a:t>permanent disk</a:t>
             </a:r>
             <a:r>
               <a:rPr sz="1300" b="0">
@@ -32683,7 +32701,7 @@
                 </a:solidFill>
                 <a:latin typeface="Arial"/>
               </a:rPr>
-              <a:t>Holds every secret: JWT, Groq, SMTP, DB password. The </a:t>
+              <a:t>A </a:t>
             </a:r>
             <a:r>
               <a:rPr sz="1300" b="1">
@@ -32692,7 +32710,7 @@
                 </a:solidFill>
                 <a:latin typeface="Arial"/>
               </a:rPr>
-              <a:t>CSI driver</a:t>
+              <a:t>safe for secrets</a:t>
             </a:r>
             <a:r>
               <a:rPr sz="1300" b="0">
@@ -32701,7 +32719,25 @@
                 </a:solidFill>
                 <a:latin typeface="Arial"/>
               </a:rPr>
-              <a:t> injects them into pods at runtime, never in code or images.</a:t>
+              <a:t> (passwords, API keys). They are handed to the app </a:t>
+            </a:r>
+            <a:r>
+              <a:rPr sz="1300" b="1">
+                <a:solidFill>
+                  <a:srgbClr val="000000"/>
+                </a:solidFill>
+                <a:latin typeface="Arial"/>
+              </a:rPr>
+              <a:t>when it starts</a:t>
+            </a:r>
+            <a:r>
+              <a:rPr sz="1300" b="0">
+                <a:solidFill>
+                  <a:srgbClr val="333333"/>
+                </a:solidFill>
+                <a:latin typeface="Arial"/>
+              </a:rPr>
+              <a:t>, never written in the code.</a:t>
             </a:r>
           </a:p>
         </p:txBody>
@@ -32837,7 +32873,7 @@
                 </a:solidFill>
                 <a:latin typeface="Arial"/>
               </a:rPr>
-              <a:t>Azure's inbound load balancer is </a:t>
+              <a:t>Azure's usual public entrance is </a:t>
             </a:r>
             <a:r>
               <a:rPr sz="1300" b="1">
@@ -32846,7 +32882,7 @@
                 </a:solidFill>
                 <a:latin typeface="Arial"/>
               </a:rPr>
-              <a:t>blocked at subscription level</a:t>
+              <a:t>blocked on our account</a:t>
             </a:r>
             <a:r>
               <a:rPr sz="1300" b="0">
@@ -32855,7 +32891,7 @@
                 </a:solidFill>
                 <a:latin typeface="Arial"/>
               </a:rPr>
-              <a:t>, so the ngrok pod </a:t>
+              <a:t>, so a small service </a:t>
             </a:r>
             <a:r>
               <a:rPr sz="1300" b="1">
@@ -32864,7 +32900,7 @@
                 </a:solidFill>
                 <a:latin typeface="Arial"/>
               </a:rPr>
-              <a:t>dials out</a:t>
+              <a:t>connects out</a:t>
             </a:r>
             <a:r>
               <a:rPr sz="1300" b="0">
@@ -32873,7 +32909,7 @@
                 </a:solidFill>
                 <a:latin typeface="Arial"/>
               </a:rPr>
-              <a:t> and relays public HTTPS to the frontend.</a:t>
+              <a:t> to ngrok, which forwards visitors in.</a:t>
             </a:r>
           </a:p>
         </p:txBody>
@@ -32974,7 +33010,7 @@
                 </a:solidFill>
                 <a:latin typeface="Arial"/>
               </a:rPr>
-              <a:t>CI/CD &amp; IaC</a:t>
+              <a:t>Automated delivery</a:t>
             </a:r>
           </a:p>
         </p:txBody>
@@ -33003,13 +33039,22 @@
           <a:p>
             <a:pPr algn="l"/>
             <a:r>
+              <a:rPr sz="1300" b="0">
+                <a:solidFill>
+                  <a:srgbClr val="333333"/>
+                </a:solidFill>
+                <a:latin typeface="Arial"/>
+              </a:rPr>
+              <a:t>Every change is </a:t>
+            </a:r>
+            <a:r>
               <a:rPr sz="1300" b="1">
                 <a:solidFill>
                   <a:srgbClr val="000000"/>
                 </a:solidFill>
                 <a:latin typeface="Arial"/>
               </a:rPr>
-              <a:t>GitLab CI</a:t>
+              <a:t>checked for security</a:t>
             </a:r>
             <a:r>
               <a:rPr sz="1300" b="0">
@@ -33018,7 +33063,7 @@
                 </a:solidFill>
                 <a:latin typeface="Arial"/>
               </a:rPr>
-              <a:t> checks every push; </a:t>
+              <a:t>, then </a:t>
             </a:r>
             <a:r>
               <a:rPr sz="1300" b="1">
@@ -33027,7 +33072,7 @@
                 </a:solidFill>
                 <a:latin typeface="Arial"/>
               </a:rPr>
-              <a:t>deploy-aks</a:t>
+              <a:t>built and deployed</a:t>
             </a:r>
             <a:r>
               <a:rPr sz="1300" b="0">
@@ -33036,7 +33081,7 @@
                 </a:solidFill>
                 <a:latin typeface="Arial"/>
               </a:rPr>
-              <a:t> builds, pushes to ACR and restarts. </a:t>
+              <a:t> automatically. The cloud setup is </a:t>
             </a:r>
             <a:r>
               <a:rPr sz="1300" b="1">
@@ -33045,7 +33090,7 @@
                 </a:solidFill>
                 <a:latin typeface="Arial"/>
               </a:rPr>
-              <a:t>Terraform</a:t>
+              <a:t>written as code</a:t>
             </a:r>
             <a:r>
               <a:rPr sz="1300" b="0">
@@ -33054,25 +33099,7 @@
                 </a:solidFill>
                 <a:latin typeface="Arial"/>
               </a:rPr>
-              <a:t> defines Azure, </a:t>
-            </a:r>
-            <a:r>
-              <a:rPr sz="1300" b="1">
-                <a:solidFill>
-                  <a:srgbClr val="000000"/>
-                </a:solidFill>
-                <a:latin typeface="Arial"/>
-              </a:rPr>
-              <a:t>Helm</a:t>
-            </a:r>
-            <a:r>
-              <a:rPr sz="1300" b="0">
-                <a:solidFill>
-                  <a:srgbClr val="333333"/>
-                </a:solidFill>
-                <a:latin typeface="Arial"/>
-              </a:rPr>
-              <a:t> the deployment.</a:t>
+              <a:t>, so it can be rebuilt anytime.</a:t>
             </a:r>
           </a:p>
         </p:txBody>
@@ -33116,7 +33143,7 @@
                 </a:solidFill>
                 <a:latin typeface="Arial"/>
               </a:rPr>
-              <a:t> self-healing, autoscaling, managed database, centralized secrets, reproducible infrastructure.</a:t>
+              <a:t> it repairs itself, grows with demand, keeps secrets in a vault, and can be rebuilt at any time.</a:t>
             </a:r>
           </a:p>
         </p:txBody>
@@ -33376,7 +33403,7 @@
                 </a:solidFill>
                 <a:latin typeface="Arial"/>
               </a:rPr>
-              <a:t>Container &amp; Compose</a:t>
+              <a:t>Containers</a:t>
             </a:r>
           </a:p>
         </p:txBody>
@@ -33411,7 +33438,7 @@
                 </a:solidFill>
                 <a:latin typeface="Arial"/>
               </a:rPr>
-              <a:t>A </a:t>
+              <a:t>Each part of the app runs in its own </a:t>
             </a:r>
             <a:r>
               <a:rPr sz="1400" b="1">
@@ -33429,7 +33456,7 @@
                 </a:solidFill>
                 <a:latin typeface="Arial"/>
               </a:rPr>
-              <a:t> packages an app with all its dependencies and runs it in isolation; each box on the diagram is one. </a:t>
+              <a:t>: a sealed box holding the code and everything it needs. </a:t>
             </a:r>
             <a:r>
               <a:rPr sz="1400" b="1">
@@ -33447,7 +33474,7 @@
                 </a:solidFill>
                 <a:latin typeface="Arial"/>
               </a:rPr>
-              <a:t> describes every container in one file and starts them together.</a:t>
+              <a:t> starts all the boxes with one command.</a:t>
             </a:r>
           </a:p>
         </p:txBody>
@@ -33548,7 +33575,7 @@
                 </a:solidFill>
                 <a:latin typeface="Arial"/>
               </a:rPr>
-              <a:t>Caddy: reverse proxy</a:t>
+              <a:t>Caddy: the front door</a:t>
             </a:r>
           </a:p>
         </p:txBody>
@@ -33592,7 +33619,7 @@
                 </a:solidFill>
                 <a:latin typeface="Arial"/>
               </a:rPr>
-              <a:t>single entry point</a:t>
+              <a:t>only door</a:t>
             </a:r>
             <a:r>
               <a:rPr sz="1400" b="0">
@@ -33601,7 +33628,7 @@
                 </a:solidFill>
                 <a:latin typeface="Arial"/>
               </a:rPr>
-              <a:t> from the internet. It handles </a:t>
+              <a:t> from the internet. It adds the </a:t>
             </a:r>
             <a:r>
               <a:rPr sz="1400" b="1">
@@ -33610,7 +33637,7 @@
                 </a:solidFill>
                 <a:latin typeface="Arial"/>
               </a:rPr>
-              <a:t>HTTPS</a:t>
+              <a:t>HTTPS padlock</a:t>
             </a:r>
             <a:r>
               <a:rPr sz="1400" b="0">
@@ -33619,61 +33646,7 @@
                 </a:solidFill>
                 <a:latin typeface="Arial"/>
               </a:rPr>
-              <a:t> automatically (Let's Encrypt) and routes by path: </a:t>
-            </a:r>
-            <a:r>
-              <a:rPr sz="1400" b="1">
-                <a:solidFill>
-                  <a:srgbClr val="000000"/>
-                </a:solidFill>
-                <a:latin typeface="Arial"/>
-              </a:rPr>
-              <a:t>/</a:t>
-            </a:r>
-            <a:r>
-              <a:rPr sz="1400" b="0">
-                <a:solidFill>
-                  <a:srgbClr val="333333"/>
-                </a:solidFill>
-                <a:latin typeface="Arial"/>
-              </a:rPr>
-              <a:t> to the frontend, </a:t>
-            </a:r>
-            <a:r>
-              <a:rPr sz="1400" b="1">
-                <a:solidFill>
-                  <a:srgbClr val="000000"/>
-                </a:solidFill>
-                <a:latin typeface="Arial"/>
-              </a:rPr>
-              <a:t>/api</a:t>
-            </a:r>
-            <a:r>
-              <a:rPr sz="1400" b="0">
-                <a:solidFill>
-                  <a:srgbClr val="333333"/>
-                </a:solidFill>
-                <a:latin typeface="Arial"/>
-              </a:rPr>
-              <a:t> to the backend, </a:t>
-            </a:r>
-            <a:r>
-              <a:rPr sz="1400" b="1">
-                <a:solidFill>
-                  <a:srgbClr val="000000"/>
-                </a:solidFill>
-                <a:latin typeface="Arial"/>
-              </a:rPr>
-              <a:t>/grafana</a:t>
-            </a:r>
-            <a:r>
-              <a:rPr sz="1400" b="0">
-                <a:solidFill>
-                  <a:srgbClr val="333333"/>
-                </a:solidFill>
-                <a:latin typeface="Arial"/>
-              </a:rPr>
-              <a:t> to the dashboards.</a:t>
+              <a:t> and sends each request to the right place: pages, data or dashboards.</a:t>
             </a:r>
           </a:p>
         </p:txBody>
@@ -33774,7 +33747,7 @@
                 </a:solidFill>
                 <a:latin typeface="Arial"/>
               </a:rPr>
-              <a:t>Bridge network</a:t>
+              <a:t>Private network</a:t>
             </a:r>
           </a:p>
         </p:txBody>
@@ -33803,13 +33776,22 @@
           <a:p>
             <a:pPr algn="l"/>
             <a:r>
+              <a:rPr sz="1400" b="0">
+                <a:solidFill>
+                  <a:srgbClr val="333333"/>
+                </a:solidFill>
+                <a:latin typeface="Arial"/>
+              </a:rPr>
+              <a:t>The containers share a </a:t>
+            </a:r>
+            <a:r>
               <a:rPr sz="1400" b="1">
                 <a:solidFill>
                   <a:srgbClr val="000000"/>
                 </a:solidFill>
                 <a:latin typeface="Arial"/>
               </a:rPr>
-              <a:t>asset_management_network</a:t>
+              <a:t>private network</a:t>
             </a:r>
             <a:r>
               <a:rPr sz="1400" b="0">
@@ -33818,7 +33800,7 @@
                 </a:solidFill>
                 <a:latin typeface="Arial"/>
               </a:rPr>
-              <a:t> is a private network shared by the app containers. They reach each other </a:t>
+              <a:t> and find each other </a:t>
             </a:r>
             <a:r>
               <a:rPr sz="1400" b="1">
@@ -33827,7 +33809,7 @@
                 </a:solidFill>
                 <a:latin typeface="Arial"/>
               </a:rPr>
-              <a:t>by service name</a:t>
+              <a:t>by name</a:t>
             </a:r>
             <a:r>
               <a:rPr sz="1400" b="0">
@@ -33836,7 +33818,7 @@
                 </a:solidFill>
                 <a:latin typeface="Arial"/>
               </a:rPr>
-              <a:t>, never by a hard-coded IP address.</a:t>
+              <a:t> (the backend simply calls "ml-service"), so nothing depends on fixed addresses.</a:t>
             </a:r>
           </a:p>
         </p:txBody>
@@ -33972,7 +33954,7 @@
                 </a:solidFill>
                 <a:latin typeface="Arial"/>
               </a:rPr>
-              <a:t>Each service listens on a </a:t>
+              <a:t>In development, each service is reachable on its own </a:t>
             </a:r>
             <a:r>
               <a:rPr sz="1400" b="1">
@@ -33990,7 +33972,7 @@
                 </a:solidFill>
                 <a:latin typeface="Arial"/>
               </a:rPr>
-              <a:t>; in dev some are opened on the host (e.g. :3000) for debugging. A </a:t>
+              <a:t> for easy debugging. Database data is </a:t>
             </a:r>
             <a:r>
               <a:rPr sz="1400" b="1">
@@ -33999,7 +33981,7 @@
                 </a:solidFill>
                 <a:latin typeface="Arial"/>
               </a:rPr>
-              <a:t>volume</a:t>
+              <a:t>saved on disk</a:t>
             </a:r>
             <a:r>
               <a:rPr sz="1400" b="0">
@@ -34008,7 +33990,7 @@
                 </a:solidFill>
                 <a:latin typeface="Arial"/>
               </a:rPr>
-              <a:t> keeps PostgreSQL data across restarts; models are a </a:t>
+              <a:t> and survives restarts; the AI models are </a:t>
             </a:r>
             <a:r>
               <a:rPr sz="1400" b="1">
@@ -34017,7 +33999,7 @@
                 </a:solidFill>
                 <a:latin typeface="Arial"/>
               </a:rPr>
-              <a:t>read-only bind mount</a:t>
+              <a:t>locked against changes</a:t>
             </a:r>
             <a:r>
               <a:rPr sz="1400" b="0">
@@ -34127,7 +34109,7 @@
                 </a:solidFill>
                 <a:latin typeface="Arial"/>
               </a:rPr>
-              <a:t>Monitoring stack</a:t>
+              <a:t>Monitoring</a:t>
             </a:r>
           </a:p>
         </p:txBody>
@@ -34162,7 +34144,7 @@
                 </a:solidFill>
                 <a:latin typeface="Arial"/>
               </a:rPr>
-              <a:t>On its own network. </a:t>
+              <a:t>A separate set of tools </a:t>
             </a:r>
             <a:r>
               <a:rPr sz="1400" b="1">
@@ -34171,7 +34153,7 @@
                 </a:solidFill>
                 <a:latin typeface="Arial"/>
               </a:rPr>
-              <a:t>Prometheus</a:t>
+              <a:t>watches the app</a:t>
             </a:r>
             <a:r>
               <a:rPr sz="1400" b="0">
@@ -34180,7 +34162,7 @@
                 </a:solidFill>
                 <a:latin typeface="Arial"/>
               </a:rPr>
-              <a:t> collects metrics, </a:t>
+              <a:t>: it collects performance numbers, shows them on </a:t>
             </a:r>
             <a:r>
               <a:rPr sz="1400" b="1">
@@ -34189,7 +34171,7 @@
                 </a:solidFill>
                 <a:latin typeface="Arial"/>
               </a:rPr>
-              <a:t>Pushgateway</a:t>
+              <a:t>dashboards</a:t>
             </a:r>
             <a:r>
               <a:rPr sz="1400" b="0">
@@ -34198,7 +34180,7 @@
                 </a:solidFill>
                 <a:latin typeface="Arial"/>
               </a:rPr>
-              <a:t> receives them from short jobs, </a:t>
+              <a:t>, and </a:t>
             </a:r>
             <a:r>
               <a:rPr sz="1400" b="1">
@@ -34207,7 +34189,7 @@
                 </a:solidFill>
                 <a:latin typeface="Arial"/>
               </a:rPr>
-              <a:t>Grafana</a:t>
+              <a:t>scans the containers</a:t>
             </a:r>
             <a:r>
               <a:rPr sz="1400" b="0">
@@ -34216,25 +34198,7 @@
                 </a:solidFill>
                 <a:latin typeface="Arial"/>
               </a:rPr>
-              <a:t> shows dashboards, </a:t>
-            </a:r>
-            <a:r>
-              <a:rPr sz="1400" b="1">
-                <a:solidFill>
-                  <a:srgbClr val="000000"/>
-                </a:solidFill>
-                <a:latin typeface="Arial"/>
-              </a:rPr>
-              <a:t>Trivy</a:t>
-            </a:r>
-            <a:r>
-              <a:rPr sz="1400" b="0">
-                <a:solidFill>
-                  <a:srgbClr val="333333"/>
-                </a:solidFill>
-                <a:latin typeface="Arial"/>
-              </a:rPr>
-              <a:t> scans images for known vulnerabilities.</a:t>
+              <a:t> for known security flaws.</a:t>
             </a:r>
           </a:p>
         </p:txBody>
@@ -34335,7 +34299,7 @@
                 </a:solidFill>
                 <a:latin typeface="Arial"/>
               </a:rPr>
-              <a:t>On-demand stacks</a:t>
+              <a:t>Tools on demand</a:t>
             </a:r>
           </a:p>
         </p:txBody>
@@ -34370,7 +34334,7 @@
                 </a:solidFill>
                 <a:latin typeface="Arial"/>
               </a:rPr>
-              <a:t>Started only when needed, each from its own Compose file: </a:t>
+              <a:t>Some tools run </a:t>
             </a:r>
             <a:r>
               <a:rPr sz="1400" b="1">
@@ -34379,7 +34343,7 @@
                 </a:solidFill>
                 <a:latin typeface="Arial"/>
               </a:rPr>
-              <a:t>SonarQube</a:t>
+              <a:t>only when needed</a:t>
             </a:r>
             <a:r>
               <a:rPr sz="1400" b="0">
@@ -34388,7 +34352,7 @@
                 </a:solidFill>
                 <a:latin typeface="Arial"/>
               </a:rPr>
-              <a:t> for code-quality analysis and </a:t>
+              <a:t>: a </a:t>
             </a:r>
             <a:r>
               <a:rPr sz="1400" b="1">
@@ -34397,7 +34361,7 @@
                 </a:solidFill>
                 <a:latin typeface="Arial"/>
               </a:rPr>
-              <a:t>Jupyter</a:t>
+              <a:t>code-quality checker</a:t>
             </a:r>
             <a:r>
               <a:rPr sz="1400" b="0">
@@ -34406,7 +34370,25 @@
                 </a:solidFill>
                 <a:latin typeface="Arial"/>
               </a:rPr>
-              <a:t> for the offline ML research notebooks.</a:t>
+              <a:t> (SonarQube) and the </a:t>
+            </a:r>
+            <a:r>
+              <a:rPr sz="1400" b="1">
+                <a:solidFill>
+                  <a:srgbClr val="000000"/>
+                </a:solidFill>
+                <a:latin typeface="Arial"/>
+              </a:rPr>
+              <a:t>notebooks</a:t>
+            </a:r>
+            <a:r>
+              <a:rPr sz="1400" b="0">
+                <a:solidFill>
+                  <a:srgbClr val="333333"/>
+                </a:solidFill>
+                <a:latin typeface="Arial"/>
+              </a:rPr>
+              <a:t> where the AI models were researched (Jupyter).</a:t>
             </a:r>
           </a:p>
         </p:txBody>
@@ -34450,7 +34432,7 @@
                 </a:solidFill>
                 <a:latin typeface="Arial"/>
               </a:rPr>
-              <a:t> dev exposes every port; the prod overlay leaves only Caddy (80/443) open and pulls prebuilt images.</a:t>
+              <a:t> in development every service is reachable; in the demo only Caddy is, so there is one secure way in.</a:t>
             </a:r>
           </a:p>
         </p:txBody>

</xml_diff>

<commit_message>
docs(presentation): plain-language wording for logical architecture slide
Co-Authored-By: Claude Opus 5.5 <noreply@anthropic.com>
Claude-Session: https://claude.ai/code/session_01F96Sh6kL5Mvj9m6qX6kkqv
</commit_message>
<xml_diff>
--- a/presentation/technical_defense_final_v2.pptx
+++ b/presentation/technical_defense_final_v2.pptx
@@ -35963,49 +35963,67 @@
           <a:p>
             <a:pPr algn="l"/>
             <a:r>
-              <a:rPr sz="1200" b="0">
+              <a:rPr sz="1300" b="0">
                 <a:solidFill>
                   <a:srgbClr val="333333"/>
                 </a:solidFill>
                 <a:latin typeface="Arial"/>
               </a:rPr>
-              <a:t>Four roles reach the platform over </a:t>
-            </a:r>
-            <a:r>
-              <a:rPr sz="1200" b="1">
+              <a:t>Four kinds of users open the app in their </a:t>
+            </a:r>
+            <a:r>
+              <a:rPr sz="1300" b="1">
                 <a:solidFill>
                   <a:srgbClr val="000000"/>
                 </a:solidFill>
                 <a:latin typeface="Arial"/>
               </a:rPr>
-              <a:t>HTTPS</a:t>
-            </a:r>
-            <a:r>
-              <a:rPr sz="1200" b="0">
+              <a:t>web browser</a:t>
+            </a:r>
+            <a:r>
+              <a:rPr sz="1300" b="0">
                 <a:solidFill>
                   <a:srgbClr val="333333"/>
                 </a:solidFill>
                 <a:latin typeface="Arial"/>
               </a:rPr>
-              <a:t>. The frontend is a </a:t>
-            </a:r>
-            <a:r>
-              <a:rPr sz="1200" b="1">
+              <a:t>. The app loads </a:t>
+            </a:r>
+            <a:r>
+              <a:rPr sz="1300" b="1">
                 <a:solidFill>
                   <a:srgbClr val="000000"/>
                 </a:solidFill>
                 <a:latin typeface="Arial"/>
               </a:rPr>
-              <a:t>React + TypeScript single-page app (SPA)</a:t>
-            </a:r>
-            <a:r>
-              <a:rPr sz="1200" b="0">
+              <a:t>once</a:t>
+            </a:r>
+            <a:r>
+              <a:rPr sz="1300" b="0">
                 <a:solidFill>
                   <a:srgbClr val="333333"/>
                 </a:solidFill>
                 <a:latin typeface="Arial"/>
               </a:rPr>
-              <a:t>: loaded once, it then only exchanges data with the server, with no full page reloads. Each role gets its own space, plus the ML panel and AI assistant.</a:t>
+              <a:t>, then only fetches data, so screens switch instantly. Each role sees </a:t>
+            </a:r>
+            <a:r>
+              <a:rPr sz="1300" b="1">
+                <a:solidFill>
+                  <a:srgbClr val="000000"/>
+                </a:solidFill>
+                <a:latin typeface="Arial"/>
+              </a:rPr>
+              <a:t>its own space</a:t>
+            </a:r>
+            <a:r>
+              <a:rPr sz="1300" b="0">
+                <a:solidFill>
+                  <a:srgbClr val="333333"/>
+                </a:solidFill>
+                <a:latin typeface="Arial"/>
+              </a:rPr>
+              <a:t>, plus the machine-health panel and the AI assistant.</a:t>
             </a:r>
           </a:p>
         </p:txBody>
@@ -36115,76 +36133,67 @@
           <a:p>
             <a:pPr algn="l"/>
             <a:r>
-              <a:rPr sz="1200" b="1">
+              <a:rPr sz="1300" b="0">
+                <a:solidFill>
+                  <a:srgbClr val="333333"/>
+                </a:solidFill>
+                <a:latin typeface="Arial"/>
+              </a:rPr>
+              <a:t>The </a:t>
+            </a:r>
+            <a:r>
+              <a:rPr sz="1300" b="1">
                 <a:solidFill>
                   <a:srgbClr val="000000"/>
                 </a:solidFill>
                 <a:latin typeface="Arial"/>
               </a:rPr>
-              <a:t>FastAPI</a:t>
-            </a:r>
-            <a:r>
-              <a:rPr sz="1200" b="0">
+              <a:t>backend</a:t>
+            </a:r>
+            <a:r>
+              <a:rPr sz="1300" b="0">
                 <a:solidFill>
                   <a:srgbClr val="333333"/>
                 </a:solidFill>
                 <a:latin typeface="Arial"/>
               </a:rPr>
-              <a:t> holds all the business logic. The frontend calls it with </a:t>
-            </a:r>
-            <a:r>
-              <a:rPr sz="1200" b="1">
+              <a:t> is the brain of the app: it holds all the business rules. Every request carries a </a:t>
+            </a:r>
+            <a:r>
+              <a:rPr sz="1300" b="1">
                 <a:solidFill>
                   <a:srgbClr val="000000"/>
                 </a:solidFill>
                 <a:latin typeface="Arial"/>
               </a:rPr>
-              <a:t>REST/JSON</a:t>
-            </a:r>
-            <a:r>
-              <a:rPr sz="1200" b="0">
+              <a:t>login token</a:t>
+            </a:r>
+            <a:r>
+              <a:rPr sz="1300" b="0">
                 <a:solidFill>
                   <a:srgbClr val="333333"/>
                 </a:solidFill>
                 <a:latin typeface="Arial"/>
               </a:rPr>
-              <a:t>, and every request carries a </a:t>
-            </a:r>
-            <a:r>
-              <a:rPr sz="1200" b="1">
+              <a:t> that proves who you are, and the backend checks </a:t>
+            </a:r>
+            <a:r>
+              <a:rPr sz="1300" b="1">
                 <a:solidFill>
                   <a:srgbClr val="000000"/>
                 </a:solidFill>
                 <a:latin typeface="Arial"/>
               </a:rPr>
-              <a:t>JWT</a:t>
-            </a:r>
-            <a:r>
-              <a:rPr sz="1200" b="0">
+              <a:t>what your role is allowed to do</a:t>
+            </a:r>
+            <a:r>
+              <a:rPr sz="1300" b="0">
                 <a:solidFill>
                   <a:srgbClr val="333333"/>
                 </a:solidFill>
                 <a:latin typeface="Arial"/>
               </a:rPr>
-              <a:t>, a signed login token proving who the user is. </a:t>
-            </a:r>
-            <a:r>
-              <a:rPr sz="1200" b="1">
-                <a:solidFill>
-                  <a:srgbClr val="000000"/>
-                </a:solidFill>
-                <a:latin typeface="Arial"/>
-              </a:rPr>
-              <a:t>RBAC</a:t>
-            </a:r>
-            <a:r>
-              <a:rPr sz="1200" b="0">
-                <a:solidFill>
-                  <a:srgbClr val="333333"/>
-                </a:solidFill>
-                <a:latin typeface="Arial"/>
-              </a:rPr>
-              <a:t> (role-based access control) decides what each role is allowed to do.</a:t>
+              <a:t>.</a:t>
             </a:r>
           </a:p>
         </p:txBody>
@@ -36294,76 +36303,67 @@
           <a:p>
             <a:pPr algn="l"/>
             <a:r>
-              <a:rPr sz="1200" b="1">
+              <a:rPr sz="1300" b="0">
+                <a:solidFill>
+                  <a:srgbClr val="333333"/>
+                </a:solidFill>
+                <a:latin typeface="Arial"/>
+              </a:rPr>
+              <a:t>Three helpers, called only by the backend: the </a:t>
+            </a:r>
+            <a:r>
+              <a:rPr sz="1300" b="1">
                 <a:solidFill>
                   <a:srgbClr val="000000"/>
                 </a:solidFill>
                 <a:latin typeface="Arial"/>
               </a:rPr>
-              <a:t>ML microservice</a:t>
-            </a:r>
-            <a:r>
-              <a:rPr sz="1200" b="0">
+              <a:t>ML service</a:t>
+            </a:r>
+            <a:r>
+              <a:rPr sz="1300" b="0">
                 <a:solidFill>
                   <a:srgbClr val="333333"/>
                 </a:solidFill>
                 <a:latin typeface="Arial"/>
               </a:rPr>
-              <a:t>: P1-P7 models and Wave 2 signals, merged into one verdict by </a:t>
-            </a:r>
-            <a:r>
-              <a:rPr sz="1200" b="1">
+              <a:t> predicts machine health, the </a:t>
+            </a:r>
+            <a:r>
+              <a:rPr sz="1300" b="1">
                 <a:solidFill>
                   <a:srgbClr val="000000"/>
                 </a:solidFill>
                 <a:latin typeface="Arial"/>
               </a:rPr>
-              <a:t>Dempster-Shafer fusion</a:t>
-            </a:r>
-            <a:r>
-              <a:rPr sz="1200" b="0">
+              <a:t>document search service</a:t>
+            </a:r>
+            <a:r>
+              <a:rPr sz="1300" b="0">
                 <a:solidFill>
                   <a:srgbClr val="333333"/>
                 </a:solidFill>
                 <a:latin typeface="Arial"/>
               </a:rPr>
-              <a:t>. </a:t>
-            </a:r>
-            <a:r>
-              <a:rPr sz="1200" b="1">
+              <a:t> finds the right passages in technical manuals for the AI assistant, and </a:t>
+            </a:r>
+            <a:r>
+              <a:rPr sz="1300" b="1">
                 <a:solidFill>
                   <a:srgbClr val="000000"/>
                 </a:solidFill>
                 <a:latin typeface="Arial"/>
               </a:rPr>
-              <a:t>RAG service</a:t>
-            </a:r>
-            <a:r>
-              <a:rPr sz="1200" b="0">
+              <a:t>background workers</a:t>
+            </a:r>
+            <a:r>
+              <a:rPr sz="1300" b="0">
                 <a:solidFill>
                   <a:srgbClr val="333333"/>
                 </a:solidFill>
                 <a:latin typeface="Arial"/>
               </a:rPr>
-              <a:t>: turns manuals into vectors (bge-m3), finds relevant passages with keyword + semantic search, then reranks them for the LLM. </a:t>
-            </a:r>
-            <a:r>
-              <a:rPr sz="1200" b="1">
-                <a:solidFill>
-                  <a:srgbClr val="000000"/>
-                </a:solidFill>
-                <a:latin typeface="Arial"/>
-              </a:rPr>
-              <a:t>Celery</a:t>
-            </a:r>
-            <a:r>
-              <a:rPr sz="1200" b="0">
-                <a:solidFill>
-                  <a:srgbClr val="333333"/>
-                </a:solidFill>
-                <a:latin typeface="Arial"/>
-              </a:rPr>
-              <a:t>: background jobs (worker) and scheduled jobs (beat).</a:t>
+              <a:t> handle slow or scheduled jobs like e-mails.</a:t>
             </a:r>
           </a:p>
         </p:txBody>
@@ -36473,76 +36473,85 @@
           <a:p>
             <a:pPr algn="l"/>
             <a:r>
-              <a:rPr sz="1200" b="1">
+              <a:rPr sz="1300" b="0">
+                <a:solidFill>
+                  <a:srgbClr val="333333"/>
+                </a:solidFill>
+                <a:latin typeface="Arial"/>
+              </a:rPr>
+              <a:t>One </a:t>
+            </a:r>
+            <a:r>
+              <a:rPr sz="1300" b="1">
                 <a:solidFill>
                   <a:srgbClr val="000000"/>
                 </a:solidFill>
                 <a:latin typeface="Arial"/>
               </a:rPr>
-              <a:t>PostgreSQL + pgvector</a:t>
-            </a:r>
-            <a:r>
-              <a:rPr sz="1200" b="0">
+              <a:t>database</a:t>
+            </a:r>
+            <a:r>
+              <a:rPr sz="1300" b="0">
                 <a:solidFill>
                   <a:srgbClr val="333333"/>
                 </a:solidFill>
                 <a:latin typeface="Arial"/>
               </a:rPr>
-              <a:t>: business data, ML logs and document vectors in one database. </a:t>
-            </a:r>
-            <a:r>
-              <a:rPr sz="1200" b="1">
+              <a:t> holds the business data, the prediction history and the searchable manuals. Files go to a separate </a:t>
+            </a:r>
+            <a:r>
+              <a:rPr sz="1300" b="1">
                 <a:solidFill>
                   <a:srgbClr val="000000"/>
                 </a:solidFill>
                 <a:latin typeface="Arial"/>
               </a:rPr>
-              <a:t>MinIO</a:t>
-            </a:r>
-            <a:r>
-              <a:rPr sz="1200" b="0">
+              <a:t>file store</a:t>
+            </a:r>
+            <a:r>
+              <a:rPr sz="1300" b="0">
                 <a:solidFill>
                   <a:srgbClr val="333333"/>
                 </a:solidFill>
                 <a:latin typeface="Arial"/>
               </a:rPr>
-              <a:t>: S3-compatible file storage. </a:t>
-            </a:r>
-            <a:r>
-              <a:rPr sz="1200" b="1">
+              <a:t>. A </a:t>
+            </a:r>
+            <a:r>
+              <a:rPr sz="1300" b="1">
                 <a:solidFill>
                   <a:srgbClr val="000000"/>
                 </a:solidFill>
                 <a:latin typeface="Arial"/>
               </a:rPr>
-              <a:t>RabbitMQ</a:t>
-            </a:r>
-            <a:r>
-              <a:rPr sz="1200" b="0">
+              <a:t>task queue</a:t>
+            </a:r>
+            <a:r>
+              <a:rPr sz="1300" b="0">
                 <a:solidFill>
                   <a:srgbClr val="333333"/>
                 </a:solidFill>
                 <a:latin typeface="Arial"/>
               </a:rPr>
-              <a:t>: message queue; the backend posts a task and Celery runs it asynchronously. </a:t>
-            </a:r>
-            <a:r>
-              <a:rPr sz="1200" b="1">
+              <a:t> hands jobs to the background workers, and the trained </a:t>
+            </a:r>
+            <a:r>
+              <a:rPr sz="1300" b="1">
                 <a:solidFill>
                   <a:srgbClr val="000000"/>
                 </a:solidFill>
                 <a:latin typeface="Arial"/>
               </a:rPr>
-              <a:t>.pkl files</a:t>
-            </a:r>
-            <a:r>
-              <a:rPr sz="1200" b="0">
+              <a:t>AI models</a:t>
+            </a:r>
+            <a:r>
+              <a:rPr sz="1300" b="0">
                 <a:solidFill>
                   <a:srgbClr val="333333"/>
                 </a:solidFill>
                 <a:latin typeface="Arial"/>
               </a:rPr>
-              <a:t>: trained models, read-only.</a:t>
+              <a:t> are files the app can read but never change.</a:t>
             </a:r>
           </a:p>
         </p:txBody>
@@ -36652,40 +36661,49 @@
           <a:p>
             <a:pPr algn="l"/>
             <a:r>
-              <a:rPr sz="1200" b="1">
+              <a:rPr sz="1300" b="0">
+                <a:solidFill>
+                  <a:srgbClr val="333333"/>
+                </a:solidFill>
+                <a:latin typeface="Arial"/>
+              </a:rPr>
+              <a:t>An outside </a:t>
+            </a:r>
+            <a:r>
+              <a:rPr sz="1300" b="1">
                 <a:solidFill>
                   <a:srgbClr val="000000"/>
                 </a:solidFill>
                 <a:latin typeface="Arial"/>
               </a:rPr>
-              <a:t>Groq LLM API</a:t>
-            </a:r>
-            <a:r>
-              <a:rPr sz="1200" b="0">
+              <a:t>AI language model</a:t>
+            </a:r>
+            <a:r>
+              <a:rPr sz="1300" b="0">
                 <a:solidFill>
                   <a:srgbClr val="333333"/>
                 </a:solidFill>
                 <a:latin typeface="Arial"/>
               </a:rPr>
-              <a:t> writes the AI assistant's answers from the retrieved passages. </a:t>
-            </a:r>
-            <a:r>
-              <a:rPr sz="1200" b="1">
+              <a:t> (Groq) writes the assistant's answers, and an </a:t>
+            </a:r>
+            <a:r>
+              <a:rPr sz="1300" b="1">
                 <a:solidFill>
                   <a:srgbClr val="000000"/>
                 </a:solidFill>
                 <a:latin typeface="Arial"/>
               </a:rPr>
-              <a:t>SMTP server</a:t>
-            </a:r>
-            <a:r>
-              <a:rPr sz="1200" b="0">
+              <a:t>e-mail server</a:t>
+            </a:r>
+            <a:r>
+              <a:rPr sz="1300" b="0">
                 <a:solidFill>
                   <a:srgbClr val="333333"/>
                 </a:solidFill>
                 <a:latin typeface="Arial"/>
               </a:rPr>
-              <a:t> sends e-mail notifications, called by Celery.</a:t>
+              <a:t> sends the notifications.</a:t>
             </a:r>
           </a:p>
         </p:txBody>
@@ -36729,7 +36747,7 @@
                 </a:solidFill>
                 <a:latin typeface="Arial"/>
               </a:rPr>
-              <a:t> only the backend calls ML and RAG: one entry point, least privilege, independent services.</a:t>
+              <a:t> only the backend talks to the helpers, so there is one door to secure and each part can change on its own.</a:t>
             </a:r>
           </a:p>
         </p:txBody>

</xml_diff>

<commit_message>
docs(presentation): simplify request flow slide, add Wave 2 models to models table
Request flow step-by-step slide reworded in plain language. The
'Models & Why They Were Chosen' table now lists PINN, Cox PH,
Mahalanobis and CUSUM + Kalman alongside the Dempster-Shafer fusion row.

Co-Authored-By: Claude Opus 5.5 <noreply@anthropic.com>
Claude-Session: https://claude.ai/code/session_01F96Sh6kL5Mvj9m6qX6kkqv
</commit_message>
<xml_diff>
--- a/presentation/technical_defense_final_v2.pptx
+++ b/presentation/technical_defense_final_v2.pptx
@@ -25565,7 +25565,7 @@
         </p:nvGraphicFramePr>
         <p:xfrm>
           <a:off x="457200" y="1554480"/>
-          <a:ext cx="11247120" cy="4608576"/>
+          <a:ext cx="11247120" cy="4754880"/>
         </p:xfrm>
         <a:graphic>
           <a:graphicData uri="http://schemas.openxmlformats.org/drawingml/2006/table">
@@ -25603,7 +25603,7 @@
                   </a:extLst>
                 </a:gridCol>
               </a:tblGrid>
-              <a:tr h="512064">
+              <a:tr h="365760">
                 <a:tc>
                   <a:txBody>
                     <a:bodyPr/>
@@ -25702,7 +25702,7 @@
                   </a:ext>
                 </a:extLst>
               </a:tr>
-              <a:tr h="512064">
+              <a:tr h="365760">
                 <a:tc>
                   <a:txBody>
                     <a:bodyPr/>
@@ -25781,7 +25781,7 @@
                   </a:ext>
                 </a:extLst>
               </a:tr>
-              <a:tr h="512064">
+              <a:tr h="365760">
                 <a:tc>
                   <a:txBody>
                     <a:bodyPr/>
@@ -25860,7 +25860,7 @@
                   </a:ext>
                 </a:extLst>
               </a:tr>
-              <a:tr h="512064">
+              <a:tr h="365760">
                 <a:tc>
                   <a:txBody>
                     <a:bodyPr/>
@@ -25939,7 +25939,7 @@
                   </a:ext>
                 </a:extLst>
               </a:tr>
-              <a:tr h="512064">
+              <a:tr h="365760">
                 <a:tc>
                   <a:txBody>
                     <a:bodyPr/>
@@ -26018,7 +26018,7 @@
                   </a:ext>
                 </a:extLst>
               </a:tr>
-              <a:tr h="512064">
+              <a:tr h="365760">
                 <a:tc>
                   <a:txBody>
                     <a:bodyPr/>
@@ -26097,7 +26097,7 @@
                   </a:ext>
                 </a:extLst>
               </a:tr>
-              <a:tr h="512064">
+              <a:tr h="365760">
                 <a:tc>
                   <a:txBody>
                     <a:bodyPr/>
@@ -26176,7 +26176,7 @@
                   </a:ext>
                 </a:extLst>
               </a:tr>
-              <a:tr h="512064">
+              <a:tr h="365760">
                 <a:tc>
                   <a:txBody>
                     <a:bodyPr/>
@@ -26255,7 +26255,7 @@
                   </a:ext>
                 </a:extLst>
               </a:tr>
-              <a:tr h="512064">
+              <a:tr h="365760">
                 <a:tc>
                   <a:txBody>
                     <a:bodyPr/>
@@ -26268,7 +26268,323 @@
                           </a:solidFill>
                           <a:latin typeface="Arial"/>
                         </a:rPr>
-                        <a:t>Wave 2 fusion</a:t>
+                        <a:t>Wave 2: Realistic life</a:t>
+                      </a:r>
+                    </a:p>
+                  </a:txBody>
+                  <a:tcPr marL="54864" marR="54864" marT="18288" marB="18288" anchor="ctr"/>
+                </a:tc>
+                <a:tc>
+                  <a:txBody>
+                    <a:bodyPr/>
+                    <a:lstStyle/>
+                    <a:p>
+                      <a:r>
+                        <a:rPr sz="1200" b="0" i="0">
+                          <a:solidFill>
+                            <a:srgbClr val="000000"/>
+                          </a:solidFill>
+                          <a:latin typeface="Arial"/>
+                        </a:rPr>
+                        <a:t>PINN (physics-informed network)</a:t>
+                      </a:r>
+                    </a:p>
+                  </a:txBody>
+                  <a:tcPr marL="54864" marR="54864" marT="18288" marB="18288" anchor="ctr"/>
+                </a:tc>
+                <a:tc>
+                  <a:txBody>
+                    <a:bodyPr/>
+                    <a:lstStyle/>
+                    <a:p>
+                      <a:r>
+                        <a:rPr sz="1200" b="0" i="0">
+                          <a:solidFill>
+                            <a:srgbClr val="000000"/>
+                          </a:solidFill>
+                          <a:latin typeface="Arial"/>
+                        </a:rPr>
+                        <a:t>Purely data-driven network</a:t>
+                      </a:r>
+                    </a:p>
+                  </a:txBody>
+                  <a:tcPr marL="54864" marR="54864" marT="18288" marB="18288" anchor="ctr"/>
+                </a:tc>
+                <a:tc>
+                  <a:txBody>
+                    <a:bodyPr/>
+                    <a:lstStyle/>
+                    <a:p>
+                      <a:r>
+                        <a:rPr sz="1200" b="0" i="0">
+                          <a:solidFill>
+                            <a:srgbClr val="000000"/>
+                          </a:solidFill>
+                          <a:latin typeface="Arial"/>
+                        </a:rPr>
+                        <a:t>Physics rules out impossible estimates</a:t>
+                      </a:r>
+                    </a:p>
+                  </a:txBody>
+                  <a:tcPr marL="54864" marR="54864" marT="18288" marB="18288" anchor="ctr"/>
+                </a:tc>
+                <a:extLst>
+                  <a:ext uri="{0D108BD9-81ED-4DB2-BD59-A6C34878D82A}">
+                    <a16:rowId xmlns:a16="http://schemas.microsoft.com/office/drawing/2014/main" val="10101"/>
+                  </a:ext>
+                </a:extLst>
+              </a:tr>
+              <a:tr h="365760">
+                <a:tc>
+                  <a:txBody>
+                    <a:bodyPr/>
+                    <a:lstStyle/>
+                    <a:p>
+                      <a:r>
+                        <a:rPr sz="1200" b="1" i="0">
+                          <a:solidFill>
+                            <a:srgbClr val="000000"/>
+                          </a:solidFill>
+                          <a:latin typeface="Arial"/>
+                        </a:rPr>
+                        <a:t>Wave 2: Time to failure</a:t>
+                      </a:r>
+                    </a:p>
+                  </a:txBody>
+                  <a:tcPr marL="54864" marR="54864" marT="18288" marB="18288" anchor="ctr"/>
+                </a:tc>
+                <a:tc>
+                  <a:txBody>
+                    <a:bodyPr/>
+                    <a:lstStyle/>
+                    <a:p>
+                      <a:r>
+                        <a:rPr sz="1200" b="0" i="0">
+                          <a:solidFill>
+                            <a:srgbClr val="000000"/>
+                          </a:solidFill>
+                          <a:latin typeface="Arial"/>
+                        </a:rPr>
+                        <a:t>Cox PH survival model</a:t>
+                      </a:r>
+                    </a:p>
+                  </a:txBody>
+                  <a:tcPr marL="54864" marR="54864" marT="18288" marB="18288" anchor="ctr"/>
+                </a:tc>
+                <a:tc>
+                  <a:txBody>
+                    <a:bodyPr/>
+                    <a:lstStyle/>
+                    <a:p>
+                      <a:r>
+                        <a:rPr sz="1200" b="0" i="0">
+                          <a:solidFill>
+                            <a:srgbClr val="000000"/>
+                          </a:solidFill>
+                          <a:latin typeface="Arial"/>
+                        </a:rPr>
+                        <a:t>Plain regression, Weibull AFT</a:t>
+                      </a:r>
+                    </a:p>
+                  </a:txBody>
+                  <a:tcPr marL="54864" marR="54864" marT="18288" marB="18288" anchor="ctr"/>
+                </a:tc>
+                <a:tc>
+                  <a:txBody>
+                    <a:bodyPr/>
+                    <a:lstStyle/>
+                    <a:p>
+                      <a:r>
+                        <a:rPr sz="1200" b="0" i="0">
+                          <a:solidFill>
+                            <a:srgbClr val="000000"/>
+                          </a:solidFill>
+                          <a:latin typeface="Arial"/>
+                        </a:rPr>
+                        <a:t>Handles running machines · C-index 0.712</a:t>
+                      </a:r>
+                    </a:p>
+                  </a:txBody>
+                  <a:tcPr marL="54864" marR="54864" marT="18288" marB="18288" anchor="ctr"/>
+                </a:tc>
+                <a:extLst>
+                  <a:ext uri="{0D108BD9-81ED-4DB2-BD59-A6C34878D82A}">
+                    <a16:rowId xmlns:a16="http://schemas.microsoft.com/office/drawing/2014/main" val="10102"/>
+                  </a:ext>
+                </a:extLst>
+              </a:tr>
+              <a:tr h="365760">
+                <a:tc>
+                  <a:txBody>
+                    <a:bodyPr/>
+                    <a:lstStyle/>
+                    <a:p>
+                      <a:r>
+                        <a:rPr sz="1200" b="1" i="0">
+                          <a:solidFill>
+                            <a:srgbClr val="000000"/>
+                          </a:solidFill>
+                          <a:latin typeface="Arial"/>
+                        </a:rPr>
+                        <a:t>Wave 2: Off its normal</a:t>
+                      </a:r>
+                    </a:p>
+                  </a:txBody>
+                  <a:tcPr marL="54864" marR="54864" marT="18288" marB="18288" anchor="ctr"/>
+                </a:tc>
+                <a:tc>
+                  <a:txBody>
+                    <a:bodyPr/>
+                    <a:lstStyle/>
+                    <a:p>
+                      <a:r>
+                        <a:rPr sz="1200" b="0" i="0">
+                          <a:solidFill>
+                            <a:srgbClr val="000000"/>
+                          </a:solidFill>
+                          <a:latin typeface="Arial"/>
+                        </a:rPr>
+                        <a:t>Mahalanobis health index</a:t>
+                      </a:r>
+                    </a:p>
+                  </a:txBody>
+                  <a:tcPr marL="54864" marR="54864" marT="18288" marB="18288" anchor="ctr"/>
+                </a:tc>
+                <a:tc>
+                  <a:txBody>
+                    <a:bodyPr/>
+                    <a:lstStyle/>
+                    <a:p>
+                      <a:r>
+                        <a:rPr sz="1200" b="0" i="0">
+                          <a:solidFill>
+                            <a:srgbClr val="000000"/>
+                          </a:solidFill>
+                          <a:latin typeface="Arial"/>
+                        </a:rPr>
+                        <a:t>Fixed per-sensor thresholds</a:t>
+                      </a:r>
+                    </a:p>
+                  </a:txBody>
+                  <a:tcPr marL="54864" marR="54864" marT="18288" marB="18288" anchor="ctr"/>
+                </a:tc>
+                <a:tc>
+                  <a:txBody>
+                    <a:bodyPr/>
+                    <a:lstStyle/>
+                    <a:p>
+                      <a:r>
+                        <a:rPr sz="1200" b="0" i="0">
+                          <a:solidFill>
+                            <a:srgbClr val="000000"/>
+                          </a:solidFill>
+                          <a:latin typeface="Arial"/>
+                        </a:rPr>
+                        <a:t>Compares to the machine's own baseline</a:t>
+                      </a:r>
+                    </a:p>
+                  </a:txBody>
+                  <a:tcPr marL="54864" marR="54864" marT="18288" marB="18288" anchor="ctr"/>
+                </a:tc>
+                <a:extLst>
+                  <a:ext uri="{0D108BD9-81ED-4DB2-BD59-A6C34878D82A}">
+                    <a16:rowId xmlns:a16="http://schemas.microsoft.com/office/drawing/2014/main" val="10103"/>
+                  </a:ext>
+                </a:extLst>
+              </a:tr>
+              <a:tr h="365760">
+                <a:tc>
+                  <a:txBody>
+                    <a:bodyPr/>
+                    <a:lstStyle/>
+                    <a:p>
+                      <a:r>
+                        <a:rPr sz="1200" b="1" i="0">
+                          <a:solidFill>
+                            <a:srgbClr val="000000"/>
+                          </a:solidFill>
+                          <a:latin typeface="Arial"/>
+                        </a:rPr>
+                        <a:t>Wave 2: Slow decline</a:t>
+                      </a:r>
+                    </a:p>
+                  </a:txBody>
+                  <a:tcPr marL="54864" marR="54864" marT="18288" marB="18288" anchor="ctr"/>
+                </a:tc>
+                <a:tc>
+                  <a:txBody>
+                    <a:bodyPr/>
+                    <a:lstStyle/>
+                    <a:p>
+                      <a:r>
+                        <a:rPr sz="1200" b="0" i="0">
+                          <a:solidFill>
+                            <a:srgbClr val="000000"/>
+                          </a:solidFill>
+                          <a:latin typeface="Arial"/>
+                        </a:rPr>
+                        <a:t>CUSUM + Kalman filter</a:t>
+                      </a:r>
+                    </a:p>
+                  </a:txBody>
+                  <a:tcPr marL="54864" marR="54864" marT="18288" marB="18288" anchor="ctr"/>
+                </a:tc>
+                <a:tc>
+                  <a:txBody>
+                    <a:bodyPr/>
+                    <a:lstStyle/>
+                    <a:p>
+                      <a:r>
+                        <a:rPr sz="1200" b="0" i="0">
+                          <a:solidFill>
+                            <a:srgbClr val="000000"/>
+                          </a:solidFill>
+                          <a:latin typeface="Arial"/>
+                        </a:rPr>
+                        <a:t>Single-snapshot thresholds</a:t>
+                      </a:r>
+                    </a:p>
+                  </a:txBody>
+                  <a:tcPr marL="54864" marR="54864" marT="18288" marB="18288" anchor="ctr"/>
+                </a:tc>
+                <a:tc>
+                  <a:txBody>
+                    <a:bodyPr/>
+                    <a:lstStyle/>
+                    <a:p>
+                      <a:r>
+                        <a:rPr sz="1200" b="0" i="0">
+                          <a:solidFill>
+                            <a:srgbClr val="000000"/>
+                          </a:solidFill>
+                          <a:latin typeface="Arial"/>
+                        </a:rPr>
+                        <a:t>Catches slow drift a snapshot misses</a:t>
+                      </a:r>
+                    </a:p>
+                  </a:txBody>
+                  <a:tcPr marL="54864" marR="54864" marT="18288" marB="18288" anchor="ctr"/>
+                </a:tc>
+                <a:extLst>
+                  <a:ext uri="{0D108BD9-81ED-4DB2-BD59-A6C34878D82A}">
+                    <a16:rowId xmlns:a16="http://schemas.microsoft.com/office/drawing/2014/main" val="10104"/>
+                  </a:ext>
+                </a:extLst>
+              </a:tr>
+              <a:tr h="365760">
+                <a:tc>
+                  <a:txBody>
+                    <a:bodyPr/>
+                    <a:lstStyle/>
+                    <a:p>
+                      <a:r>
+                        <a:rPr sz="1200" b="1" i="0">
+                          <a:solidFill>
+                            <a:srgbClr val="000000"/>
+                          </a:solidFill>
+                          <a:latin typeface="Arial"/>
+                        </a:rPr>
+                        <a:t>Wave 2: Fusion</a:t>
                       </a:r>
                     </a:p>
                   </a:txBody>
@@ -34727,7 +35043,7 @@
                 </a:solidFill>
                 <a:latin typeface="Arial"/>
               </a:rPr>
-              <a:t>Opening a machine's ML panel sends </a:t>
+              <a:t>When someone opens a machine's health panel, the browser </a:t>
             </a:r>
             <a:r>
               <a:rPr sz="1400" b="1">
@@ -34736,7 +35052,7 @@
                 </a:solidFill>
                 <a:latin typeface="Arial"/>
               </a:rPr>
-              <a:t>GET /machines/{id}/unified-health</a:t>
+              <a:t>asks the backend</a:t>
             </a:r>
             <a:r>
               <a:rPr sz="1400" b="0">
@@ -34745,7 +35061,7 @@
                 </a:solidFill>
                 <a:latin typeface="Arial"/>
               </a:rPr>
-              <a:t> to the backend: a REST call that carries the user's </a:t>
+              <a:t> for that machine's health, sending the user's </a:t>
             </a:r>
             <a:r>
               <a:rPr sz="1400" b="1">
@@ -34754,7 +35070,7 @@
                 </a:solidFill>
                 <a:latin typeface="Arial"/>
               </a:rPr>
-              <a:t>JWT</a:t>
+              <a:t>login token</a:t>
             </a:r>
             <a:r>
               <a:rPr sz="1400" b="0">
@@ -34763,7 +35079,7 @@
                 </a:solidFill>
                 <a:latin typeface="Arial"/>
               </a:rPr>
-              <a:t>.</a:t>
+              <a:t> with the request.</a:t>
             </a:r>
           </a:p>
         </p:txBody>
@@ -34899,7 +35215,7 @@
                 </a:solidFill>
                 <a:latin typeface="Arial"/>
               </a:rPr>
-              <a:t>It loads the latest </a:t>
+              <a:t>The backend fetches the machine's </a:t>
             </a:r>
             <a:r>
               <a:rPr sz="1400" b="1">
@@ -34908,7 +35224,7 @@
                 </a:solidFill>
                 <a:latin typeface="Arial"/>
               </a:rPr>
-              <a:t>real sensor readings</a:t>
+              <a:t>latest sensor readings</a:t>
             </a:r>
             <a:r>
               <a:rPr sz="1400" b="0">
@@ -34917,7 +35233,7 @@
                 </a:solidFill>
                 <a:latin typeface="Arial"/>
               </a:rPr>
-              <a:t> (temperatures, speed, torque, tool wear). If none are on record, </a:t>
+              <a:t> (temperatures, speed, torque, tool wear). If there are none, it </a:t>
             </a:r>
             <a:r>
               <a:rPr sz="1400" b="1">
@@ -34926,7 +35242,7 @@
                 </a:solidFill>
                 <a:latin typeface="Arial"/>
               </a:rPr>
-              <a:t>telemetry_available</a:t>
+              <a:t>stops here</a:t>
             </a:r>
             <a:r>
               <a:rPr sz="1400" b="0">
@@ -34935,7 +35251,7 @@
                 </a:solidFill>
                 <a:latin typeface="Arial"/>
               </a:rPr>
-              <a:t> is set to false and no model is called.</a:t>
+              <a:t> and calls no model.</a:t>
             </a:r>
           </a:p>
         </p:txBody>
@@ -35071,7 +35387,7 @@
                 </a:solidFill>
                 <a:latin typeface="Arial"/>
               </a:rPr>
-              <a:t>The backend calls </a:t>
+              <a:t>The ML service runs </a:t>
             </a:r>
             <a:r>
               <a:rPr sz="1400" b="1">
@@ -35080,7 +35396,7 @@
                 </a:solidFill>
                 <a:latin typeface="Arial"/>
               </a:rPr>
-              <a:t>/predict</a:t>
+              <a:t>seven models at once</a:t>
             </a:r>
             <a:r>
               <a:rPr sz="1400" b="0">
@@ -35089,25 +35405,7 @@
                 </a:solidFill>
                 <a:latin typeface="Arial"/>
               </a:rPr>
-              <a:t> with the sensor snapshot. </a:t>
-            </a:r>
-            <a:r>
-              <a:rPr sz="1400" b="1">
-                <a:solidFill>
-                  <a:srgbClr val="000000"/>
-                </a:solidFill>
-                <a:latin typeface="Arial"/>
-              </a:rPr>
-              <a:t>P1-P7</a:t>
-            </a:r>
-            <a:r>
-              <a:rPr sz="1400" b="0">
-                <a:solidFill>
-                  <a:srgbClr val="333333"/>
-                </a:solidFill>
-                <a:latin typeface="Arial"/>
-              </a:rPr>
-              <a:t> run in parallel: failure chance, failure type, remaining life, anomaly, priority, schedule, parts.</a:t>
+              <a:t> on those readings: failure chance, failure type, remaining life, odd behavior, urgency, best timing, parts needed.</a:t>
             </a:r>
           </a:p>
         </p:txBody>
@@ -35445,13 +35743,22 @@
           <a:p>
             <a:pPr algn="l"/>
             <a:r>
+              <a:rPr sz="1400" b="0">
+                <a:solidFill>
+                  <a:srgbClr val="333333"/>
+                </a:solidFill>
+                <a:latin typeface="Arial"/>
+              </a:rPr>
+              <a:t>All the opinions are </a:t>
+            </a:r>
+            <a:r>
               <a:rPr sz="1400" b="1">
                 <a:solidFill>
                   <a:srgbClr val="000000"/>
                 </a:solidFill>
                 <a:latin typeface="Arial"/>
               </a:rPr>
-              <a:t>Dempster-Shafer</a:t>
+              <a:t>combined into one health score</a:t>
             </a:r>
             <a:r>
               <a:rPr sz="1400" b="0">
@@ -35460,7 +35767,7 @@
                 </a:solidFill>
                 <a:latin typeface="Arial"/>
               </a:rPr>
-              <a:t> merges every signal into one </a:t>
+              <a:t> (0 to 100) and a verdict: Healthy, Degrading, Critical or </a:t>
             </a:r>
             <a:r>
               <a:rPr sz="1400" b="1">
@@ -35469,7 +35776,7 @@
                 </a:solidFill>
                 <a:latin typeface="Arial"/>
               </a:rPr>
-              <a:t>0-100 score</a:t>
+              <a:t>Unknown</a:t>
             </a:r>
             <a:r>
               <a:rPr sz="1400" b="0">
@@ -35478,25 +35785,7 @@
                 </a:solidFill>
                 <a:latin typeface="Arial"/>
               </a:rPr>
-              <a:t> and a verdict: Healthy, Degrading, Critical or </a:t>
-            </a:r>
-            <a:r>
-              <a:rPr sz="1400" b="1">
-                <a:solidFill>
-                  <a:srgbClr val="000000"/>
-                </a:solidFill>
-                <a:latin typeface="Arial"/>
-              </a:rPr>
-              <a:t>Unknown</a:t>
-            </a:r>
-            <a:r>
-              <a:rPr sz="1400" b="0">
-                <a:solidFill>
-                  <a:srgbClr val="333333"/>
-                </a:solidFill>
-                <a:latin typeface="Arial"/>
-              </a:rPr>
-              <a:t>. If the models strongly disagree, it answers Unknown instead of guessing.</a:t>
+              <a:t>. If the models strongly disagree, it says Unknown instead of guessing.</a:t>
             </a:r>
           </a:p>
         </p:txBody>
@@ -35632,7 +35921,7 @@
                 </a:solidFill>
                 <a:latin typeface="Arial"/>
               </a:rPr>
-              <a:t>The result is stored in </a:t>
+              <a:t>The result is </a:t>
             </a:r>
             <a:r>
               <a:rPr sz="1400" b="1">
@@ -35641,7 +35930,7 @@
                 </a:solidFill>
                 <a:latin typeface="Arial"/>
               </a:rPr>
-              <a:t>ml_prediction_logs</a:t>
+              <a:t>saved</a:t>
             </a:r>
             <a:r>
               <a:rPr sz="1400" b="0">
@@ -35650,7 +35939,25 @@
                 </a:solidFill>
                 <a:latin typeface="Arial"/>
               </a:rPr>
-              <a:t>, for audit and to compare predictions with what really happened. Then the panel updates.</a:t>
+              <a:t>, so every prediction can be checked later against what really happened. Then the </a:t>
+            </a:r>
+            <a:r>
+              <a:rPr sz="1400" b="1">
+                <a:solidFill>
+                  <a:srgbClr val="000000"/>
+                </a:solidFill>
+                <a:latin typeface="Arial"/>
+              </a:rPr>
+              <a:t>panel updates</a:t>
+            </a:r>
+            <a:r>
+              <a:rPr sz="1400" b="0">
+                <a:solidFill>
+                  <a:srgbClr val="333333"/>
+                </a:solidFill>
+                <a:latin typeface="Arial"/>
+              </a:rPr>
+              <a:t> on screen.</a:t>
             </a:r>
           </a:p>
         </p:txBody>
@@ -35685,7 +35992,7 @@
                 </a:solidFill>
                 <a:latin typeface="Arial"/>
               </a:rPr>
-              <a:t>Graceful degradation:</a:t>
+              <a:t>No data, no guessing:</a:t>
             </a:r>
             <a:r>
               <a:rPr sz="1300" b="0">
@@ -35694,7 +36001,7 @@
                 </a:solidFill>
                 <a:latin typeface="Arial"/>
               </a:rPr>
-              <a:t> no telemetry means a maintenance-history-only score, never a fabricated prediction.</a:t>
+              <a:t> without sensor readings, the score comes from maintenance history only, never from invented values.</a:t>
             </a:r>
           </a:p>
         </p:txBody>

</xml_diff>

<commit_message>
docs(presentation): add plain-language ML pipeline step-by-step slide
Co-Authored-By: Claude Opus 5.5 <noreply@anthropic.com>
Claude-Session: https://claude.ai/code/session_01F96Sh6kL5Mvj9m6qX6kkqv
</commit_message>
<xml_diff>
--- a/presentation/technical_defense_final_v2.pptx
+++ b/presentation/technical_defense_final_v2.pptx
@@ -26,16 +26,17 @@
     <p:sldId id="272" r:id="rId17"/>
     <p:sldId id="273" r:id="rId18"/>
     <p:sldId id="274" r:id="rId19"/>
+    <p:sldId id="295" r:id="rId45"/>
+    <p:sldId id="275" r:id="rId20"/>
     <p:sldId id="294" r:id="rId44"/>
-    <p:sldId id="275" r:id="rId20"/>
+    <p:sldId id="276" r:id="rId21"/>
     <p:sldId id="293" r:id="rId43"/>
-    <p:sldId id="276" r:id="rId21"/>
+    <p:sldId id="277" r:id="rId22"/>
     <p:sldId id="292" r:id="rId42"/>
-    <p:sldId id="277" r:id="rId22"/>
-    <p:sldId id="291" r:id="rId41"/>
     <p:sldId id="278" r:id="rId23"/>
     <p:sldId id="279" r:id="rId24"/>
     <p:sldId id="280" r:id="rId25"/>
+    <p:sldId id="291" r:id="rId41"/>
     <p:sldId id="281" r:id="rId26"/>
     <p:sldId id="282" r:id="rId27"/>
     <p:sldId id="269" r:id="rId28"/>
@@ -832,7 +833,7 @@
           <a:lstStyle/>
           <a:p>
             <a:r>
-              <a:t>Same application, now on Azure Kubernetes Service. Kubernetes runs the containers in pods across several VMs, restarts failed pods and scales with load. The system node pool runs Kubernetes' own components; the user pool runs our app and autoscales between two and four VMs. Two namespaces, eam-staging and eam-prod, have the same layout so new versions are tested before real users see them. The cluster sits in a private VNet, network policies restrict pod-to-pod traffic, and workload identity lets pods authenticate to Azure without stored credentials. PostgreSQL is a managed Flexible Server, images come from Azure Container Registry, and all secrets live in Key Vault, injected at runtime by the Secrets Store CSI driver. Because the inbound public load balancer is blocked at subscription level, an ngrok pod dials out and relays public traffic to the frontend. Delivery: GitLab CI gates every push, deploy-aks builds, pushes and restarts, and Terraform plus Helm define the infrastructure as code.</a:t>
+              <a:t>The pipeline starts from five sensor readings per machine: air temperature, process temperature, rotational speed, torque and tool wear. The feature pipeline derives extra signals from them, such as the temperature difference between process and air (heat build-up) and mechanical power, torque times speed (workload). Two groups of models then run in parallel. P1 to P7 work on the current snapshot: failure probability (XGBoost), failure type, remaining useful life, anomaly detection (a four-method ensemble), priority, maintenance schedule and parts demand. The Wave 2 signals work on the telemetry history: the PINN keeps remaining-life estimates physically realistic, the Cox proportional-hazards survival model estimates time to failure, the Mahalanobis health index measures how far the machine is from its own healthy baseline, and CUSUM with a Kalman filter detects slow cumulative drift. Dempster-Shafer evidence fusion combines the signals over four states, Healthy, Degrading, Critical and Unknown, switching to Yager's rule when the conflict is high so that disagreement is reported as uncertainty. The output is a 0-100 health score with a plain-language verdict, and every result is logged for audit and retraining.</a:t>
             </a:r>
           </a:p>
         </p:txBody>
@@ -902,7 +903,7 @@
           <a:lstStyle/>
           <a:p>
             <a:r>
-              <a:t>Everything runs on one machine: a developer workstation or the Azure demo VM. Each component is a Docker container, and Docker Compose starts them all from one file. Caddy is the reverse proxy and single entry point: it terminates HTTPS with Let's Encrypt certificates and routes / to the frontend, /api to the backend and /grafana to Grafana. Application containers share a private bridge network and call each other by service name. Ports are exposed on the host only in development; PostgreSQL keeps its data on a volume and the model files are mounted read-only. Monitoring (Prometheus, Pushgateway, Grafana, Trivy) runs on its own network, while SonarQube and Jupyter are started only when needed. In the demo, the prod overlay un-publishes everything except Caddy on 80/443 and pulls ready-built images from the registry, so the attack surface is one encrypted entry point.</a:t>
+              <a:t>Same application, now on Azure Kubernetes Service. Kubernetes runs the containers in pods across several VMs, restarts failed pods and scales with load. The system node pool runs Kubernetes' own components; the user pool runs our app and autoscales between two and four VMs. Two namespaces, eam-staging and eam-prod, have the same layout so new versions are tested before real users see them. The cluster sits in a private VNet, network policies restrict pod-to-pod traffic, and workload identity lets pods authenticate to Azure without stored credentials. PostgreSQL is a managed Flexible Server, images come from Azure Container Registry, and all secrets live in Key Vault, injected at runtime by the Secrets Store CSI driver. Because the inbound public load balancer is blocked at subscription level, an ngrok pod dials out and relays public traffic to the frontend. Delivery: GitLab CI gates every push, deploy-aks builds, pushes and restarts, and Terraform plus Helm define the infrastructure as code.</a:t>
             </a:r>
           </a:p>
         </p:txBody>
@@ -972,7 +973,7 @@
           <a:lstStyle/>
           <a:p>
             <a:r>
-              <a:t>This is what happens when a user opens a machine's ML Intelligence panel. The frontend sends GET /machines/{id}/unified-health to the backend. The backend first loads the machine's latest real sensor readings. If there are none, it sets telemetry_available to false and does not call the models: it never substitutes placeholder values, because fabricated inputs would give every machine the same meaningless prediction. With telemetry, two things run concurrently: the ML microservice runs the seven P1-P7 models on the current sensor snapshot, and the Wave 2 signals analyse the telemetry history: CUSUM and a Kalman filter detect a slow decline over time, the Cox survival model estimates how long the machine can keep running, the Mahalanobis index measures how far it has drifted from its own normal behaviour, and the physics-informed network (PINN) keeps the estimates physically realistic. Dempster-Shafer fusion then combines all these signals into a single 0-100 health score and a verdict: Healthy, Degrading, Critical or Unknown. When the models strongly disagree, Yager's rule moves that conflict to Unknown instead of forcing a confident answer. Finally the result is logged in ml_prediction_logs, so predictions can be audited and compared with real interventions, and the panel updates. Without telemetry the platform still answers, using a score computed from the maintenance history only.</a:t>
+              <a:t>Everything runs on one machine: a developer workstation or the Azure demo VM. Each component is a Docker container, and Docker Compose starts them all from one file. Caddy is the reverse proxy and single entry point: it terminates HTTPS with Let's Encrypt certificates and routes / to the frontend, /api to the backend and /grafana to Grafana. Application containers share a private bridge network and call each other by service name. Ports are exposed on the host only in development; PostgreSQL keeps its data on a volume and the model files are mounted read-only. Monitoring (Prometheus, Pushgateway, Grafana, Trivy) runs on its own network, while SonarQube and Jupyter are started only when needed. In the demo, the prod overlay un-publishes everything except Caddy on 80/443 and pulls ready-built images from the registry, so the attack surface is one encrypted entry point.</a:t>
             </a:r>
           </a:p>
         </p:txBody>
@@ -998,6 +999,76 @@
 </file>
 
 <file path=ppt/notesSlides/notesSlide7.xml><?xml version="1.0" encoding="utf-8"?>
+<p:notes xmlns:a="http://schemas.openxmlformats.org/drawingml/2006/main" xmlns:p="http://schemas.openxmlformats.org/presentationml/2006/main" xmlns:r="http://schemas.openxmlformats.org/officeDocument/2006/relationships">
+  <p:cSld>
+    <p:spTree>
+      <p:nvGrpSpPr>
+        <p:cNvPr id="1" name=""/>
+        <p:cNvGrpSpPr/>
+        <p:nvPr/>
+      </p:nvGrpSpPr>
+      <p:grpSpPr>
+        <a:xfrm>
+          <a:off x="0" y="0"/>
+          <a:ext cx="0" cy="0"/>
+          <a:chOff x="0" y="0"/>
+          <a:chExt cx="0" cy="0"/>
+        </a:xfrm>
+      </p:grpSpPr>
+      <p:sp>
+        <p:nvSpPr>
+          <p:cNvPr id="2" name="Slide Image Placeholder 1"/>
+          <p:cNvSpPr>
+            <a:spLocks noGrp="1"/>
+          </p:cNvSpPr>
+          <p:nvPr>
+            <p:ph type="sldImg" idx="2"/>
+          </p:nvPr>
+        </p:nvSpPr>
+        <p:spPr/>
+      </p:sp>
+      <p:sp>
+        <p:nvSpPr>
+          <p:cNvPr id="3" name="Notes Placeholder 2"/>
+          <p:cNvSpPr>
+            <a:spLocks noGrp="1"/>
+          </p:cNvSpPr>
+          <p:nvPr>
+            <p:ph type="body" idx="3" sz="quarter"/>
+          </p:nvPr>
+        </p:nvSpPr>
+        <p:spPr/>
+        <p:txBody>
+          <a:bodyPr/>
+          <a:lstStyle/>
+          <a:p>
+            <a:r>
+              <a:t>This is what happens when a user opens a machine's ML Intelligence panel. The frontend sends GET /machines/{id}/unified-health to the backend. The backend first loads the machine's latest real sensor readings. If there are none, it sets telemetry_available to false and does not call the models: it never substitutes placeholder values, because fabricated inputs would give every machine the same meaningless prediction. With telemetry, two things run concurrently: the ML microservice runs the seven P1-P7 models on the current sensor snapshot, and the Wave 2 signals analyse the telemetry history: CUSUM and a Kalman filter detect a slow decline over time, the Cox survival model estimates how long the machine can keep running, the Mahalanobis index measures how far it has drifted from its own normal behaviour, and the physics-informed network (PINN) keeps the estimates physically realistic. Dempster-Shafer fusion then combines all these signals into a single 0-100 health score and a verdict: Healthy, Degrading, Critical or Unknown. When the models strongly disagree, Yager's rule moves that conflict to Unknown instead of forcing a confident answer. Finally the result is logged in ml_prediction_logs, so predictions can be audited and compared with real interventions, and the panel updates. Without telemetry the platform still answers, using a score computed from the maintenance history only.</a:t>
+            </a:r>
+          </a:p>
+        </p:txBody>
+      </p:sp>
+      <p:sp>
+        <p:nvSpPr>
+          <p:cNvPr id="4" name="Slide Number Placeholder 3"/>
+          <p:cNvSpPr>
+            <a:spLocks noGrp="1"/>
+          </p:cNvSpPr>
+          <p:nvPr>
+            <p:ph type="sldNum" idx="5" sz="quarter"/>
+          </p:nvPr>
+        </p:nvSpPr>
+        <p:spPr/>
+      </p:sp>
+    </p:spTree>
+  </p:cSld>
+  <p:clrMapOvr>
+    <a:masterClrMapping/>
+  </p:clrMapOvr>
+</p:notes>
+</file>
+
+<file path=ppt/notesSlides/notesSlide8.xml><?xml version="1.0" encoding="utf-8"?>
 <p:notes xmlns:a="http://schemas.openxmlformats.org/drawingml/2006/main" xmlns:p="http://schemas.openxmlformats.org/presentationml/2006/main" xmlns:r="http://schemas.openxmlformats.org/officeDocument/2006/relationships">
   <p:cSld>
     <p:spTree>
@@ -25550,7 +25621,7 @@
                 </a:solidFill>
                 <a:latin typeface="Arial"/>
               </a:rPr>
-              <a:t>29</a:t>
+              <a:t>30</a:t>
             </a:r>
           </a:p>
         </p:txBody>
@@ -26815,7 +26886,7 @@
                 </a:solidFill>
                 <a:latin typeface="Arial"/>
               </a:rPr>
-              <a:t>30</a:t>
+              <a:t>31</a:t>
             </a:r>
           </a:p>
         </p:txBody>
@@ -28371,7 +28442,7 @@
                 </a:solidFill>
                 <a:latin typeface="Arial"/>
               </a:rPr>
-              <a:t>31</a:t>
+              <a:t>32</a:t>
             </a:r>
           </a:p>
         </p:txBody>
@@ -28566,7 +28637,7 @@
                 </a:solidFill>
                 <a:latin typeface="Arial"/>
               </a:rPr>
-              <a:t>32</a:t>
+              <a:t>33</a:t>
             </a:r>
           </a:p>
         </p:txBody>
@@ -28733,7 +28804,7 @@
                 </a:solidFill>
                 <a:latin typeface="Arial"/>
               </a:rPr>
-              <a:t>33</a:t>
+              <a:t>34</a:t>
             </a:r>
           </a:p>
         </p:txBody>
@@ -29054,7 +29125,7 @@
                 </a:solidFill>
                 <a:latin typeface="Arial"/>
               </a:rPr>
-              <a:t>34</a:t>
+              <a:t>35</a:t>
             </a:r>
           </a:p>
         </p:txBody>
@@ -30356,7 +30427,7 @@
                 </a:solidFill>
                 <a:latin typeface="Arial"/>
               </a:rPr>
-              <a:t>35</a:t>
+              <a:t>36</a:t>
             </a:r>
           </a:p>
         </p:txBody>
@@ -30514,7 +30585,7 @@
                 </a:solidFill>
                 <a:latin typeface="Arial"/>
               </a:rPr>
-              <a:t>36</a:t>
+              <a:t>37</a:t>
             </a:r>
           </a:p>
         </p:txBody>
@@ -31071,7 +31142,7 @@
                 </a:solidFill>
                 <a:latin typeface="Arial"/>
               </a:rPr>
-              <a:t>37</a:t>
+              <a:t>38</a:t>
             </a:r>
           </a:p>
         </p:txBody>
@@ -31790,7 +31861,7 @@
                 </a:solidFill>
                 <a:latin typeface="Arial"/>
               </a:rPr>
-              <a:t>38</a:t>
+              <a:t>39</a:t>
             </a:r>
           </a:p>
         </p:txBody>
@@ -31843,7 +31914,7 @@
                 </a:solidFill>
                 <a:latin typeface="Arial"/>
               </a:rPr>
-              <a:t>04. Design: Physical Architecture</a:t>
+              <a:t>04. Implementation: Machine Learning</a:t>
             </a:r>
           </a:p>
         </p:txBody>
@@ -31914,7 +31985,7 @@
                 </a:solidFill>
                 <a:latin typeface="Arial Black"/>
               </a:rPr>
-              <a:t>Azure AKS: Key Concepts</a:t>
+              <a:t>Machine Learning Pipeline: Step by Step</a:t>
             </a:r>
           </a:p>
         </p:txBody>
@@ -31949,7 +32020,7 @@
                 </a:solidFill>
                 <a:latin typeface="Arial"/>
               </a:rPr>
-              <a:t>25</a:t>
+              <a:t>29</a:t>
             </a:r>
           </a:p>
         </p:txBody>
@@ -31963,7 +32034,7 @@
         <p:spPr>
           <a:xfrm>
             <a:off x="457200" y="1760220"/>
-            <a:ext cx="2715768" cy="1645920"/>
+            <a:ext cx="3666744" cy="1645920"/>
           </a:xfrm>
           <a:prstGeom prst="roundRect">
             <a:avLst>
@@ -32008,8 +32079,8 @@
         </p:nvSpPr>
         <p:spPr>
           <a:xfrm>
-            <a:off x="672084" y="1554480"/>
-            <a:ext cx="2286000" cy="411480"/>
+            <a:off x="918972" y="1554480"/>
+            <a:ext cx="2743200" cy="411480"/>
           </a:xfrm>
           <a:prstGeom prst="roundRect">
             <a:avLst>
@@ -32050,7 +32121,7 @@
                 </a:solidFill>
                 <a:latin typeface="Arial"/>
               </a:rPr>
-              <a:t>Kubernetes (AKS)</a:t>
+              <a:t>1 · Sensor telemetry</a:t>
             </a:r>
           </a:p>
         </p:txBody>
@@ -32064,7 +32135,7 @@
         <p:spPr>
           <a:xfrm>
             <a:off x="548640" y="2011680"/>
-            <a:ext cx="2532888" cy="1348740"/>
+            <a:ext cx="3483864" cy="1348740"/>
           </a:xfrm>
           <a:prstGeom prst="rect">
             <a:avLst/>
@@ -32079,67 +32150,31 @@
           <a:p>
             <a:pPr algn="l"/>
             <a:r>
-              <a:rPr sz="1300" b="0">
+              <a:rPr sz="1400" b="0">
                 <a:solidFill>
                   <a:srgbClr val="333333"/>
                 </a:solidFill>
                 <a:latin typeface="Arial"/>
               </a:rPr>
-              <a:t>Runs our containers across </a:t>
-            </a:r>
-            <a:r>
-              <a:rPr sz="1300" b="1">
+              <a:t>Each machine reports </a:t>
+            </a:r>
+            <a:r>
+              <a:rPr sz="1400" b="1">
                 <a:solidFill>
                   <a:srgbClr val="000000"/>
                 </a:solidFill>
                 <a:latin typeface="Arial"/>
               </a:rPr>
-              <a:t>several machines</a:t>
-            </a:r>
-            <a:r>
-              <a:rPr sz="1300" b="0">
+              <a:t>five readings</a:t>
+            </a:r>
+            <a:r>
+              <a:rPr sz="1400" b="0">
                 <a:solidFill>
                   <a:srgbClr val="333333"/>
                 </a:solidFill>
                 <a:latin typeface="Arial"/>
               </a:rPr>
-              <a:t>. A crashed service is </a:t>
-            </a:r>
-            <a:r>
-              <a:rPr sz="1300" b="1">
-                <a:solidFill>
-                  <a:srgbClr val="000000"/>
-                </a:solidFill>
-                <a:latin typeface="Arial"/>
-              </a:rPr>
-              <a:t>restarted automatically</a:t>
-            </a:r>
-            <a:r>
-              <a:rPr sz="1300" b="0">
-                <a:solidFill>
-                  <a:srgbClr val="333333"/>
-                </a:solidFill>
-                <a:latin typeface="Arial"/>
-              </a:rPr>
-              <a:t>, and capacity </a:t>
-            </a:r>
-            <a:r>
-              <a:rPr sz="1300" b="1">
-                <a:solidFill>
-                  <a:srgbClr val="000000"/>
-                </a:solidFill>
-                <a:latin typeface="Arial"/>
-              </a:rPr>
-              <a:t>grows with traffic</a:t>
-            </a:r>
-            <a:r>
-              <a:rPr sz="1300" b="0">
-                <a:solidFill>
-                  <a:srgbClr val="333333"/>
-                </a:solidFill>
-                <a:latin typeface="Arial"/>
-              </a:rPr>
-              <a:t>.</a:t>
+              <a:t>: air temperature, process temperature, rotation speed, torque and tool wear. Everything starts from these numbers.</a:t>
             </a:r>
           </a:p>
         </p:txBody>
@@ -32152,8 +32187,8 @@
         </p:nvSpPr>
         <p:spPr>
           <a:xfrm>
-            <a:off x="3310128" y="1760220"/>
-            <a:ext cx="2715768" cy="1645920"/>
+            <a:off x="4261104" y="1760220"/>
+            <a:ext cx="3666744" cy="1645920"/>
           </a:xfrm>
           <a:prstGeom prst="roundRect">
             <a:avLst>
@@ -32198,8 +32233,8 @@
         </p:nvSpPr>
         <p:spPr>
           <a:xfrm>
-            <a:off x="3525012" y="1554480"/>
-            <a:ext cx="2286000" cy="411480"/>
+            <a:off x="4722876" y="1554480"/>
+            <a:ext cx="2743200" cy="411480"/>
           </a:xfrm>
           <a:prstGeom prst="roundRect">
             <a:avLst>
@@ -32240,7 +32275,7 @@
                 </a:solidFill>
                 <a:latin typeface="Arial"/>
               </a:rPr>
-              <a:t>Node pools</a:t>
+              <a:t>2 · Feature pipeline</a:t>
             </a:r>
           </a:p>
         </p:txBody>
@@ -32253,8 +32288,8 @@
         </p:nvSpPr>
         <p:spPr>
           <a:xfrm>
-            <a:off x="3401568" y="2011680"/>
-            <a:ext cx="2532888" cy="1348740"/>
+            <a:off x="4352544" y="2011680"/>
+            <a:ext cx="3483864" cy="1348740"/>
           </a:xfrm>
           <a:prstGeom prst="rect">
             <a:avLst/>
@@ -32269,67 +32304,67 @@
           <a:p>
             <a:pPr algn="l"/>
             <a:r>
-              <a:rPr sz="1300" b="0">
+              <a:rPr sz="1400" b="0">
                 <a:solidFill>
                   <a:srgbClr val="333333"/>
                 </a:solidFill>
                 <a:latin typeface="Arial"/>
               </a:rPr>
-              <a:t>Two groups of machines: one for </a:t>
-            </a:r>
-            <a:r>
-              <a:rPr sz="1300" b="1">
+              <a:t>The raw numbers are turned into </a:t>
+            </a:r>
+            <a:r>
+              <a:rPr sz="1400" b="1">
                 <a:solidFill>
                   <a:srgbClr val="000000"/>
                 </a:solidFill>
                 <a:latin typeface="Arial"/>
               </a:rPr>
-              <a:t>Kubernetes itself</a:t>
-            </a:r>
-            <a:r>
-              <a:rPr sz="1300" b="0">
+              <a:t>useful clues</a:t>
+            </a:r>
+            <a:r>
+              <a:rPr sz="1400" b="0">
                 <a:solidFill>
                   <a:srgbClr val="333333"/>
                 </a:solidFill>
                 <a:latin typeface="Arial"/>
               </a:rPr>
-              <a:t>, one for </a:t>
-            </a:r>
-            <a:r>
-              <a:rPr sz="1300" b="1">
+              <a:t>, such as how much </a:t>
+            </a:r>
+            <a:r>
+              <a:rPr sz="1400" b="1">
                 <a:solidFill>
                   <a:srgbClr val="000000"/>
                 </a:solidFill>
                 <a:latin typeface="Arial"/>
               </a:rPr>
-              <a:t>our app</a:t>
-            </a:r>
-            <a:r>
-              <a:rPr sz="1300" b="0">
+              <a:t>heat is building up</a:t>
+            </a:r>
+            <a:r>
+              <a:rPr sz="1400" b="0">
                 <a:solidFill>
                   <a:srgbClr val="333333"/>
                 </a:solidFill>
                 <a:latin typeface="Arial"/>
               </a:rPr>
-              <a:t>, which grows from </a:t>
-            </a:r>
-            <a:r>
-              <a:rPr sz="1300" b="1">
+              <a:t> inside the machine and how </a:t>
+            </a:r>
+            <a:r>
+              <a:rPr sz="1400" b="1">
                 <a:solidFill>
                   <a:srgbClr val="000000"/>
                 </a:solidFill>
                 <a:latin typeface="Arial"/>
               </a:rPr>
-              <a:t>2 to 4 machines</a:t>
-            </a:r>
-            <a:r>
-              <a:rPr sz="1300" b="0">
+              <a:t>hard it is working</a:t>
+            </a:r>
+            <a:r>
+              <a:rPr sz="1400" b="0">
                 <a:solidFill>
                   <a:srgbClr val="333333"/>
                 </a:solidFill>
                 <a:latin typeface="Arial"/>
               </a:rPr>
-              <a:t> with demand.</a:t>
+              <a:t>.</a:t>
             </a:r>
           </a:p>
         </p:txBody>
@@ -32342,8 +32377,8 @@
         </p:nvSpPr>
         <p:spPr>
           <a:xfrm>
-            <a:off x="6163056" y="1760220"/>
-            <a:ext cx="2715768" cy="1645920"/>
+            <a:off x="8065008" y="1760220"/>
+            <a:ext cx="3666744" cy="1645920"/>
           </a:xfrm>
           <a:prstGeom prst="roundRect">
             <a:avLst>
@@ -32388,8 +32423,8 @@
         </p:nvSpPr>
         <p:spPr>
           <a:xfrm>
-            <a:off x="6377940" y="1554480"/>
-            <a:ext cx="2286000" cy="411480"/>
+            <a:off x="8526780" y="1554480"/>
+            <a:ext cx="2743200" cy="411480"/>
           </a:xfrm>
           <a:prstGeom prst="roundRect">
             <a:avLst>
@@ -32430,7 +32465,7 @@
                 </a:solidFill>
                 <a:latin typeface="Arial"/>
               </a:rPr>
-              <a:t>Staging &amp; production</a:t>
+              <a:t>3 · Seven models (P1-P7)</a:t>
             </a:r>
           </a:p>
         </p:txBody>
@@ -32443,8 +32478,8 @@
         </p:nvSpPr>
         <p:spPr>
           <a:xfrm>
-            <a:off x="6254496" y="2011680"/>
-            <a:ext cx="2532888" cy="1348740"/>
+            <a:off x="8156448" y="2011680"/>
+            <a:ext cx="3483864" cy="1348740"/>
           </a:xfrm>
           <a:prstGeom prst="rect">
             <a:avLst/>
@@ -32459,49 +32494,31 @@
           <a:p>
             <a:pPr algn="l"/>
             <a:r>
-              <a:rPr sz="1300" b="0">
+              <a:rPr sz="1400" b="0">
                 <a:solidFill>
                   <a:srgbClr val="333333"/>
                 </a:solidFill>
                 <a:latin typeface="Arial"/>
               </a:rPr>
-              <a:t>Two identical copies of the app: </a:t>
-            </a:r>
-            <a:r>
-              <a:rPr sz="1300" b="1">
+              <a:t>Seven models each answer </a:t>
+            </a:r>
+            <a:r>
+              <a:rPr sz="1400" b="1">
                 <a:solidFill>
                   <a:srgbClr val="000000"/>
                 </a:solidFill>
                 <a:latin typeface="Arial"/>
               </a:rPr>
-              <a:t>staging</a:t>
-            </a:r>
-            <a:r>
-              <a:rPr sz="1300" b="0">
+              <a:t>one question about right now</a:t>
+            </a:r>
+            <a:r>
+              <a:rPr sz="1400" b="0">
                 <a:solidFill>
                   <a:srgbClr val="333333"/>
                 </a:solidFill>
                 <a:latin typeface="Arial"/>
               </a:rPr>
-              <a:t> to test new versions, </a:t>
-            </a:r>
-            <a:r>
-              <a:rPr sz="1300" b="1">
-                <a:solidFill>
-                  <a:srgbClr val="000000"/>
-                </a:solidFill>
-                <a:latin typeface="Arial"/>
-              </a:rPr>
-              <a:t>production</a:t>
-            </a:r>
-            <a:r>
-              <a:rPr sz="1300" b="0">
-                <a:solidFill>
-                  <a:srgbClr val="333333"/>
-                </a:solidFill>
-                <a:latin typeface="Arial"/>
-              </a:rPr>
-              <a:t> for real users.</a:t>
+              <a:t>: will it fail, how, how long is left, is it acting oddly, how urgent is it, when to repair, which parts.</a:t>
             </a:r>
           </a:p>
         </p:txBody>
@@ -32514,8 +32531,8 @@
         </p:nvSpPr>
         <p:spPr>
           <a:xfrm>
-            <a:off x="9015984" y="1760220"/>
-            <a:ext cx="2715768" cy="1645920"/>
+            <a:off x="457200" y="3931920"/>
+            <a:ext cx="3666744" cy="1645920"/>
           </a:xfrm>
           <a:prstGeom prst="roundRect">
             <a:avLst>
@@ -32560,8 +32577,8 @@
         </p:nvSpPr>
         <p:spPr>
           <a:xfrm>
-            <a:off x="9230868" y="1554480"/>
-            <a:ext cx="2286000" cy="411480"/>
+            <a:off x="918972" y="3726180"/>
+            <a:ext cx="2743200" cy="411480"/>
           </a:xfrm>
           <a:prstGeom prst="roundRect">
             <a:avLst>
@@ -32602,7 +32619,7 @@
                 </a:solidFill>
                 <a:latin typeface="Arial"/>
               </a:rPr>
-              <a:t>Network security</a:t>
+              <a:t>4 · Wave 2 signals</a:t>
             </a:r>
           </a:p>
         </p:txBody>
@@ -32615,8 +32632,8 @@
         </p:nvSpPr>
         <p:spPr>
           <a:xfrm>
-            <a:off x="9107424" y="2011680"/>
-            <a:ext cx="2532888" cy="1348740"/>
+            <a:off x="548640" y="4183380"/>
+            <a:ext cx="3483864" cy="1348740"/>
           </a:xfrm>
           <a:prstGeom prst="rect">
             <a:avLst/>
@@ -32631,67 +32648,31 @@
           <a:p>
             <a:pPr algn="l"/>
             <a:r>
-              <a:rPr sz="1300" b="0">
+              <a:rPr sz="1400" b="0">
                 <a:solidFill>
                   <a:srgbClr val="333333"/>
                 </a:solidFill>
                 <a:latin typeface="Arial"/>
               </a:rPr>
-              <a:t>Everything sits on a </a:t>
-            </a:r>
-            <a:r>
-              <a:rPr sz="1300" b="1">
+              <a:t>Four more models look at the </a:t>
+            </a:r>
+            <a:r>
+              <a:rPr sz="1400" b="1">
                 <a:solidFill>
                   <a:srgbClr val="000000"/>
                 </a:solidFill>
                 <a:latin typeface="Arial"/>
               </a:rPr>
-              <a:t>private network</a:t>
-            </a:r>
-            <a:r>
-              <a:rPr sz="1300" b="0">
+              <a:t>machine's history</a:t>
+            </a:r>
+            <a:r>
+              <a:rPr sz="1400" b="0">
                 <a:solidFill>
                   <a:srgbClr val="333333"/>
                 </a:solidFill>
                 <a:latin typeface="Arial"/>
               </a:rPr>
-              <a:t>. </a:t>
-            </a:r>
-            <a:r>
-              <a:rPr sz="1300" b="1">
-                <a:solidFill>
-                  <a:srgbClr val="000000"/>
-                </a:solidFill>
-                <a:latin typeface="Arial"/>
-              </a:rPr>
-              <a:t>Firewall rules</a:t>
-            </a:r>
-            <a:r>
-              <a:rPr sz="1300" b="0">
-                <a:solidFill>
-                  <a:srgbClr val="333333"/>
-                </a:solidFill>
-                <a:latin typeface="Arial"/>
-              </a:rPr>
-              <a:t> limit who talks to whom, and </a:t>
-            </a:r>
-            <a:r>
-              <a:rPr sz="1300" b="1">
-                <a:solidFill>
-                  <a:srgbClr val="000000"/>
-                </a:solidFill>
-                <a:latin typeface="Arial"/>
-              </a:rPr>
-              <a:t>no passwords</a:t>
-            </a:r>
-            <a:r>
-              <a:rPr sz="1300" b="0">
-                <a:solidFill>
-                  <a:srgbClr val="333333"/>
-                </a:solidFill>
-                <a:latin typeface="Arial"/>
-              </a:rPr>
-              <a:t> are stored to reach Azure.</a:t>
+              <a:t>: is the estimate realistic, how long can it keep running, is it far from its usual self, is it slowly getting worse?</a:t>
             </a:r>
           </a:p>
         </p:txBody>
@@ -32704,8 +32685,8 @@
         </p:nvSpPr>
         <p:spPr>
           <a:xfrm>
-            <a:off x="457200" y="3931920"/>
-            <a:ext cx="2715768" cy="1645920"/>
+            <a:off x="4261104" y="3931920"/>
+            <a:ext cx="3666744" cy="1645920"/>
           </a:xfrm>
           <a:prstGeom prst="roundRect">
             <a:avLst>
@@ -32750,8 +32731,8 @@
         </p:nvSpPr>
         <p:spPr>
           <a:xfrm>
-            <a:off x="672084" y="3726180"/>
-            <a:ext cx="2286000" cy="411480"/>
+            <a:off x="4722876" y="3726180"/>
+            <a:ext cx="2743200" cy="411480"/>
           </a:xfrm>
           <a:prstGeom prst="roundRect">
             <a:avLst>
@@ -32792,7 +32773,7 @@
                 </a:solidFill>
                 <a:latin typeface="Arial"/>
               </a:rPr>
-              <a:t>Managed by Azure</a:t>
+              <a:t>5 · DST fusion</a:t>
             </a:r>
           </a:p>
         </p:txBody>
@@ -32805,8 +32786,8 @@
         </p:nvSpPr>
         <p:spPr>
           <a:xfrm>
-            <a:off x="548640" y="4183380"/>
-            <a:ext cx="2532888" cy="1348740"/>
+            <a:off x="4352544" y="4183380"/>
+            <a:ext cx="3483864" cy="1348740"/>
           </a:xfrm>
           <a:prstGeom prst="rect">
             <a:avLst/>
@@ -32821,67 +32802,67 @@
           <a:p>
             <a:pPr algn="l"/>
             <a:r>
-              <a:rPr sz="1300" b="0">
+              <a:rPr sz="1400" b="0">
                 <a:solidFill>
                   <a:srgbClr val="333333"/>
                 </a:solidFill>
                 <a:latin typeface="Arial"/>
               </a:rPr>
-              <a:t>Azure runs the </a:t>
-            </a:r>
-            <a:r>
-              <a:rPr sz="1300" b="1">
+              <a:t>All the answers are </a:t>
+            </a:r>
+            <a:r>
+              <a:rPr sz="1400" b="1">
                 <a:solidFill>
                   <a:srgbClr val="000000"/>
                 </a:solidFill>
                 <a:latin typeface="Arial"/>
               </a:rPr>
-              <a:t>database</a:t>
-            </a:r>
-            <a:r>
-              <a:rPr sz="1300" b="0">
+              <a:t>weighed together</a:t>
+            </a:r>
+            <a:r>
+              <a:rPr sz="1400" b="0">
                 <a:solidFill>
                   <a:srgbClr val="333333"/>
                 </a:solidFill>
                 <a:latin typeface="Arial"/>
               </a:rPr>
-              <a:t> for us (backups, updates) and stores our </a:t>
-            </a:r>
-            <a:r>
-              <a:rPr sz="1300" b="1">
+              <a:t>. When they agree, the result is confident; when they </a:t>
+            </a:r>
+            <a:r>
+              <a:rPr sz="1400" b="1">
                 <a:solidFill>
                   <a:srgbClr val="000000"/>
                 </a:solidFill>
                 <a:latin typeface="Arial"/>
               </a:rPr>
-              <a:t>container images</a:t>
-            </a:r>
-            <a:r>
-              <a:rPr sz="1300" b="0">
+              <a:t>disagree</a:t>
+            </a:r>
+            <a:r>
+              <a:rPr sz="1400" b="0">
                 <a:solidFill>
                   <a:srgbClr val="333333"/>
                 </a:solidFill>
                 <a:latin typeface="Arial"/>
               </a:rPr>
-              <a:t>. Files are kept on a </a:t>
-            </a:r>
-            <a:r>
-              <a:rPr sz="1300" b="1">
+              <a:t>, it says </a:t>
+            </a:r>
+            <a:r>
+              <a:rPr sz="1400" b="1">
                 <a:solidFill>
                   <a:srgbClr val="000000"/>
                 </a:solidFill>
                 <a:latin typeface="Arial"/>
               </a:rPr>
-              <a:t>permanent disk</a:t>
-            </a:r>
-            <a:r>
-              <a:rPr sz="1300" b="0">
+              <a:t>"not sure"</a:t>
+            </a:r>
+            <a:r>
+              <a:rPr sz="1400" b="0">
                 <a:solidFill>
                   <a:srgbClr val="333333"/>
                 </a:solidFill>
                 <a:latin typeface="Arial"/>
               </a:rPr>
-              <a:t>.</a:t>
+              <a:t> instead of picking a side.</a:t>
             </a:r>
           </a:p>
         </p:txBody>
@@ -32894,8 +32875,8 @@
         </p:nvSpPr>
         <p:spPr>
           <a:xfrm>
-            <a:off x="3310128" y="3931920"/>
-            <a:ext cx="2715768" cy="1645920"/>
+            <a:off x="8065008" y="3931920"/>
+            <a:ext cx="3666744" cy="1645920"/>
           </a:xfrm>
           <a:prstGeom prst="roundRect">
             <a:avLst>
@@ -32940,8 +32921,8 @@
         </p:nvSpPr>
         <p:spPr>
           <a:xfrm>
-            <a:off x="3525012" y="3726180"/>
-            <a:ext cx="2286000" cy="411480"/>
+            <a:off x="8526780" y="3726180"/>
+            <a:ext cx="2743200" cy="411480"/>
           </a:xfrm>
           <a:prstGeom prst="roundRect">
             <a:avLst>
@@ -32982,7 +32963,7 @@
                 </a:solidFill>
                 <a:latin typeface="Arial"/>
               </a:rPr>
-              <a:t>Key Vault</a:t>
+              <a:t>6 · Health score</a:t>
             </a:r>
           </a:p>
         </p:txBody>
@@ -32995,8 +32976,8 @@
         </p:nvSpPr>
         <p:spPr>
           <a:xfrm>
-            <a:off x="3401568" y="4183380"/>
-            <a:ext cx="2532888" cy="1348740"/>
+            <a:off x="8156448" y="4183380"/>
+            <a:ext cx="3483864" cy="1348740"/>
           </a:xfrm>
           <a:prstGeom prst="rect">
             <a:avLst/>
@@ -33011,418 +32992,56 @@
           <a:p>
             <a:pPr algn="l"/>
             <a:r>
-              <a:rPr sz="1300" b="0">
+              <a:rPr sz="1400" b="0">
                 <a:solidFill>
                   <a:srgbClr val="333333"/>
                 </a:solidFill>
                 <a:latin typeface="Arial"/>
               </a:rPr>
-              <a:t>A </a:t>
-            </a:r>
-            <a:r>
-              <a:rPr sz="1300" b="1">
+              <a:t>The user sees </a:t>
+            </a:r>
+            <a:r>
+              <a:rPr sz="1400" b="1">
                 <a:solidFill>
                   <a:srgbClr val="000000"/>
                 </a:solidFill>
                 <a:latin typeface="Arial"/>
               </a:rPr>
-              <a:t>safe for secrets</a:t>
-            </a:r>
-            <a:r>
-              <a:rPr sz="1300" b="0">
+              <a:t>one score from 0 to 100</a:t>
+            </a:r>
+            <a:r>
+              <a:rPr sz="1400" b="0">
                 <a:solidFill>
                   <a:srgbClr val="333333"/>
                 </a:solidFill>
                 <a:latin typeface="Arial"/>
               </a:rPr>
-              <a:t> (passwords, API keys). They are handed to the app </a:t>
-            </a:r>
-            <a:r>
-              <a:rPr sz="1300" b="1">
+              <a:t> with a </a:t>
+            </a:r>
+            <a:r>
+              <a:rPr sz="1400" b="1">
                 <a:solidFill>
                   <a:srgbClr val="000000"/>
                 </a:solidFill>
                 <a:latin typeface="Arial"/>
               </a:rPr>
-              <a:t>when it starts</a:t>
-            </a:r>
-            <a:r>
-              <a:rPr sz="1300" b="0">
+              <a:t>plain-language verdict</a:t>
+            </a:r>
+            <a:r>
+              <a:rPr sz="1400" b="0">
                 <a:solidFill>
                   <a:srgbClr val="333333"/>
                 </a:solidFill>
                 <a:latin typeface="Arial"/>
               </a:rPr>
-              <a:t>, never written in the code.</a:t>
-            </a:r>
-          </a:p>
-        </p:txBody>
-      </p:sp>
-      <p:sp>
-        <p:nvSpPr>
-          <p:cNvPr id="24" name="Card 7"/>
-          <p:cNvSpPr/>
-          <p:nvPr/>
-        </p:nvSpPr>
-        <p:spPr>
-          <a:xfrm>
-            <a:off x="6163056" y="3931920"/>
-            <a:ext cx="2715768" cy="1645920"/>
-          </a:xfrm>
-          <a:prstGeom prst="roundRect">
-            <a:avLst>
-              <a:gd name="adj" fmla="val 12000"/>
-            </a:avLst>
-          </a:prstGeom>
-          <a:noFill/>
-          <a:ln w="25400">
-            <a:solidFill>
-              <a:srgbClr val="5B5243"/>
-            </a:solidFill>
-          </a:ln>
-          <a:effectLst/>
-        </p:spPr>
-        <p:style>
-          <a:lnRef idx="1">
-            <a:schemeClr val="accent1"/>
-          </a:lnRef>
-          <a:fillRef idx="3">
-            <a:schemeClr val="accent1"/>
-          </a:fillRef>
-          <a:effectRef idx="2">
-            <a:schemeClr val="accent1"/>
-          </a:effectRef>
-          <a:fontRef idx="minor">
-            <a:schemeClr val="lt1"/>
-          </a:fontRef>
-        </p:style>
-        <p:txBody>
-          <a:bodyPr rtlCol="0" anchor="ctr"/>
-          <a:lstStyle/>
-          <a:p>
-            <a:pPr algn="ctr"/>
-          </a:p>
-        </p:txBody>
-      </p:sp>
-      <p:sp>
-        <p:nvSpPr>
-          <p:cNvPr id="25" name="Chip 7"/>
-          <p:cNvSpPr/>
-          <p:nvPr/>
-        </p:nvSpPr>
-        <p:spPr>
-          <a:xfrm>
-            <a:off x="6377940" y="3726180"/>
-            <a:ext cx="2286000" cy="411480"/>
-          </a:xfrm>
-          <a:prstGeom prst="roundRect">
-            <a:avLst>
-              <a:gd name="adj" fmla="val 40000"/>
-            </a:avLst>
-          </a:prstGeom>
-          <a:solidFill>
-            <a:srgbClr val="FDE8E8"/>
-          </a:solidFill>
-          <a:ln>
-            <a:noFill/>
-          </a:ln>
-          <a:effectLst/>
-        </p:spPr>
-        <p:style>
-          <a:lnRef idx="1">
-            <a:schemeClr val="accent1"/>
-          </a:lnRef>
-          <a:fillRef idx="3">
-            <a:schemeClr val="accent1"/>
-          </a:fillRef>
-          <a:effectRef idx="2">
-            <a:schemeClr val="accent1"/>
-          </a:effectRef>
-          <a:fontRef idx="minor">
-            <a:schemeClr val="lt1"/>
-          </a:fontRef>
-        </p:style>
-        <p:txBody>
-          <a:bodyPr rtlCol="0" anchor="ctr" lIns="45720" rIns="45720"/>
-          <a:lstStyle/>
-          <a:p>
-            <a:pPr algn="ctr"/>
-            <a:r>
-              <a:rPr sz="1300" b="1">
-                <a:solidFill>
-                  <a:srgbClr val="000000"/>
-                </a:solidFill>
-                <a:latin typeface="Arial"/>
-              </a:rPr>
-              <a:t>ngrok tunnel</a:t>
-            </a:r>
-          </a:p>
-        </p:txBody>
-      </p:sp>
-      <p:sp>
-        <p:nvSpPr>
-          <p:cNvPr id="26" name="Card text 7"/>
-          <p:cNvSpPr txBox="1"/>
-          <p:nvPr/>
-        </p:nvSpPr>
-        <p:spPr>
-          <a:xfrm>
-            <a:off x="6254496" y="4183380"/>
-            <a:ext cx="2532888" cy="1348740"/>
-          </a:xfrm>
-          <a:prstGeom prst="rect">
-            <a:avLst/>
-          </a:prstGeom>
-          <a:noFill/>
-        </p:spPr>
-        <p:txBody>
-          <a:bodyPr wrap="square" lIns="45720" rIns="45720" tIns="18288" bIns="18288" anchor="ctr">
-            <a:spAutoFit/>
-          </a:bodyPr>
-          <a:lstStyle/>
-          <a:p>
-            <a:pPr algn="l"/>
-            <a:r>
-              <a:rPr sz="1300" b="0">
-                <a:solidFill>
-                  <a:srgbClr val="333333"/>
-                </a:solidFill>
-                <a:latin typeface="Arial"/>
-              </a:rPr>
-              <a:t>Azure's usual public entrance is </a:t>
-            </a:r>
-            <a:r>
-              <a:rPr sz="1300" b="1">
-                <a:solidFill>
-                  <a:srgbClr val="000000"/>
-                </a:solidFill>
-                <a:latin typeface="Arial"/>
-              </a:rPr>
-              <a:t>blocked on our account</a:t>
-            </a:r>
-            <a:r>
-              <a:rPr sz="1300" b="0">
-                <a:solidFill>
-                  <a:srgbClr val="333333"/>
-                </a:solidFill>
-                <a:latin typeface="Arial"/>
-              </a:rPr>
-              <a:t>, so a small service </a:t>
-            </a:r>
-            <a:r>
-              <a:rPr sz="1300" b="1">
-                <a:solidFill>
-                  <a:srgbClr val="000000"/>
-                </a:solidFill>
-                <a:latin typeface="Arial"/>
-              </a:rPr>
-              <a:t>connects out</a:t>
-            </a:r>
-            <a:r>
-              <a:rPr sz="1300" b="0">
-                <a:solidFill>
-                  <a:srgbClr val="333333"/>
-                </a:solidFill>
-                <a:latin typeface="Arial"/>
-              </a:rPr>
-              <a:t> to ngrok, which forwards visitors in.</a:t>
-            </a:r>
-          </a:p>
-        </p:txBody>
-      </p:sp>
-      <p:sp>
-        <p:nvSpPr>
-          <p:cNvPr id="27" name="Card 8"/>
-          <p:cNvSpPr/>
-          <p:nvPr/>
-        </p:nvSpPr>
-        <p:spPr>
-          <a:xfrm>
-            <a:off x="9015984" y="3931920"/>
-            <a:ext cx="2715768" cy="1645920"/>
-          </a:xfrm>
-          <a:prstGeom prst="roundRect">
-            <a:avLst>
-              <a:gd name="adj" fmla="val 12000"/>
-            </a:avLst>
-          </a:prstGeom>
-          <a:noFill/>
-          <a:ln w="25400">
-            <a:solidFill>
-              <a:srgbClr val="5B5243"/>
-            </a:solidFill>
-          </a:ln>
-          <a:effectLst/>
-        </p:spPr>
-        <p:style>
-          <a:lnRef idx="1">
-            <a:schemeClr val="accent1"/>
-          </a:lnRef>
-          <a:fillRef idx="3">
-            <a:schemeClr val="accent1"/>
-          </a:fillRef>
-          <a:effectRef idx="2">
-            <a:schemeClr val="accent1"/>
-          </a:effectRef>
-          <a:fontRef idx="minor">
-            <a:schemeClr val="lt1"/>
-          </a:fontRef>
-        </p:style>
-        <p:txBody>
-          <a:bodyPr rtlCol="0" anchor="ctr"/>
-          <a:lstStyle/>
-          <a:p>
-            <a:pPr algn="ctr"/>
-          </a:p>
-        </p:txBody>
-      </p:sp>
-      <p:sp>
-        <p:nvSpPr>
-          <p:cNvPr id="28" name="Chip 8"/>
-          <p:cNvSpPr/>
-          <p:nvPr/>
-        </p:nvSpPr>
-        <p:spPr>
-          <a:xfrm>
-            <a:off x="9230868" y="3726180"/>
-            <a:ext cx="2286000" cy="411480"/>
-          </a:xfrm>
-          <a:prstGeom prst="roundRect">
-            <a:avLst>
-              <a:gd name="adj" fmla="val 40000"/>
-            </a:avLst>
-          </a:prstGeom>
-          <a:solidFill>
-            <a:srgbClr val="FDE8E8"/>
-          </a:solidFill>
-          <a:ln>
-            <a:noFill/>
-          </a:ln>
-          <a:effectLst/>
-        </p:spPr>
-        <p:style>
-          <a:lnRef idx="1">
-            <a:schemeClr val="accent1"/>
-          </a:lnRef>
-          <a:fillRef idx="3">
-            <a:schemeClr val="accent1"/>
-          </a:fillRef>
-          <a:effectRef idx="2">
-            <a:schemeClr val="accent1"/>
-          </a:effectRef>
-          <a:fontRef idx="minor">
-            <a:schemeClr val="lt1"/>
-          </a:fontRef>
-        </p:style>
-        <p:txBody>
-          <a:bodyPr rtlCol="0" anchor="ctr" lIns="45720" rIns="45720"/>
-          <a:lstStyle/>
-          <a:p>
-            <a:pPr algn="ctr"/>
-            <a:r>
-              <a:rPr sz="1300" b="1">
-                <a:solidFill>
-                  <a:srgbClr val="000000"/>
-                </a:solidFill>
-                <a:latin typeface="Arial"/>
-              </a:rPr>
-              <a:t>Automated delivery</a:t>
-            </a:r>
-          </a:p>
-        </p:txBody>
-      </p:sp>
-      <p:sp>
-        <p:nvSpPr>
-          <p:cNvPr id="29" name="Card text 8"/>
-          <p:cNvSpPr txBox="1"/>
-          <p:nvPr/>
-        </p:nvSpPr>
-        <p:spPr>
-          <a:xfrm>
-            <a:off x="9107424" y="4183380"/>
-            <a:ext cx="2532888" cy="1348740"/>
-          </a:xfrm>
-          <a:prstGeom prst="rect">
-            <a:avLst/>
-          </a:prstGeom>
-          <a:noFill/>
-        </p:spPr>
-        <p:txBody>
-          <a:bodyPr wrap="square" lIns="45720" rIns="45720" tIns="18288" bIns="18288" anchor="ctr">
-            <a:spAutoFit/>
-          </a:bodyPr>
-          <a:lstStyle/>
-          <a:p>
-            <a:pPr algn="l"/>
-            <a:r>
-              <a:rPr sz="1300" b="0">
-                <a:solidFill>
-                  <a:srgbClr val="333333"/>
-                </a:solidFill>
-                <a:latin typeface="Arial"/>
-              </a:rPr>
-              <a:t>Every change is </a:t>
-            </a:r>
-            <a:r>
-              <a:rPr sz="1300" b="1">
-                <a:solidFill>
-                  <a:srgbClr val="000000"/>
-                </a:solidFill>
-                <a:latin typeface="Arial"/>
-              </a:rPr>
-              <a:t>checked for security</a:t>
-            </a:r>
-            <a:r>
-              <a:rPr sz="1300" b="0">
-                <a:solidFill>
-                  <a:srgbClr val="333333"/>
-                </a:solidFill>
-                <a:latin typeface="Arial"/>
-              </a:rPr>
-              <a:t>, then </a:t>
-            </a:r>
-            <a:r>
-              <a:rPr sz="1300" b="1">
-                <a:solidFill>
-                  <a:srgbClr val="000000"/>
-                </a:solidFill>
-                <a:latin typeface="Arial"/>
-              </a:rPr>
-              <a:t>built and deployed</a:t>
-            </a:r>
-            <a:r>
-              <a:rPr sz="1300" b="0">
-                <a:solidFill>
-                  <a:srgbClr val="333333"/>
-                </a:solidFill>
-                <a:latin typeface="Arial"/>
-              </a:rPr>
-              <a:t> automatically. The cloud setup is </a:t>
-            </a:r>
-            <a:r>
-              <a:rPr sz="1300" b="1">
-                <a:solidFill>
-                  <a:srgbClr val="000000"/>
-                </a:solidFill>
-                <a:latin typeface="Arial"/>
-              </a:rPr>
-              <a:t>written as code</a:t>
-            </a:r>
-            <a:r>
-              <a:rPr sz="1300" b="0">
-                <a:solidFill>
-                  <a:srgbClr val="333333"/>
-                </a:solidFill>
-                <a:latin typeface="Arial"/>
-              </a:rPr>
-              <a:t>, so it can be rebuilt anytime.</a:t>
-            </a:r>
-          </a:p>
-        </p:txBody>
-      </p:sp>
-      <p:sp>
-        <p:nvSpPr>
-          <p:cNvPr id="30" name="Key takeaway"/>
+              <a:t>: Healthy, Degrading, Critical or Unknown.</a:t>
+            </a:r>
+          </a:p>
+        </p:txBody>
+      </p:sp>
+      <p:sp>
+        <p:nvSpPr>
+          <p:cNvPr id="24" name="Key takeaway"/>
           <p:cNvSpPr txBox="1"/>
           <p:nvPr/>
         </p:nvSpPr>
@@ -33450,7 +33069,7 @@
                 </a:solidFill>
                 <a:latin typeface="Arial"/>
               </a:rPr>
-              <a:t>Versus Docker Compose:</a:t>
+              <a:t>Honest by design:</a:t>
             </a:r>
             <a:r>
               <a:rPr sz="1300" b="0">
@@ -33459,7 +33078,7 @@
                 </a:solidFill>
                 <a:latin typeface="Arial"/>
               </a:rPr>
-              <a:t> it repairs itself, grows with demand, keeps secrets in a vault, and can be rebuilt at any time.</a:t>
+              <a:t> a score is shown only when the evidence is confident, and every result is saved to check and retrain the models.</a:t>
             </a:r>
           </a:p>
         </p:txBody>
@@ -33583,7 +33202,7 @@
                 </a:solidFill>
                 <a:latin typeface="Arial Black"/>
               </a:rPr>
-              <a:t>Docker Compose Host: Key Concepts</a:t>
+              <a:t>Azure AKS: Key Concepts</a:t>
             </a:r>
           </a:p>
         </p:txBody>
@@ -33618,7 +33237,7 @@
                 </a:solidFill>
                 <a:latin typeface="Arial"/>
               </a:rPr>
-              <a:t>23</a:t>
+              <a:t>25</a:t>
             </a:r>
           </a:p>
         </p:txBody>
@@ -33632,7 +33251,7 @@
         <p:spPr>
           <a:xfrm>
             <a:off x="457200" y="1760220"/>
-            <a:ext cx="3666744" cy="1645920"/>
+            <a:ext cx="2715768" cy="1645920"/>
           </a:xfrm>
           <a:prstGeom prst="roundRect">
             <a:avLst>
@@ -33677,8 +33296,8 @@
         </p:nvSpPr>
         <p:spPr>
           <a:xfrm>
-            <a:off x="918972" y="1554480"/>
-            <a:ext cx="2743200" cy="411480"/>
+            <a:off x="672084" y="1554480"/>
+            <a:ext cx="2286000" cy="411480"/>
           </a:xfrm>
           <a:prstGeom prst="roundRect">
             <a:avLst>
@@ -33719,7 +33338,7 @@
                 </a:solidFill>
                 <a:latin typeface="Arial"/>
               </a:rPr>
-              <a:t>Containers</a:t>
+              <a:t>Kubernetes (AKS)</a:t>
             </a:r>
           </a:p>
         </p:txBody>
@@ -33733,7 +33352,7 @@
         <p:spPr>
           <a:xfrm>
             <a:off x="548640" y="2011680"/>
-            <a:ext cx="3483864" cy="1348740"/>
+            <a:ext cx="2532888" cy="1348740"/>
           </a:xfrm>
           <a:prstGeom prst="rect">
             <a:avLst/>
@@ -33748,49 +33367,67 @@
           <a:p>
             <a:pPr algn="l"/>
             <a:r>
-              <a:rPr sz="1400" b="0">
+              <a:rPr sz="1300" b="0">
                 <a:solidFill>
                   <a:srgbClr val="333333"/>
                 </a:solidFill>
                 <a:latin typeface="Arial"/>
               </a:rPr>
-              <a:t>Each part of the app runs in its own </a:t>
-            </a:r>
-            <a:r>
-              <a:rPr sz="1400" b="1">
+              <a:t>Runs our containers across </a:t>
+            </a:r>
+            <a:r>
+              <a:rPr sz="1300" b="1">
                 <a:solidFill>
                   <a:srgbClr val="000000"/>
                 </a:solidFill>
                 <a:latin typeface="Arial"/>
               </a:rPr>
-              <a:t>container</a:t>
-            </a:r>
-            <a:r>
-              <a:rPr sz="1400" b="0">
+              <a:t>several machines</a:t>
+            </a:r>
+            <a:r>
+              <a:rPr sz="1300" b="0">
                 <a:solidFill>
                   <a:srgbClr val="333333"/>
                 </a:solidFill>
                 <a:latin typeface="Arial"/>
               </a:rPr>
-              <a:t>: a sealed box holding the code and everything it needs. </a:t>
-            </a:r>
-            <a:r>
-              <a:rPr sz="1400" b="1">
+              <a:t>. A crashed service is </a:t>
+            </a:r>
+            <a:r>
+              <a:rPr sz="1300" b="1">
                 <a:solidFill>
                   <a:srgbClr val="000000"/>
                 </a:solidFill>
                 <a:latin typeface="Arial"/>
               </a:rPr>
-              <a:t>Docker Compose</a:t>
-            </a:r>
-            <a:r>
-              <a:rPr sz="1400" b="0">
+              <a:t>restarted automatically</a:t>
+            </a:r>
+            <a:r>
+              <a:rPr sz="1300" b="0">
                 <a:solidFill>
                   <a:srgbClr val="333333"/>
                 </a:solidFill>
                 <a:latin typeface="Arial"/>
               </a:rPr>
-              <a:t> starts all the boxes with one command.</a:t>
+              <a:t>, and capacity </a:t>
+            </a:r>
+            <a:r>
+              <a:rPr sz="1300" b="1">
+                <a:solidFill>
+                  <a:srgbClr val="000000"/>
+                </a:solidFill>
+                <a:latin typeface="Arial"/>
+              </a:rPr>
+              <a:t>grows with traffic</a:t>
+            </a:r>
+            <a:r>
+              <a:rPr sz="1300" b="0">
+                <a:solidFill>
+                  <a:srgbClr val="333333"/>
+                </a:solidFill>
+                <a:latin typeface="Arial"/>
+              </a:rPr>
+              <a:t>.</a:t>
             </a:r>
           </a:p>
         </p:txBody>
@@ -33803,8 +33440,8 @@
         </p:nvSpPr>
         <p:spPr>
           <a:xfrm>
-            <a:off x="4261104" y="1760220"/>
-            <a:ext cx="3666744" cy="1645920"/>
+            <a:off x="3310128" y="1760220"/>
+            <a:ext cx="2715768" cy="1645920"/>
           </a:xfrm>
           <a:prstGeom prst="roundRect">
             <a:avLst>
@@ -33849,8 +33486,8 @@
         </p:nvSpPr>
         <p:spPr>
           <a:xfrm>
-            <a:off x="4722876" y="1554480"/>
-            <a:ext cx="2743200" cy="411480"/>
+            <a:off x="3525012" y="1554480"/>
+            <a:ext cx="2286000" cy="411480"/>
           </a:xfrm>
           <a:prstGeom prst="roundRect">
             <a:avLst>
@@ -33891,7 +33528,7 @@
                 </a:solidFill>
                 <a:latin typeface="Arial"/>
               </a:rPr>
-              <a:t>Caddy: the front door</a:t>
+              <a:t>Node pools</a:t>
             </a:r>
           </a:p>
         </p:txBody>
@@ -33904,8 +33541,8 @@
         </p:nvSpPr>
         <p:spPr>
           <a:xfrm>
-            <a:off x="4352544" y="2011680"/>
-            <a:ext cx="3483864" cy="1348740"/>
+            <a:off x="3401568" y="2011680"/>
+            <a:ext cx="2532888" cy="1348740"/>
           </a:xfrm>
           <a:prstGeom prst="rect">
             <a:avLst/>
@@ -33920,49 +33557,67 @@
           <a:p>
             <a:pPr algn="l"/>
             <a:r>
-              <a:rPr sz="1400" b="0">
+              <a:rPr sz="1300" b="0">
                 <a:solidFill>
                   <a:srgbClr val="333333"/>
                 </a:solidFill>
                 <a:latin typeface="Arial"/>
               </a:rPr>
-              <a:t>The </a:t>
-            </a:r>
-            <a:r>
-              <a:rPr sz="1400" b="1">
+              <a:t>Two groups of machines: one for </a:t>
+            </a:r>
+            <a:r>
+              <a:rPr sz="1300" b="1">
                 <a:solidFill>
                   <a:srgbClr val="000000"/>
                 </a:solidFill>
                 <a:latin typeface="Arial"/>
               </a:rPr>
-              <a:t>only door</a:t>
-            </a:r>
-            <a:r>
-              <a:rPr sz="1400" b="0">
+              <a:t>Kubernetes itself</a:t>
+            </a:r>
+            <a:r>
+              <a:rPr sz="1300" b="0">
                 <a:solidFill>
                   <a:srgbClr val="333333"/>
                 </a:solidFill>
                 <a:latin typeface="Arial"/>
               </a:rPr>
-              <a:t> from the internet. It adds the </a:t>
-            </a:r>
-            <a:r>
-              <a:rPr sz="1400" b="1">
+              <a:t>, one for </a:t>
+            </a:r>
+            <a:r>
+              <a:rPr sz="1300" b="1">
                 <a:solidFill>
                   <a:srgbClr val="000000"/>
                 </a:solidFill>
                 <a:latin typeface="Arial"/>
               </a:rPr>
-              <a:t>HTTPS padlock</a:t>
-            </a:r>
-            <a:r>
-              <a:rPr sz="1400" b="0">
+              <a:t>our app</a:t>
+            </a:r>
+            <a:r>
+              <a:rPr sz="1300" b="0">
                 <a:solidFill>
                   <a:srgbClr val="333333"/>
                 </a:solidFill>
                 <a:latin typeface="Arial"/>
               </a:rPr>
-              <a:t> and sends each request to the right place: pages, data or dashboards.</a:t>
+              <a:t>, which grows from </a:t>
+            </a:r>
+            <a:r>
+              <a:rPr sz="1300" b="1">
+                <a:solidFill>
+                  <a:srgbClr val="000000"/>
+                </a:solidFill>
+                <a:latin typeface="Arial"/>
+              </a:rPr>
+              <a:t>2 to 4 machines</a:t>
+            </a:r>
+            <a:r>
+              <a:rPr sz="1300" b="0">
+                <a:solidFill>
+                  <a:srgbClr val="333333"/>
+                </a:solidFill>
+                <a:latin typeface="Arial"/>
+              </a:rPr>
+              <a:t> with demand.</a:t>
             </a:r>
           </a:p>
         </p:txBody>
@@ -33975,8 +33630,8 @@
         </p:nvSpPr>
         <p:spPr>
           <a:xfrm>
-            <a:off x="8065008" y="1760220"/>
-            <a:ext cx="3666744" cy="1645920"/>
+            <a:off x="6163056" y="1760220"/>
+            <a:ext cx="2715768" cy="1645920"/>
           </a:xfrm>
           <a:prstGeom prst="roundRect">
             <a:avLst>
@@ -34021,8 +33676,8 @@
         </p:nvSpPr>
         <p:spPr>
           <a:xfrm>
-            <a:off x="8526780" y="1554480"/>
-            <a:ext cx="2743200" cy="411480"/>
+            <a:off x="6377940" y="1554480"/>
+            <a:ext cx="2286000" cy="411480"/>
           </a:xfrm>
           <a:prstGeom prst="roundRect">
             <a:avLst>
@@ -34063,7 +33718,7 @@
                 </a:solidFill>
                 <a:latin typeface="Arial"/>
               </a:rPr>
-              <a:t>Private network</a:t>
+              <a:t>Staging &amp; production</a:t>
             </a:r>
           </a:p>
         </p:txBody>
@@ -34076,8 +33731,8 @@
         </p:nvSpPr>
         <p:spPr>
           <a:xfrm>
-            <a:off x="8156448" y="2011680"/>
-            <a:ext cx="3483864" cy="1348740"/>
+            <a:off x="6254496" y="2011680"/>
+            <a:ext cx="2532888" cy="1348740"/>
           </a:xfrm>
           <a:prstGeom prst="rect">
             <a:avLst/>
@@ -34092,49 +33747,49 @@
           <a:p>
             <a:pPr algn="l"/>
             <a:r>
-              <a:rPr sz="1400" b="0">
+              <a:rPr sz="1300" b="0">
                 <a:solidFill>
                   <a:srgbClr val="333333"/>
                 </a:solidFill>
                 <a:latin typeface="Arial"/>
               </a:rPr>
-              <a:t>The containers share a </a:t>
-            </a:r>
-            <a:r>
-              <a:rPr sz="1400" b="1">
+              <a:t>Two identical copies of the app: </a:t>
+            </a:r>
+            <a:r>
+              <a:rPr sz="1300" b="1">
                 <a:solidFill>
                   <a:srgbClr val="000000"/>
                 </a:solidFill>
                 <a:latin typeface="Arial"/>
               </a:rPr>
-              <a:t>private network</a:t>
-            </a:r>
-            <a:r>
-              <a:rPr sz="1400" b="0">
+              <a:t>staging</a:t>
+            </a:r>
+            <a:r>
+              <a:rPr sz="1300" b="0">
                 <a:solidFill>
                   <a:srgbClr val="333333"/>
                 </a:solidFill>
                 <a:latin typeface="Arial"/>
               </a:rPr>
-              <a:t> and find each other </a:t>
-            </a:r>
-            <a:r>
-              <a:rPr sz="1400" b="1">
+              <a:t> to test new versions, </a:t>
+            </a:r>
+            <a:r>
+              <a:rPr sz="1300" b="1">
                 <a:solidFill>
                   <a:srgbClr val="000000"/>
                 </a:solidFill>
                 <a:latin typeface="Arial"/>
               </a:rPr>
-              <a:t>by name</a:t>
-            </a:r>
-            <a:r>
-              <a:rPr sz="1400" b="0">
+              <a:t>production</a:t>
+            </a:r>
+            <a:r>
+              <a:rPr sz="1300" b="0">
                 <a:solidFill>
                   <a:srgbClr val="333333"/>
                 </a:solidFill>
                 <a:latin typeface="Arial"/>
               </a:rPr>
-              <a:t> (the backend simply calls "ml-service"), so nothing depends on fixed addresses.</a:t>
+              <a:t> for real users.</a:t>
             </a:r>
           </a:p>
         </p:txBody>
@@ -34147,8 +33802,8 @@
         </p:nvSpPr>
         <p:spPr>
           <a:xfrm>
-            <a:off x="457200" y="3931920"/>
-            <a:ext cx="3666744" cy="1645920"/>
+            <a:off x="9015984" y="1760220"/>
+            <a:ext cx="2715768" cy="1645920"/>
           </a:xfrm>
           <a:prstGeom prst="roundRect">
             <a:avLst>
@@ -34193,8 +33848,8 @@
         </p:nvSpPr>
         <p:spPr>
           <a:xfrm>
-            <a:off x="918972" y="3726180"/>
-            <a:ext cx="2743200" cy="411480"/>
+            <a:off x="9230868" y="1554480"/>
+            <a:ext cx="2286000" cy="411480"/>
           </a:xfrm>
           <a:prstGeom prst="roundRect">
             <a:avLst>
@@ -34235,7 +33890,7 @@
                 </a:solidFill>
                 <a:latin typeface="Arial"/>
               </a:rPr>
-              <a:t>Ports &amp; storage</a:t>
+              <a:t>Network security</a:t>
             </a:r>
           </a:p>
         </p:txBody>
@@ -34248,8 +33903,8 @@
         </p:nvSpPr>
         <p:spPr>
           <a:xfrm>
-            <a:off x="548640" y="4183380"/>
-            <a:ext cx="3483864" cy="1348740"/>
+            <a:off x="9107424" y="2011680"/>
+            <a:ext cx="2532888" cy="1348740"/>
           </a:xfrm>
           <a:prstGeom prst="rect">
             <a:avLst/>
@@ -34264,67 +33919,67 @@
           <a:p>
             <a:pPr algn="l"/>
             <a:r>
-              <a:rPr sz="1400" b="0">
+              <a:rPr sz="1300" b="0">
                 <a:solidFill>
                   <a:srgbClr val="333333"/>
                 </a:solidFill>
                 <a:latin typeface="Arial"/>
               </a:rPr>
-              <a:t>In development, each service is reachable on its own </a:t>
-            </a:r>
-            <a:r>
-              <a:rPr sz="1400" b="1">
+              <a:t>Everything sits on a </a:t>
+            </a:r>
+            <a:r>
+              <a:rPr sz="1300" b="1">
                 <a:solidFill>
                   <a:srgbClr val="000000"/>
                 </a:solidFill>
                 <a:latin typeface="Arial"/>
               </a:rPr>
-              <a:t>port</a:t>
-            </a:r>
-            <a:r>
-              <a:rPr sz="1400" b="0">
+              <a:t>private network</a:t>
+            </a:r>
+            <a:r>
+              <a:rPr sz="1300" b="0">
                 <a:solidFill>
                   <a:srgbClr val="333333"/>
                 </a:solidFill>
                 <a:latin typeface="Arial"/>
               </a:rPr>
-              <a:t> for easy debugging. Database data is </a:t>
-            </a:r>
-            <a:r>
-              <a:rPr sz="1400" b="1">
+              <a:t>. </a:t>
+            </a:r>
+            <a:r>
+              <a:rPr sz="1300" b="1">
                 <a:solidFill>
                   <a:srgbClr val="000000"/>
                 </a:solidFill>
                 <a:latin typeface="Arial"/>
               </a:rPr>
-              <a:t>saved on disk</a:t>
-            </a:r>
-            <a:r>
-              <a:rPr sz="1400" b="0">
+              <a:t>Firewall rules</a:t>
+            </a:r>
+            <a:r>
+              <a:rPr sz="1300" b="0">
                 <a:solidFill>
                   <a:srgbClr val="333333"/>
                 </a:solidFill>
                 <a:latin typeface="Arial"/>
               </a:rPr>
-              <a:t> and survives restarts; the AI models are </a:t>
-            </a:r>
-            <a:r>
-              <a:rPr sz="1400" b="1">
+              <a:t> limit who talks to whom, and </a:t>
+            </a:r>
+            <a:r>
+              <a:rPr sz="1300" b="1">
                 <a:solidFill>
                   <a:srgbClr val="000000"/>
                 </a:solidFill>
                 <a:latin typeface="Arial"/>
               </a:rPr>
-              <a:t>locked against changes</a:t>
-            </a:r>
-            <a:r>
-              <a:rPr sz="1400" b="0">
+              <a:t>no passwords</a:t>
+            </a:r>
+            <a:r>
+              <a:rPr sz="1300" b="0">
                 <a:solidFill>
                   <a:srgbClr val="333333"/>
                 </a:solidFill>
                 <a:latin typeface="Arial"/>
               </a:rPr>
-              <a:t>.</a:t>
+              <a:t> are stored to reach Azure.</a:t>
             </a:r>
           </a:p>
         </p:txBody>
@@ -34337,8 +33992,8 @@
         </p:nvSpPr>
         <p:spPr>
           <a:xfrm>
-            <a:off x="4261104" y="3931920"/>
-            <a:ext cx="3666744" cy="1645920"/>
+            <a:off x="457200" y="3931920"/>
+            <a:ext cx="2715768" cy="1645920"/>
           </a:xfrm>
           <a:prstGeom prst="roundRect">
             <a:avLst>
@@ -34383,8 +34038,8 @@
         </p:nvSpPr>
         <p:spPr>
           <a:xfrm>
-            <a:off x="4722876" y="3726180"/>
-            <a:ext cx="2743200" cy="411480"/>
+            <a:off x="672084" y="3726180"/>
+            <a:ext cx="2286000" cy="411480"/>
           </a:xfrm>
           <a:prstGeom prst="roundRect">
             <a:avLst>
@@ -34425,7 +34080,7 @@
                 </a:solidFill>
                 <a:latin typeface="Arial"/>
               </a:rPr>
-              <a:t>Monitoring</a:t>
+              <a:t>Managed by Azure</a:t>
             </a:r>
           </a:p>
         </p:txBody>
@@ -34438,8 +34093,8 @@
         </p:nvSpPr>
         <p:spPr>
           <a:xfrm>
-            <a:off x="4352544" y="4183380"/>
-            <a:ext cx="3483864" cy="1348740"/>
+            <a:off x="548640" y="4183380"/>
+            <a:ext cx="2532888" cy="1348740"/>
           </a:xfrm>
           <a:prstGeom prst="rect">
             <a:avLst/>
@@ -34454,67 +34109,67 @@
           <a:p>
             <a:pPr algn="l"/>
             <a:r>
-              <a:rPr sz="1400" b="0">
+              <a:rPr sz="1300" b="0">
                 <a:solidFill>
                   <a:srgbClr val="333333"/>
                 </a:solidFill>
                 <a:latin typeface="Arial"/>
               </a:rPr>
-              <a:t>A separate set of tools </a:t>
-            </a:r>
-            <a:r>
-              <a:rPr sz="1400" b="1">
+              <a:t>Azure runs the </a:t>
+            </a:r>
+            <a:r>
+              <a:rPr sz="1300" b="1">
                 <a:solidFill>
                   <a:srgbClr val="000000"/>
                 </a:solidFill>
                 <a:latin typeface="Arial"/>
               </a:rPr>
-              <a:t>watches the app</a:t>
-            </a:r>
-            <a:r>
-              <a:rPr sz="1400" b="0">
+              <a:t>database</a:t>
+            </a:r>
+            <a:r>
+              <a:rPr sz="1300" b="0">
                 <a:solidFill>
                   <a:srgbClr val="333333"/>
                 </a:solidFill>
                 <a:latin typeface="Arial"/>
               </a:rPr>
-              <a:t>: it collects performance numbers, shows them on </a:t>
-            </a:r>
-            <a:r>
-              <a:rPr sz="1400" b="1">
+              <a:t> for us (backups, updates) and stores our </a:t>
+            </a:r>
+            <a:r>
+              <a:rPr sz="1300" b="1">
                 <a:solidFill>
                   <a:srgbClr val="000000"/>
                 </a:solidFill>
                 <a:latin typeface="Arial"/>
               </a:rPr>
-              <a:t>dashboards</a:t>
-            </a:r>
-            <a:r>
-              <a:rPr sz="1400" b="0">
+              <a:t>container images</a:t>
+            </a:r>
+            <a:r>
+              <a:rPr sz="1300" b="0">
                 <a:solidFill>
                   <a:srgbClr val="333333"/>
                 </a:solidFill>
                 <a:latin typeface="Arial"/>
               </a:rPr>
-              <a:t>, and </a:t>
-            </a:r>
-            <a:r>
-              <a:rPr sz="1400" b="1">
+              <a:t>. Files are kept on a </a:t>
+            </a:r>
+            <a:r>
+              <a:rPr sz="1300" b="1">
                 <a:solidFill>
                   <a:srgbClr val="000000"/>
                 </a:solidFill>
                 <a:latin typeface="Arial"/>
               </a:rPr>
-              <a:t>scans the containers</a:t>
-            </a:r>
-            <a:r>
-              <a:rPr sz="1400" b="0">
+              <a:t>permanent disk</a:t>
+            </a:r>
+            <a:r>
+              <a:rPr sz="1300" b="0">
                 <a:solidFill>
                   <a:srgbClr val="333333"/>
                 </a:solidFill>
                 <a:latin typeface="Arial"/>
               </a:rPr>
-              <a:t> for known security flaws.</a:t>
+              <a:t>.</a:t>
             </a:r>
           </a:p>
         </p:txBody>
@@ -34527,8 +34182,8 @@
         </p:nvSpPr>
         <p:spPr>
           <a:xfrm>
-            <a:off x="8065008" y="3931920"/>
-            <a:ext cx="3666744" cy="1645920"/>
+            <a:off x="3310128" y="3931920"/>
+            <a:ext cx="2715768" cy="1645920"/>
           </a:xfrm>
           <a:prstGeom prst="roundRect">
             <a:avLst>
@@ -34573,8 +34228,8 @@
         </p:nvSpPr>
         <p:spPr>
           <a:xfrm>
-            <a:off x="8526780" y="3726180"/>
-            <a:ext cx="2743200" cy="411480"/>
+            <a:off x="3525012" y="3726180"/>
+            <a:ext cx="2286000" cy="411480"/>
           </a:xfrm>
           <a:prstGeom prst="roundRect">
             <a:avLst>
@@ -34615,7 +34270,7 @@
                 </a:solidFill>
                 <a:latin typeface="Arial"/>
               </a:rPr>
-              <a:t>Tools on demand</a:t>
+              <a:t>Key Vault</a:t>
             </a:r>
           </a:p>
         </p:txBody>
@@ -34628,8 +34283,8 @@
         </p:nvSpPr>
         <p:spPr>
           <a:xfrm>
-            <a:off x="8156448" y="4183380"/>
-            <a:ext cx="3483864" cy="1348740"/>
+            <a:off x="3401568" y="4183380"/>
+            <a:ext cx="2532888" cy="1348740"/>
           </a:xfrm>
           <a:prstGeom prst="rect">
             <a:avLst/>
@@ -34644,74 +34299,418 @@
           <a:p>
             <a:pPr algn="l"/>
             <a:r>
-              <a:rPr sz="1400" b="0">
+              <a:rPr sz="1300" b="0">
                 <a:solidFill>
                   <a:srgbClr val="333333"/>
                 </a:solidFill>
                 <a:latin typeface="Arial"/>
               </a:rPr>
-              <a:t>Some tools run </a:t>
-            </a:r>
-            <a:r>
-              <a:rPr sz="1400" b="1">
+              <a:t>A </a:t>
+            </a:r>
+            <a:r>
+              <a:rPr sz="1300" b="1">
                 <a:solidFill>
                   <a:srgbClr val="000000"/>
                 </a:solidFill>
                 <a:latin typeface="Arial"/>
               </a:rPr>
-              <a:t>only when needed</a:t>
-            </a:r>
-            <a:r>
-              <a:rPr sz="1400" b="0">
+              <a:t>safe for secrets</a:t>
+            </a:r>
+            <a:r>
+              <a:rPr sz="1300" b="0">
                 <a:solidFill>
                   <a:srgbClr val="333333"/>
                 </a:solidFill>
                 <a:latin typeface="Arial"/>
               </a:rPr>
-              <a:t>: a </a:t>
-            </a:r>
-            <a:r>
-              <a:rPr sz="1400" b="1">
+              <a:t> (passwords, API keys). They are handed to the app </a:t>
+            </a:r>
+            <a:r>
+              <a:rPr sz="1300" b="1">
                 <a:solidFill>
                   <a:srgbClr val="000000"/>
                 </a:solidFill>
                 <a:latin typeface="Arial"/>
               </a:rPr>
-              <a:t>code-quality checker</a:t>
-            </a:r>
-            <a:r>
-              <a:rPr sz="1400" b="0">
+              <a:t>when it starts</a:t>
+            </a:r>
+            <a:r>
+              <a:rPr sz="1300" b="0">
                 <a:solidFill>
                   <a:srgbClr val="333333"/>
                 </a:solidFill>
                 <a:latin typeface="Arial"/>
               </a:rPr>
-              <a:t> (SonarQube) and the </a:t>
-            </a:r>
-            <a:r>
-              <a:rPr sz="1400" b="1">
+              <a:t>, never written in the code.</a:t>
+            </a:r>
+          </a:p>
+        </p:txBody>
+      </p:sp>
+      <p:sp>
+        <p:nvSpPr>
+          <p:cNvPr id="24" name="Card 7"/>
+          <p:cNvSpPr/>
+          <p:nvPr/>
+        </p:nvSpPr>
+        <p:spPr>
+          <a:xfrm>
+            <a:off x="6163056" y="3931920"/>
+            <a:ext cx="2715768" cy="1645920"/>
+          </a:xfrm>
+          <a:prstGeom prst="roundRect">
+            <a:avLst>
+              <a:gd name="adj" fmla="val 12000"/>
+            </a:avLst>
+          </a:prstGeom>
+          <a:noFill/>
+          <a:ln w="25400">
+            <a:solidFill>
+              <a:srgbClr val="5B5243"/>
+            </a:solidFill>
+          </a:ln>
+          <a:effectLst/>
+        </p:spPr>
+        <p:style>
+          <a:lnRef idx="1">
+            <a:schemeClr val="accent1"/>
+          </a:lnRef>
+          <a:fillRef idx="3">
+            <a:schemeClr val="accent1"/>
+          </a:fillRef>
+          <a:effectRef idx="2">
+            <a:schemeClr val="accent1"/>
+          </a:effectRef>
+          <a:fontRef idx="minor">
+            <a:schemeClr val="lt1"/>
+          </a:fontRef>
+        </p:style>
+        <p:txBody>
+          <a:bodyPr rtlCol="0" anchor="ctr"/>
+          <a:lstStyle/>
+          <a:p>
+            <a:pPr algn="ctr"/>
+          </a:p>
+        </p:txBody>
+      </p:sp>
+      <p:sp>
+        <p:nvSpPr>
+          <p:cNvPr id="25" name="Chip 7"/>
+          <p:cNvSpPr/>
+          <p:nvPr/>
+        </p:nvSpPr>
+        <p:spPr>
+          <a:xfrm>
+            <a:off x="6377940" y="3726180"/>
+            <a:ext cx="2286000" cy="411480"/>
+          </a:xfrm>
+          <a:prstGeom prst="roundRect">
+            <a:avLst>
+              <a:gd name="adj" fmla="val 40000"/>
+            </a:avLst>
+          </a:prstGeom>
+          <a:solidFill>
+            <a:srgbClr val="FDE8E8"/>
+          </a:solidFill>
+          <a:ln>
+            <a:noFill/>
+          </a:ln>
+          <a:effectLst/>
+        </p:spPr>
+        <p:style>
+          <a:lnRef idx="1">
+            <a:schemeClr val="accent1"/>
+          </a:lnRef>
+          <a:fillRef idx="3">
+            <a:schemeClr val="accent1"/>
+          </a:fillRef>
+          <a:effectRef idx="2">
+            <a:schemeClr val="accent1"/>
+          </a:effectRef>
+          <a:fontRef idx="minor">
+            <a:schemeClr val="lt1"/>
+          </a:fontRef>
+        </p:style>
+        <p:txBody>
+          <a:bodyPr rtlCol="0" anchor="ctr" lIns="45720" rIns="45720"/>
+          <a:lstStyle/>
+          <a:p>
+            <a:pPr algn="ctr"/>
+            <a:r>
+              <a:rPr sz="1300" b="1">
                 <a:solidFill>
                   <a:srgbClr val="000000"/>
                 </a:solidFill>
                 <a:latin typeface="Arial"/>
               </a:rPr>
-              <a:t>notebooks</a:t>
-            </a:r>
-            <a:r>
-              <a:rPr sz="1400" b="0">
+              <a:t>ngrok tunnel</a:t>
+            </a:r>
+          </a:p>
+        </p:txBody>
+      </p:sp>
+      <p:sp>
+        <p:nvSpPr>
+          <p:cNvPr id="26" name="Card text 7"/>
+          <p:cNvSpPr txBox="1"/>
+          <p:nvPr/>
+        </p:nvSpPr>
+        <p:spPr>
+          <a:xfrm>
+            <a:off x="6254496" y="4183380"/>
+            <a:ext cx="2532888" cy="1348740"/>
+          </a:xfrm>
+          <a:prstGeom prst="rect">
+            <a:avLst/>
+          </a:prstGeom>
+          <a:noFill/>
+        </p:spPr>
+        <p:txBody>
+          <a:bodyPr wrap="square" lIns="45720" rIns="45720" tIns="18288" bIns="18288" anchor="ctr">
+            <a:spAutoFit/>
+          </a:bodyPr>
+          <a:lstStyle/>
+          <a:p>
+            <a:pPr algn="l"/>
+            <a:r>
+              <a:rPr sz="1300" b="0">
                 <a:solidFill>
                   <a:srgbClr val="333333"/>
                 </a:solidFill>
                 <a:latin typeface="Arial"/>
               </a:rPr>
-              <a:t> where the AI models were researched (Jupyter).</a:t>
-            </a:r>
-          </a:p>
-        </p:txBody>
-      </p:sp>
-      <p:sp>
-        <p:nvSpPr>
-          <p:cNvPr id="24" name="Key takeaway"/>
+              <a:t>Azure's usual public entrance is </a:t>
+            </a:r>
+            <a:r>
+              <a:rPr sz="1300" b="1">
+                <a:solidFill>
+                  <a:srgbClr val="000000"/>
+                </a:solidFill>
+                <a:latin typeface="Arial"/>
+              </a:rPr>
+              <a:t>blocked on our account</a:t>
+            </a:r>
+            <a:r>
+              <a:rPr sz="1300" b="0">
+                <a:solidFill>
+                  <a:srgbClr val="333333"/>
+                </a:solidFill>
+                <a:latin typeface="Arial"/>
+              </a:rPr>
+              <a:t>, so a small service </a:t>
+            </a:r>
+            <a:r>
+              <a:rPr sz="1300" b="1">
+                <a:solidFill>
+                  <a:srgbClr val="000000"/>
+                </a:solidFill>
+                <a:latin typeface="Arial"/>
+              </a:rPr>
+              <a:t>connects out</a:t>
+            </a:r>
+            <a:r>
+              <a:rPr sz="1300" b="0">
+                <a:solidFill>
+                  <a:srgbClr val="333333"/>
+                </a:solidFill>
+                <a:latin typeface="Arial"/>
+              </a:rPr>
+              <a:t> to ngrok, which forwards visitors in.</a:t>
+            </a:r>
+          </a:p>
+        </p:txBody>
+      </p:sp>
+      <p:sp>
+        <p:nvSpPr>
+          <p:cNvPr id="27" name="Card 8"/>
+          <p:cNvSpPr/>
+          <p:nvPr/>
+        </p:nvSpPr>
+        <p:spPr>
+          <a:xfrm>
+            <a:off x="9015984" y="3931920"/>
+            <a:ext cx="2715768" cy="1645920"/>
+          </a:xfrm>
+          <a:prstGeom prst="roundRect">
+            <a:avLst>
+              <a:gd name="adj" fmla="val 12000"/>
+            </a:avLst>
+          </a:prstGeom>
+          <a:noFill/>
+          <a:ln w="25400">
+            <a:solidFill>
+              <a:srgbClr val="5B5243"/>
+            </a:solidFill>
+          </a:ln>
+          <a:effectLst/>
+        </p:spPr>
+        <p:style>
+          <a:lnRef idx="1">
+            <a:schemeClr val="accent1"/>
+          </a:lnRef>
+          <a:fillRef idx="3">
+            <a:schemeClr val="accent1"/>
+          </a:fillRef>
+          <a:effectRef idx="2">
+            <a:schemeClr val="accent1"/>
+          </a:effectRef>
+          <a:fontRef idx="minor">
+            <a:schemeClr val="lt1"/>
+          </a:fontRef>
+        </p:style>
+        <p:txBody>
+          <a:bodyPr rtlCol="0" anchor="ctr"/>
+          <a:lstStyle/>
+          <a:p>
+            <a:pPr algn="ctr"/>
+          </a:p>
+        </p:txBody>
+      </p:sp>
+      <p:sp>
+        <p:nvSpPr>
+          <p:cNvPr id="28" name="Chip 8"/>
+          <p:cNvSpPr/>
+          <p:nvPr/>
+        </p:nvSpPr>
+        <p:spPr>
+          <a:xfrm>
+            <a:off x="9230868" y="3726180"/>
+            <a:ext cx="2286000" cy="411480"/>
+          </a:xfrm>
+          <a:prstGeom prst="roundRect">
+            <a:avLst>
+              <a:gd name="adj" fmla="val 40000"/>
+            </a:avLst>
+          </a:prstGeom>
+          <a:solidFill>
+            <a:srgbClr val="FDE8E8"/>
+          </a:solidFill>
+          <a:ln>
+            <a:noFill/>
+          </a:ln>
+          <a:effectLst/>
+        </p:spPr>
+        <p:style>
+          <a:lnRef idx="1">
+            <a:schemeClr val="accent1"/>
+          </a:lnRef>
+          <a:fillRef idx="3">
+            <a:schemeClr val="accent1"/>
+          </a:fillRef>
+          <a:effectRef idx="2">
+            <a:schemeClr val="accent1"/>
+          </a:effectRef>
+          <a:fontRef idx="minor">
+            <a:schemeClr val="lt1"/>
+          </a:fontRef>
+        </p:style>
+        <p:txBody>
+          <a:bodyPr rtlCol="0" anchor="ctr" lIns="45720" rIns="45720"/>
+          <a:lstStyle/>
+          <a:p>
+            <a:pPr algn="ctr"/>
+            <a:r>
+              <a:rPr sz="1300" b="1">
+                <a:solidFill>
+                  <a:srgbClr val="000000"/>
+                </a:solidFill>
+                <a:latin typeface="Arial"/>
+              </a:rPr>
+              <a:t>Automated delivery</a:t>
+            </a:r>
+          </a:p>
+        </p:txBody>
+      </p:sp>
+      <p:sp>
+        <p:nvSpPr>
+          <p:cNvPr id="29" name="Card text 8"/>
+          <p:cNvSpPr txBox="1"/>
+          <p:nvPr/>
+        </p:nvSpPr>
+        <p:spPr>
+          <a:xfrm>
+            <a:off x="9107424" y="4183380"/>
+            <a:ext cx="2532888" cy="1348740"/>
+          </a:xfrm>
+          <a:prstGeom prst="rect">
+            <a:avLst/>
+          </a:prstGeom>
+          <a:noFill/>
+        </p:spPr>
+        <p:txBody>
+          <a:bodyPr wrap="square" lIns="45720" rIns="45720" tIns="18288" bIns="18288" anchor="ctr">
+            <a:spAutoFit/>
+          </a:bodyPr>
+          <a:lstStyle/>
+          <a:p>
+            <a:pPr algn="l"/>
+            <a:r>
+              <a:rPr sz="1300" b="0">
+                <a:solidFill>
+                  <a:srgbClr val="333333"/>
+                </a:solidFill>
+                <a:latin typeface="Arial"/>
+              </a:rPr>
+              <a:t>Every change is </a:t>
+            </a:r>
+            <a:r>
+              <a:rPr sz="1300" b="1">
+                <a:solidFill>
+                  <a:srgbClr val="000000"/>
+                </a:solidFill>
+                <a:latin typeface="Arial"/>
+              </a:rPr>
+              <a:t>checked for security</a:t>
+            </a:r>
+            <a:r>
+              <a:rPr sz="1300" b="0">
+                <a:solidFill>
+                  <a:srgbClr val="333333"/>
+                </a:solidFill>
+                <a:latin typeface="Arial"/>
+              </a:rPr>
+              <a:t>, then </a:t>
+            </a:r>
+            <a:r>
+              <a:rPr sz="1300" b="1">
+                <a:solidFill>
+                  <a:srgbClr val="000000"/>
+                </a:solidFill>
+                <a:latin typeface="Arial"/>
+              </a:rPr>
+              <a:t>built and deployed</a:t>
+            </a:r>
+            <a:r>
+              <a:rPr sz="1300" b="0">
+                <a:solidFill>
+                  <a:srgbClr val="333333"/>
+                </a:solidFill>
+                <a:latin typeface="Arial"/>
+              </a:rPr>
+              <a:t> automatically. The cloud setup is </a:t>
+            </a:r>
+            <a:r>
+              <a:rPr sz="1300" b="1">
+                <a:solidFill>
+                  <a:srgbClr val="000000"/>
+                </a:solidFill>
+                <a:latin typeface="Arial"/>
+              </a:rPr>
+              <a:t>written as code</a:t>
+            </a:r>
+            <a:r>
+              <a:rPr sz="1300" b="0">
+                <a:solidFill>
+                  <a:srgbClr val="333333"/>
+                </a:solidFill>
+                <a:latin typeface="Arial"/>
+              </a:rPr>
+              <a:t>, so it can be rebuilt anytime.</a:t>
+            </a:r>
+          </a:p>
+        </p:txBody>
+      </p:sp>
+      <p:sp>
+        <p:nvSpPr>
+          <p:cNvPr id="30" name="Key takeaway"/>
           <p:cNvSpPr txBox="1"/>
           <p:nvPr/>
         </p:nvSpPr>
@@ -34739,7 +34738,7 @@
                 </a:solidFill>
                 <a:latin typeface="Arial"/>
               </a:rPr>
-              <a:t>Dev vs demo:</a:t>
+              <a:t>Versus Docker Compose:</a:t>
             </a:r>
             <a:r>
               <a:rPr sz="1300" b="0">
@@ -34748,7 +34747,7 @@
                 </a:solidFill>
                 <a:latin typeface="Arial"/>
               </a:rPr>
-              <a:t> in development every service is reachable; in the demo only Caddy is, so there is one secure way in.</a:t>
+              <a:t> it repairs itself, grows with demand, keeps secrets in a vault, and can be rebuilt at any time.</a:t>
             </a:r>
           </a:p>
         </p:txBody>
@@ -34801,7 +34800,7 @@
                 </a:solidFill>
                 <a:latin typeface="Arial"/>
               </a:rPr>
-              <a:t>04. Design: Logical Architecture</a:t>
+              <a:t>04. Design: Physical Architecture</a:t>
             </a:r>
           </a:p>
         </p:txBody>
@@ -34872,7 +34871,7 @@
                 </a:solidFill>
                 <a:latin typeface="Arial Black"/>
               </a:rPr>
-              <a:t>Request Flow: Step by Step</a:t>
+              <a:t>Docker Compose Host: Key Concepts</a:t>
             </a:r>
           </a:p>
         </p:txBody>
@@ -34907,7 +34906,7 @@
                 </a:solidFill>
                 <a:latin typeface="Arial"/>
               </a:rPr>
-              <a:t>21</a:t>
+              <a:t>23</a:t>
             </a:r>
           </a:p>
         </p:txBody>
@@ -35008,7 +35007,7 @@
                 </a:solidFill>
                 <a:latin typeface="Arial"/>
               </a:rPr>
-              <a:t>1 · Frontend asks</a:t>
+              <a:t>Containers</a:t>
             </a:r>
           </a:p>
         </p:txBody>
@@ -35043,7 +35042,7 @@
                 </a:solidFill>
                 <a:latin typeface="Arial"/>
               </a:rPr>
-              <a:t>When someone opens a machine's health panel, the browser </a:t>
+              <a:t>Each part of the app runs in its own </a:t>
             </a:r>
             <a:r>
               <a:rPr sz="1400" b="1">
@@ -35052,7 +35051,7 @@
                 </a:solidFill>
                 <a:latin typeface="Arial"/>
               </a:rPr>
-              <a:t>asks the backend</a:t>
+              <a:t>container</a:t>
             </a:r>
             <a:r>
               <a:rPr sz="1400" b="0">
@@ -35061,7 +35060,7 @@
                 </a:solidFill>
                 <a:latin typeface="Arial"/>
               </a:rPr>
-              <a:t> for that machine's health, sending the user's </a:t>
+              <a:t>: a sealed box holding the code and everything it needs. </a:t>
             </a:r>
             <a:r>
               <a:rPr sz="1400" b="1">
@@ -35070,7 +35069,7 @@
                 </a:solidFill>
                 <a:latin typeface="Arial"/>
               </a:rPr>
-              <a:t>login token</a:t>
+              <a:t>Docker Compose</a:t>
             </a:r>
             <a:r>
               <a:rPr sz="1400" b="0">
@@ -35079,7 +35078,7 @@
                 </a:solidFill>
                 <a:latin typeface="Arial"/>
               </a:rPr>
-              <a:t> with the request.</a:t>
+              <a:t> starts all the boxes with one command.</a:t>
             </a:r>
           </a:p>
         </p:txBody>
@@ -35180,7 +35179,7 @@
                 </a:solidFill>
                 <a:latin typeface="Arial"/>
               </a:rPr>
-              <a:t>2 · Backend reads telemetry</a:t>
+              <a:t>Caddy: the front door</a:t>
             </a:r>
           </a:p>
         </p:txBody>
@@ -35215,7 +35214,7 @@
                 </a:solidFill>
                 <a:latin typeface="Arial"/>
               </a:rPr>
-              <a:t>The backend fetches the machine's </a:t>
+              <a:t>The </a:t>
             </a:r>
             <a:r>
               <a:rPr sz="1400" b="1">
@@ -35224,7 +35223,7 @@
                 </a:solidFill>
                 <a:latin typeface="Arial"/>
               </a:rPr>
-              <a:t>latest sensor readings</a:t>
+              <a:t>only door</a:t>
             </a:r>
             <a:r>
               <a:rPr sz="1400" b="0">
@@ -35233,7 +35232,7 @@
                 </a:solidFill>
                 <a:latin typeface="Arial"/>
               </a:rPr>
-              <a:t> (temperatures, speed, torque, tool wear). If there are none, it </a:t>
+              <a:t> from the internet. It adds the </a:t>
             </a:r>
             <a:r>
               <a:rPr sz="1400" b="1">
@@ -35242,7 +35241,7 @@
                 </a:solidFill>
                 <a:latin typeface="Arial"/>
               </a:rPr>
-              <a:t>stops here</a:t>
+              <a:t>HTTPS padlock</a:t>
             </a:r>
             <a:r>
               <a:rPr sz="1400" b="0">
@@ -35251,7 +35250,7 @@
                 </a:solidFill>
                 <a:latin typeface="Arial"/>
               </a:rPr>
-              <a:t> and calls no model.</a:t>
+              <a:t> and sends each request to the right place: pages, data or dashboards.</a:t>
             </a:r>
           </a:p>
         </p:txBody>
@@ -35352,7 +35351,7 @@
                 </a:solidFill>
                 <a:latin typeface="Arial"/>
               </a:rPr>
-              <a:t>3 · ML microservice</a:t>
+              <a:t>Private network</a:t>
             </a:r>
           </a:p>
         </p:txBody>
@@ -35387,7 +35386,7 @@
                 </a:solidFill>
                 <a:latin typeface="Arial"/>
               </a:rPr>
-              <a:t>The ML service runs </a:t>
+              <a:t>The containers share a </a:t>
             </a:r>
             <a:r>
               <a:rPr sz="1400" b="1">
@@ -35396,7 +35395,7 @@
                 </a:solidFill>
                 <a:latin typeface="Arial"/>
               </a:rPr>
-              <a:t>seven models at once</a:t>
+              <a:t>private network</a:t>
             </a:r>
             <a:r>
               <a:rPr sz="1400" b="0">
@@ -35405,7 +35404,25 @@
                 </a:solidFill>
                 <a:latin typeface="Arial"/>
               </a:rPr>
-              <a:t> on those readings: failure chance, failure type, remaining life, odd behavior, urgency, best timing, parts needed.</a:t>
+              <a:t> and find each other </a:t>
+            </a:r>
+            <a:r>
+              <a:rPr sz="1400" b="1">
+                <a:solidFill>
+                  <a:srgbClr val="000000"/>
+                </a:solidFill>
+                <a:latin typeface="Arial"/>
+              </a:rPr>
+              <a:t>by name</a:t>
+            </a:r>
+            <a:r>
+              <a:rPr sz="1400" b="0">
+                <a:solidFill>
+                  <a:srgbClr val="333333"/>
+                </a:solidFill>
+                <a:latin typeface="Arial"/>
+              </a:rPr>
+              <a:t> (the backend simply calls "ml-service"), so nothing depends on fixed addresses.</a:t>
             </a:r>
           </a:p>
         </p:txBody>
@@ -35506,7 +35523,7 @@
                 </a:solidFill>
                 <a:latin typeface="Arial"/>
               </a:rPr>
-              <a:t>4 · Wave 2 signals</a:t>
+              <a:t>Ports &amp; storage</a:t>
             </a:r>
           </a:p>
         </p:txBody>
@@ -35541,7 +35558,7 @@
                 </a:solidFill>
                 <a:latin typeface="Arial"/>
               </a:rPr>
-              <a:t>A second group of models studies the machine's </a:t>
+              <a:t>In development, each service is reachable on its own </a:t>
             </a:r>
             <a:r>
               <a:rPr sz="1400" b="1">
@@ -35550,7 +35567,7 @@
                 </a:solidFill>
                 <a:latin typeface="Arial"/>
               </a:rPr>
-              <a:t>past readings</a:t>
+              <a:t>port</a:t>
             </a:r>
             <a:r>
               <a:rPr sz="1400" b="0">
@@ -35559,7 +35576,7 @@
                 </a:solidFill>
                 <a:latin typeface="Arial"/>
               </a:rPr>
-              <a:t>. They catch a </a:t>
+              <a:t> for easy debugging. Database data is </a:t>
             </a:r>
             <a:r>
               <a:rPr sz="1400" b="1">
@@ -35568,7 +35585,7 @@
                 </a:solidFill>
                 <a:latin typeface="Arial"/>
               </a:rPr>
-              <a:t>slow decline over time</a:t>
+              <a:t>saved on disk</a:t>
             </a:r>
             <a:r>
               <a:rPr sz="1400" b="0">
@@ -35577,7 +35594,7 @@
                 </a:solidFill>
                 <a:latin typeface="Arial"/>
               </a:rPr>
-              <a:t>, estimate how long it can </a:t>
+              <a:t> and survives restarts; the AI models are </a:t>
             </a:r>
             <a:r>
               <a:rPr sz="1400" b="1">
@@ -35586,25 +35603,7 @@
                 </a:solidFill>
                 <a:latin typeface="Arial"/>
               </a:rPr>
-              <a:t>keep running</a:t>
-            </a:r>
-            <a:r>
-              <a:rPr sz="1400" b="0">
-                <a:solidFill>
-                  <a:srgbClr val="333333"/>
-                </a:solidFill>
-                <a:latin typeface="Arial"/>
-              </a:rPr>
-              <a:t>, and spot when it </a:t>
-            </a:r>
-            <a:r>
-              <a:rPr sz="1400" b="1">
-                <a:solidFill>
-                  <a:srgbClr val="000000"/>
-                </a:solidFill>
-                <a:latin typeface="Arial"/>
-              </a:rPr>
-              <a:t>drifts from its usual behavior</a:t>
+              <a:t>locked against changes</a:t>
             </a:r>
             <a:r>
               <a:rPr sz="1400" b="0">
@@ -35714,7 +35713,7 @@
                 </a:solidFill>
                 <a:latin typeface="Arial"/>
               </a:rPr>
-              <a:t>5 · DST fusion</a:t>
+              <a:t>Monitoring</a:t>
             </a:r>
           </a:p>
         </p:txBody>
@@ -35749,7 +35748,7 @@
                 </a:solidFill>
                 <a:latin typeface="Arial"/>
               </a:rPr>
-              <a:t>All the opinions are </a:t>
+              <a:t>A separate set of tools </a:t>
             </a:r>
             <a:r>
               <a:rPr sz="1400" b="1">
@@ -35758,7 +35757,7 @@
                 </a:solidFill>
                 <a:latin typeface="Arial"/>
               </a:rPr>
-              <a:t>combined into one health score</a:t>
+              <a:t>watches the app</a:t>
             </a:r>
             <a:r>
               <a:rPr sz="1400" b="0">
@@ -35767,7 +35766,7 @@
                 </a:solidFill>
                 <a:latin typeface="Arial"/>
               </a:rPr>
-              <a:t> (0 to 100) and a verdict: Healthy, Degrading, Critical or </a:t>
+              <a:t>: it collects performance numbers, shows them on </a:t>
             </a:r>
             <a:r>
               <a:rPr sz="1400" b="1">
@@ -35776,7 +35775,7 @@
                 </a:solidFill>
                 <a:latin typeface="Arial"/>
               </a:rPr>
-              <a:t>Unknown</a:t>
+              <a:t>dashboards</a:t>
             </a:r>
             <a:r>
               <a:rPr sz="1400" b="0">
@@ -35785,7 +35784,25 @@
                 </a:solidFill>
                 <a:latin typeface="Arial"/>
               </a:rPr>
-              <a:t>. If the models strongly disagree, it says Unknown instead of guessing.</a:t>
+              <a:t>, and </a:t>
+            </a:r>
+            <a:r>
+              <a:rPr sz="1400" b="1">
+                <a:solidFill>
+                  <a:srgbClr val="000000"/>
+                </a:solidFill>
+                <a:latin typeface="Arial"/>
+              </a:rPr>
+              <a:t>scans the containers</a:t>
+            </a:r>
+            <a:r>
+              <a:rPr sz="1400" b="0">
+                <a:solidFill>
+                  <a:srgbClr val="333333"/>
+                </a:solidFill>
+                <a:latin typeface="Arial"/>
+              </a:rPr>
+              <a:t> for known security flaws.</a:t>
             </a:r>
           </a:p>
         </p:txBody>
@@ -35886,7 +35903,7 @@
                 </a:solidFill>
                 <a:latin typeface="Arial"/>
               </a:rPr>
-              <a:t>6 · Log &amp; render</a:t>
+              <a:t>Tools on demand</a:t>
             </a:r>
           </a:p>
         </p:txBody>
@@ -35921,7 +35938,7 @@
                 </a:solidFill>
                 <a:latin typeface="Arial"/>
               </a:rPr>
-              <a:t>The result is </a:t>
+              <a:t>Some tools run </a:t>
             </a:r>
             <a:r>
               <a:rPr sz="1400" b="1">
@@ -35930,7 +35947,7 @@
                 </a:solidFill>
                 <a:latin typeface="Arial"/>
               </a:rPr>
-              <a:t>saved</a:t>
+              <a:t>only when needed</a:t>
             </a:r>
             <a:r>
               <a:rPr sz="1400" b="0">
@@ -35939,7 +35956,7 @@
                 </a:solidFill>
                 <a:latin typeface="Arial"/>
               </a:rPr>
-              <a:t>, so every prediction can be checked later against what really happened. Then the </a:t>
+              <a:t>: a </a:t>
             </a:r>
             <a:r>
               <a:rPr sz="1400" b="1">
@@ -35948,7 +35965,7 @@
                 </a:solidFill>
                 <a:latin typeface="Arial"/>
               </a:rPr>
-              <a:t>panel updates</a:t>
+              <a:t>code-quality checker</a:t>
             </a:r>
             <a:r>
               <a:rPr sz="1400" b="0">
@@ -35957,7 +35974,25 @@
                 </a:solidFill>
                 <a:latin typeface="Arial"/>
               </a:rPr>
-              <a:t> on screen.</a:t>
+              <a:t> (SonarQube) and the </a:t>
+            </a:r>
+            <a:r>
+              <a:rPr sz="1400" b="1">
+                <a:solidFill>
+                  <a:srgbClr val="000000"/>
+                </a:solidFill>
+                <a:latin typeface="Arial"/>
+              </a:rPr>
+              <a:t>notebooks</a:t>
+            </a:r>
+            <a:r>
+              <a:rPr sz="1400" b="0">
+                <a:solidFill>
+                  <a:srgbClr val="333333"/>
+                </a:solidFill>
+                <a:latin typeface="Arial"/>
+              </a:rPr>
+              <a:t> where the AI models were researched (Jupyter).</a:t>
             </a:r>
           </a:p>
         </p:txBody>
@@ -35992,7 +36027,7 @@
                 </a:solidFill>
                 <a:latin typeface="Arial"/>
               </a:rPr>
-              <a:t>No data, no guessing:</a:t>
+              <a:t>Dev vs demo:</a:t>
             </a:r>
             <a:r>
               <a:rPr sz="1300" b="0">
@@ -36001,7 +36036,7 @@
                 </a:solidFill>
                 <a:latin typeface="Arial"/>
               </a:rPr>
-              <a:t> without sensor readings, the score comes from maintenance history only, never from invented values.</a:t>
+              <a:t> in development every service is reachable; in the demo only Caddy is, so there is one secure way in.</a:t>
             </a:r>
           </a:p>
         </p:txBody>
@@ -36015,6 +36050,1259 @@
 </file>
 
 <file path=ppt/slides/slide38.xml><?xml version="1.0" encoding="utf-8"?>
+<p:sld xmlns:a="http://schemas.openxmlformats.org/drawingml/2006/main" xmlns:p="http://schemas.openxmlformats.org/presentationml/2006/main" xmlns:r="http://schemas.openxmlformats.org/officeDocument/2006/relationships">
+  <p:cSld>
+    <p:spTree>
+      <p:nvGrpSpPr>
+        <p:cNvPr id="1" name=""/>
+        <p:cNvGrpSpPr/>
+        <p:nvPr/>
+      </p:nvGrpSpPr>
+      <p:grpSpPr/>
+      <p:sp>
+        <p:nvSpPr>
+          <p:cNvPr id="2" name="Section label"/>
+          <p:cNvSpPr txBox="1"/>
+          <p:nvPr/>
+        </p:nvSpPr>
+        <p:spPr>
+          <a:xfrm>
+            <a:off x="457200" y="201168"/>
+            <a:ext cx="8229600" cy="365760"/>
+          </a:xfrm>
+          <a:prstGeom prst="rect">
+            <a:avLst/>
+          </a:prstGeom>
+          <a:noFill/>
+        </p:spPr>
+        <p:txBody>
+          <a:bodyPr wrap="square" lIns="45720" rIns="45720" tIns="18288" bIns="18288" anchor="ctr">
+            <a:spAutoFit/>
+          </a:bodyPr>
+          <a:lstStyle/>
+          <a:p>
+            <a:pPr algn="l"/>
+            <a:r>
+              <a:rPr sz="1400" b="1" spc="200">
+                <a:solidFill>
+                  <a:srgbClr val="D0101A"/>
+                </a:solidFill>
+                <a:latin typeface="Arial"/>
+              </a:rPr>
+              <a:t>04. Design: Logical Architecture</a:t>
+            </a:r>
+          </a:p>
+        </p:txBody>
+      </p:sp>
+      <p:cxnSp>
+        <p:nvCxnSpPr>
+          <p:cNvPr id="3" name="Connector 2"/>
+          <p:cNvCxnSpPr/>
+          <p:nvPr/>
+        </p:nvCxnSpPr>
+        <p:spPr>
+          <a:xfrm>
+            <a:off x="457200" y="685800"/>
+            <a:ext cx="11274552" cy="0"/>
+          </a:xfrm>
+          <a:prstGeom prst="line">
+            <a:avLst/>
+          </a:prstGeom>
+          <a:ln w="12700">
+            <a:solidFill>
+              <a:srgbClr val="000000"/>
+            </a:solidFill>
+          </a:ln>
+          <a:effectLst/>
+        </p:spPr>
+        <p:style>
+          <a:lnRef idx="2">
+            <a:schemeClr val="accent1"/>
+          </a:lnRef>
+          <a:fillRef idx="0">
+            <a:schemeClr val="accent1"/>
+          </a:fillRef>
+          <a:effectRef idx="1">
+            <a:schemeClr val="accent1"/>
+          </a:effectRef>
+          <a:fontRef idx="minor">
+            <a:schemeClr val="tx1"/>
+          </a:fontRef>
+        </p:style>
+      </p:cxnSp>
+      <p:sp>
+        <p:nvSpPr>
+          <p:cNvPr id="4" name="Title"/>
+          <p:cNvSpPr txBox="1"/>
+          <p:nvPr/>
+        </p:nvSpPr>
+        <p:spPr>
+          <a:xfrm>
+            <a:off x="457200" y="749808"/>
+            <a:ext cx="11274552" cy="685800"/>
+          </a:xfrm>
+          <a:prstGeom prst="rect">
+            <a:avLst/>
+          </a:prstGeom>
+          <a:noFill/>
+        </p:spPr>
+        <p:txBody>
+          <a:bodyPr wrap="square" lIns="45720" rIns="45720" tIns="18288" bIns="18288" anchor="ctr">
+            <a:spAutoFit/>
+          </a:bodyPr>
+          <a:lstStyle/>
+          <a:p>
+            <a:pPr algn="ctr"/>
+            <a:r>
+              <a:rPr sz="2600" b="0">
+                <a:solidFill>
+                  <a:srgbClr val="0A1045"/>
+                </a:solidFill>
+                <a:latin typeface="Arial Black"/>
+              </a:rPr>
+              <a:t>Request Flow: Step by Step</a:t>
+            </a:r>
+          </a:p>
+        </p:txBody>
+      </p:sp>
+      <p:sp>
+        <p:nvSpPr>
+          <p:cNvPr id="5" name="Page number"/>
+          <p:cNvSpPr txBox="1"/>
+          <p:nvPr/>
+        </p:nvSpPr>
+        <p:spPr>
+          <a:xfrm>
+            <a:off x="11247120" y="6446520"/>
+            <a:ext cx="640080" cy="274320"/>
+          </a:xfrm>
+          <a:prstGeom prst="rect">
+            <a:avLst/>
+          </a:prstGeom>
+          <a:noFill/>
+        </p:spPr>
+        <p:txBody>
+          <a:bodyPr wrap="square" lIns="45720" rIns="45720" tIns="18288" bIns="18288" anchor="ctr">
+            <a:spAutoFit/>
+          </a:bodyPr>
+          <a:lstStyle/>
+          <a:p>
+            <a:pPr algn="r"/>
+            <a:r>
+              <a:rPr sz="1200" b="0">
+                <a:solidFill>
+                  <a:srgbClr val="000000"/>
+                </a:solidFill>
+                <a:latin typeface="Arial"/>
+              </a:rPr>
+              <a:t>21</a:t>
+            </a:r>
+          </a:p>
+        </p:txBody>
+      </p:sp>
+      <p:sp>
+        <p:nvSpPr>
+          <p:cNvPr id="6" name="Card 1"/>
+          <p:cNvSpPr/>
+          <p:nvPr/>
+        </p:nvSpPr>
+        <p:spPr>
+          <a:xfrm>
+            <a:off x="457200" y="1760220"/>
+            <a:ext cx="3666744" cy="1645920"/>
+          </a:xfrm>
+          <a:prstGeom prst="roundRect">
+            <a:avLst>
+              <a:gd name="adj" fmla="val 12000"/>
+            </a:avLst>
+          </a:prstGeom>
+          <a:noFill/>
+          <a:ln w="25400">
+            <a:solidFill>
+              <a:srgbClr val="5B5243"/>
+            </a:solidFill>
+          </a:ln>
+          <a:effectLst/>
+        </p:spPr>
+        <p:style>
+          <a:lnRef idx="1">
+            <a:schemeClr val="accent1"/>
+          </a:lnRef>
+          <a:fillRef idx="3">
+            <a:schemeClr val="accent1"/>
+          </a:fillRef>
+          <a:effectRef idx="2">
+            <a:schemeClr val="accent1"/>
+          </a:effectRef>
+          <a:fontRef idx="minor">
+            <a:schemeClr val="lt1"/>
+          </a:fontRef>
+        </p:style>
+        <p:txBody>
+          <a:bodyPr rtlCol="0" anchor="ctr"/>
+          <a:lstStyle/>
+          <a:p>
+            <a:pPr algn="ctr"/>
+          </a:p>
+        </p:txBody>
+      </p:sp>
+      <p:sp>
+        <p:nvSpPr>
+          <p:cNvPr id="7" name="Chip 1"/>
+          <p:cNvSpPr/>
+          <p:nvPr/>
+        </p:nvSpPr>
+        <p:spPr>
+          <a:xfrm>
+            <a:off x="918972" y="1554480"/>
+            <a:ext cx="2743200" cy="411480"/>
+          </a:xfrm>
+          <a:prstGeom prst="roundRect">
+            <a:avLst>
+              <a:gd name="adj" fmla="val 40000"/>
+            </a:avLst>
+          </a:prstGeom>
+          <a:solidFill>
+            <a:srgbClr val="FDE8E8"/>
+          </a:solidFill>
+          <a:ln>
+            <a:noFill/>
+          </a:ln>
+          <a:effectLst/>
+        </p:spPr>
+        <p:style>
+          <a:lnRef idx="1">
+            <a:schemeClr val="accent1"/>
+          </a:lnRef>
+          <a:fillRef idx="3">
+            <a:schemeClr val="accent1"/>
+          </a:fillRef>
+          <a:effectRef idx="2">
+            <a:schemeClr val="accent1"/>
+          </a:effectRef>
+          <a:fontRef idx="minor">
+            <a:schemeClr val="lt1"/>
+          </a:fontRef>
+        </p:style>
+        <p:txBody>
+          <a:bodyPr rtlCol="0" anchor="ctr" lIns="45720" rIns="45720"/>
+          <a:lstStyle/>
+          <a:p>
+            <a:pPr algn="ctr"/>
+            <a:r>
+              <a:rPr sz="1300" b="1">
+                <a:solidFill>
+                  <a:srgbClr val="000000"/>
+                </a:solidFill>
+                <a:latin typeface="Arial"/>
+              </a:rPr>
+              <a:t>1 · Frontend asks</a:t>
+            </a:r>
+          </a:p>
+        </p:txBody>
+      </p:sp>
+      <p:sp>
+        <p:nvSpPr>
+          <p:cNvPr id="8" name="Card text 1"/>
+          <p:cNvSpPr txBox="1"/>
+          <p:nvPr/>
+        </p:nvSpPr>
+        <p:spPr>
+          <a:xfrm>
+            <a:off x="548640" y="2011680"/>
+            <a:ext cx="3483864" cy="1348740"/>
+          </a:xfrm>
+          <a:prstGeom prst="rect">
+            <a:avLst/>
+          </a:prstGeom>
+          <a:noFill/>
+        </p:spPr>
+        <p:txBody>
+          <a:bodyPr wrap="square" lIns="45720" rIns="45720" tIns="18288" bIns="18288" anchor="ctr">
+            <a:spAutoFit/>
+          </a:bodyPr>
+          <a:lstStyle/>
+          <a:p>
+            <a:pPr algn="l"/>
+            <a:r>
+              <a:rPr sz="1400" b="0">
+                <a:solidFill>
+                  <a:srgbClr val="333333"/>
+                </a:solidFill>
+                <a:latin typeface="Arial"/>
+              </a:rPr>
+              <a:t>When someone opens a machine's health panel, the browser </a:t>
+            </a:r>
+            <a:r>
+              <a:rPr sz="1400" b="1">
+                <a:solidFill>
+                  <a:srgbClr val="000000"/>
+                </a:solidFill>
+                <a:latin typeface="Arial"/>
+              </a:rPr>
+              <a:t>asks the backend</a:t>
+            </a:r>
+            <a:r>
+              <a:rPr sz="1400" b="0">
+                <a:solidFill>
+                  <a:srgbClr val="333333"/>
+                </a:solidFill>
+                <a:latin typeface="Arial"/>
+              </a:rPr>
+              <a:t> for that machine's health, sending the user's </a:t>
+            </a:r>
+            <a:r>
+              <a:rPr sz="1400" b="1">
+                <a:solidFill>
+                  <a:srgbClr val="000000"/>
+                </a:solidFill>
+                <a:latin typeface="Arial"/>
+              </a:rPr>
+              <a:t>login token</a:t>
+            </a:r>
+            <a:r>
+              <a:rPr sz="1400" b="0">
+                <a:solidFill>
+                  <a:srgbClr val="333333"/>
+                </a:solidFill>
+                <a:latin typeface="Arial"/>
+              </a:rPr>
+              <a:t> with the request.</a:t>
+            </a:r>
+          </a:p>
+        </p:txBody>
+      </p:sp>
+      <p:sp>
+        <p:nvSpPr>
+          <p:cNvPr id="9" name="Card 2"/>
+          <p:cNvSpPr/>
+          <p:nvPr/>
+        </p:nvSpPr>
+        <p:spPr>
+          <a:xfrm>
+            <a:off x="4261104" y="1760220"/>
+            <a:ext cx="3666744" cy="1645920"/>
+          </a:xfrm>
+          <a:prstGeom prst="roundRect">
+            <a:avLst>
+              <a:gd name="adj" fmla="val 12000"/>
+            </a:avLst>
+          </a:prstGeom>
+          <a:noFill/>
+          <a:ln w="25400">
+            <a:solidFill>
+              <a:srgbClr val="5B5243"/>
+            </a:solidFill>
+          </a:ln>
+          <a:effectLst/>
+        </p:spPr>
+        <p:style>
+          <a:lnRef idx="1">
+            <a:schemeClr val="accent1"/>
+          </a:lnRef>
+          <a:fillRef idx="3">
+            <a:schemeClr val="accent1"/>
+          </a:fillRef>
+          <a:effectRef idx="2">
+            <a:schemeClr val="accent1"/>
+          </a:effectRef>
+          <a:fontRef idx="minor">
+            <a:schemeClr val="lt1"/>
+          </a:fontRef>
+        </p:style>
+        <p:txBody>
+          <a:bodyPr rtlCol="0" anchor="ctr"/>
+          <a:lstStyle/>
+          <a:p>
+            <a:pPr algn="ctr"/>
+          </a:p>
+        </p:txBody>
+      </p:sp>
+      <p:sp>
+        <p:nvSpPr>
+          <p:cNvPr id="10" name="Chip 2"/>
+          <p:cNvSpPr/>
+          <p:nvPr/>
+        </p:nvSpPr>
+        <p:spPr>
+          <a:xfrm>
+            <a:off x="4722876" y="1554480"/>
+            <a:ext cx="2743200" cy="411480"/>
+          </a:xfrm>
+          <a:prstGeom prst="roundRect">
+            <a:avLst>
+              <a:gd name="adj" fmla="val 40000"/>
+            </a:avLst>
+          </a:prstGeom>
+          <a:solidFill>
+            <a:srgbClr val="FDE8E8"/>
+          </a:solidFill>
+          <a:ln>
+            <a:noFill/>
+          </a:ln>
+          <a:effectLst/>
+        </p:spPr>
+        <p:style>
+          <a:lnRef idx="1">
+            <a:schemeClr val="accent1"/>
+          </a:lnRef>
+          <a:fillRef idx="3">
+            <a:schemeClr val="accent1"/>
+          </a:fillRef>
+          <a:effectRef idx="2">
+            <a:schemeClr val="accent1"/>
+          </a:effectRef>
+          <a:fontRef idx="minor">
+            <a:schemeClr val="lt1"/>
+          </a:fontRef>
+        </p:style>
+        <p:txBody>
+          <a:bodyPr rtlCol="0" anchor="ctr" lIns="45720" rIns="45720"/>
+          <a:lstStyle/>
+          <a:p>
+            <a:pPr algn="ctr"/>
+            <a:r>
+              <a:rPr sz="1300" b="1">
+                <a:solidFill>
+                  <a:srgbClr val="000000"/>
+                </a:solidFill>
+                <a:latin typeface="Arial"/>
+              </a:rPr>
+              <a:t>2 · Backend reads telemetry</a:t>
+            </a:r>
+          </a:p>
+        </p:txBody>
+      </p:sp>
+      <p:sp>
+        <p:nvSpPr>
+          <p:cNvPr id="11" name="Card text 2"/>
+          <p:cNvSpPr txBox="1"/>
+          <p:nvPr/>
+        </p:nvSpPr>
+        <p:spPr>
+          <a:xfrm>
+            <a:off x="4352544" y="2011680"/>
+            <a:ext cx="3483864" cy="1348740"/>
+          </a:xfrm>
+          <a:prstGeom prst="rect">
+            <a:avLst/>
+          </a:prstGeom>
+          <a:noFill/>
+        </p:spPr>
+        <p:txBody>
+          <a:bodyPr wrap="square" lIns="45720" rIns="45720" tIns="18288" bIns="18288" anchor="ctr">
+            <a:spAutoFit/>
+          </a:bodyPr>
+          <a:lstStyle/>
+          <a:p>
+            <a:pPr algn="l"/>
+            <a:r>
+              <a:rPr sz="1400" b="0">
+                <a:solidFill>
+                  <a:srgbClr val="333333"/>
+                </a:solidFill>
+                <a:latin typeface="Arial"/>
+              </a:rPr>
+              <a:t>The backend fetches the machine's </a:t>
+            </a:r>
+            <a:r>
+              <a:rPr sz="1400" b="1">
+                <a:solidFill>
+                  <a:srgbClr val="000000"/>
+                </a:solidFill>
+                <a:latin typeface="Arial"/>
+              </a:rPr>
+              <a:t>latest sensor readings</a:t>
+            </a:r>
+            <a:r>
+              <a:rPr sz="1400" b="0">
+                <a:solidFill>
+                  <a:srgbClr val="333333"/>
+                </a:solidFill>
+                <a:latin typeface="Arial"/>
+              </a:rPr>
+              <a:t> (temperatures, speed, torque, tool wear). If there are none, it </a:t>
+            </a:r>
+            <a:r>
+              <a:rPr sz="1400" b="1">
+                <a:solidFill>
+                  <a:srgbClr val="000000"/>
+                </a:solidFill>
+                <a:latin typeface="Arial"/>
+              </a:rPr>
+              <a:t>stops here</a:t>
+            </a:r>
+            <a:r>
+              <a:rPr sz="1400" b="0">
+                <a:solidFill>
+                  <a:srgbClr val="333333"/>
+                </a:solidFill>
+                <a:latin typeface="Arial"/>
+              </a:rPr>
+              <a:t> and calls no model.</a:t>
+            </a:r>
+          </a:p>
+        </p:txBody>
+      </p:sp>
+      <p:sp>
+        <p:nvSpPr>
+          <p:cNvPr id="12" name="Card 3"/>
+          <p:cNvSpPr/>
+          <p:nvPr/>
+        </p:nvSpPr>
+        <p:spPr>
+          <a:xfrm>
+            <a:off x="8065008" y="1760220"/>
+            <a:ext cx="3666744" cy="1645920"/>
+          </a:xfrm>
+          <a:prstGeom prst="roundRect">
+            <a:avLst>
+              <a:gd name="adj" fmla="val 12000"/>
+            </a:avLst>
+          </a:prstGeom>
+          <a:noFill/>
+          <a:ln w="25400">
+            <a:solidFill>
+              <a:srgbClr val="5B5243"/>
+            </a:solidFill>
+          </a:ln>
+          <a:effectLst/>
+        </p:spPr>
+        <p:style>
+          <a:lnRef idx="1">
+            <a:schemeClr val="accent1"/>
+          </a:lnRef>
+          <a:fillRef idx="3">
+            <a:schemeClr val="accent1"/>
+          </a:fillRef>
+          <a:effectRef idx="2">
+            <a:schemeClr val="accent1"/>
+          </a:effectRef>
+          <a:fontRef idx="minor">
+            <a:schemeClr val="lt1"/>
+          </a:fontRef>
+        </p:style>
+        <p:txBody>
+          <a:bodyPr rtlCol="0" anchor="ctr"/>
+          <a:lstStyle/>
+          <a:p>
+            <a:pPr algn="ctr"/>
+          </a:p>
+        </p:txBody>
+      </p:sp>
+      <p:sp>
+        <p:nvSpPr>
+          <p:cNvPr id="13" name="Chip 3"/>
+          <p:cNvSpPr/>
+          <p:nvPr/>
+        </p:nvSpPr>
+        <p:spPr>
+          <a:xfrm>
+            <a:off x="8526780" y="1554480"/>
+            <a:ext cx="2743200" cy="411480"/>
+          </a:xfrm>
+          <a:prstGeom prst="roundRect">
+            <a:avLst>
+              <a:gd name="adj" fmla="val 40000"/>
+            </a:avLst>
+          </a:prstGeom>
+          <a:solidFill>
+            <a:srgbClr val="FDE8E8"/>
+          </a:solidFill>
+          <a:ln>
+            <a:noFill/>
+          </a:ln>
+          <a:effectLst/>
+        </p:spPr>
+        <p:style>
+          <a:lnRef idx="1">
+            <a:schemeClr val="accent1"/>
+          </a:lnRef>
+          <a:fillRef idx="3">
+            <a:schemeClr val="accent1"/>
+          </a:fillRef>
+          <a:effectRef idx="2">
+            <a:schemeClr val="accent1"/>
+          </a:effectRef>
+          <a:fontRef idx="minor">
+            <a:schemeClr val="lt1"/>
+          </a:fontRef>
+        </p:style>
+        <p:txBody>
+          <a:bodyPr rtlCol="0" anchor="ctr" lIns="45720" rIns="45720"/>
+          <a:lstStyle/>
+          <a:p>
+            <a:pPr algn="ctr"/>
+            <a:r>
+              <a:rPr sz="1300" b="1">
+                <a:solidFill>
+                  <a:srgbClr val="000000"/>
+                </a:solidFill>
+                <a:latin typeface="Arial"/>
+              </a:rPr>
+              <a:t>3 · ML microservice</a:t>
+            </a:r>
+          </a:p>
+        </p:txBody>
+      </p:sp>
+      <p:sp>
+        <p:nvSpPr>
+          <p:cNvPr id="14" name="Card text 3"/>
+          <p:cNvSpPr txBox="1"/>
+          <p:nvPr/>
+        </p:nvSpPr>
+        <p:spPr>
+          <a:xfrm>
+            <a:off x="8156448" y="2011680"/>
+            <a:ext cx="3483864" cy="1348740"/>
+          </a:xfrm>
+          <a:prstGeom prst="rect">
+            <a:avLst/>
+          </a:prstGeom>
+          <a:noFill/>
+        </p:spPr>
+        <p:txBody>
+          <a:bodyPr wrap="square" lIns="45720" rIns="45720" tIns="18288" bIns="18288" anchor="ctr">
+            <a:spAutoFit/>
+          </a:bodyPr>
+          <a:lstStyle/>
+          <a:p>
+            <a:pPr algn="l"/>
+            <a:r>
+              <a:rPr sz="1400" b="0">
+                <a:solidFill>
+                  <a:srgbClr val="333333"/>
+                </a:solidFill>
+                <a:latin typeface="Arial"/>
+              </a:rPr>
+              <a:t>The ML service runs </a:t>
+            </a:r>
+            <a:r>
+              <a:rPr sz="1400" b="1">
+                <a:solidFill>
+                  <a:srgbClr val="000000"/>
+                </a:solidFill>
+                <a:latin typeface="Arial"/>
+              </a:rPr>
+              <a:t>seven models at once</a:t>
+            </a:r>
+            <a:r>
+              <a:rPr sz="1400" b="0">
+                <a:solidFill>
+                  <a:srgbClr val="333333"/>
+                </a:solidFill>
+                <a:latin typeface="Arial"/>
+              </a:rPr>
+              <a:t> on those readings: failure chance, failure type, remaining life, odd behavior, urgency, best timing, parts needed.</a:t>
+            </a:r>
+          </a:p>
+        </p:txBody>
+      </p:sp>
+      <p:sp>
+        <p:nvSpPr>
+          <p:cNvPr id="15" name="Card 4"/>
+          <p:cNvSpPr/>
+          <p:nvPr/>
+        </p:nvSpPr>
+        <p:spPr>
+          <a:xfrm>
+            <a:off x="457200" y="3931920"/>
+            <a:ext cx="3666744" cy="1645920"/>
+          </a:xfrm>
+          <a:prstGeom prst="roundRect">
+            <a:avLst>
+              <a:gd name="adj" fmla="val 12000"/>
+            </a:avLst>
+          </a:prstGeom>
+          <a:noFill/>
+          <a:ln w="25400">
+            <a:solidFill>
+              <a:srgbClr val="5B5243"/>
+            </a:solidFill>
+          </a:ln>
+          <a:effectLst/>
+        </p:spPr>
+        <p:style>
+          <a:lnRef idx="1">
+            <a:schemeClr val="accent1"/>
+          </a:lnRef>
+          <a:fillRef idx="3">
+            <a:schemeClr val="accent1"/>
+          </a:fillRef>
+          <a:effectRef idx="2">
+            <a:schemeClr val="accent1"/>
+          </a:effectRef>
+          <a:fontRef idx="minor">
+            <a:schemeClr val="lt1"/>
+          </a:fontRef>
+        </p:style>
+        <p:txBody>
+          <a:bodyPr rtlCol="0" anchor="ctr"/>
+          <a:lstStyle/>
+          <a:p>
+            <a:pPr algn="ctr"/>
+          </a:p>
+        </p:txBody>
+      </p:sp>
+      <p:sp>
+        <p:nvSpPr>
+          <p:cNvPr id="16" name="Chip 4"/>
+          <p:cNvSpPr/>
+          <p:nvPr/>
+        </p:nvSpPr>
+        <p:spPr>
+          <a:xfrm>
+            <a:off x="918972" y="3726180"/>
+            <a:ext cx="2743200" cy="411480"/>
+          </a:xfrm>
+          <a:prstGeom prst="roundRect">
+            <a:avLst>
+              <a:gd name="adj" fmla="val 40000"/>
+            </a:avLst>
+          </a:prstGeom>
+          <a:solidFill>
+            <a:srgbClr val="FDE8E8"/>
+          </a:solidFill>
+          <a:ln>
+            <a:noFill/>
+          </a:ln>
+          <a:effectLst/>
+        </p:spPr>
+        <p:style>
+          <a:lnRef idx="1">
+            <a:schemeClr val="accent1"/>
+          </a:lnRef>
+          <a:fillRef idx="3">
+            <a:schemeClr val="accent1"/>
+          </a:fillRef>
+          <a:effectRef idx="2">
+            <a:schemeClr val="accent1"/>
+          </a:effectRef>
+          <a:fontRef idx="minor">
+            <a:schemeClr val="lt1"/>
+          </a:fontRef>
+        </p:style>
+        <p:txBody>
+          <a:bodyPr rtlCol="0" anchor="ctr" lIns="45720" rIns="45720"/>
+          <a:lstStyle/>
+          <a:p>
+            <a:pPr algn="ctr"/>
+            <a:r>
+              <a:rPr sz="1300" b="1">
+                <a:solidFill>
+                  <a:srgbClr val="000000"/>
+                </a:solidFill>
+                <a:latin typeface="Arial"/>
+              </a:rPr>
+              <a:t>4 · Wave 2 signals</a:t>
+            </a:r>
+          </a:p>
+        </p:txBody>
+      </p:sp>
+      <p:sp>
+        <p:nvSpPr>
+          <p:cNvPr id="17" name="Card text 4"/>
+          <p:cNvSpPr txBox="1"/>
+          <p:nvPr/>
+        </p:nvSpPr>
+        <p:spPr>
+          <a:xfrm>
+            <a:off x="548640" y="4183380"/>
+            <a:ext cx="3483864" cy="1348740"/>
+          </a:xfrm>
+          <a:prstGeom prst="rect">
+            <a:avLst/>
+          </a:prstGeom>
+          <a:noFill/>
+        </p:spPr>
+        <p:txBody>
+          <a:bodyPr wrap="square" lIns="45720" rIns="45720" tIns="18288" bIns="18288" anchor="ctr">
+            <a:spAutoFit/>
+          </a:bodyPr>
+          <a:lstStyle/>
+          <a:p>
+            <a:pPr algn="l"/>
+            <a:r>
+              <a:rPr sz="1400" b="0">
+                <a:solidFill>
+                  <a:srgbClr val="333333"/>
+                </a:solidFill>
+                <a:latin typeface="Arial"/>
+              </a:rPr>
+              <a:t>A second group of models studies the machine's </a:t>
+            </a:r>
+            <a:r>
+              <a:rPr sz="1400" b="1">
+                <a:solidFill>
+                  <a:srgbClr val="000000"/>
+                </a:solidFill>
+                <a:latin typeface="Arial"/>
+              </a:rPr>
+              <a:t>past readings</a:t>
+            </a:r>
+            <a:r>
+              <a:rPr sz="1400" b="0">
+                <a:solidFill>
+                  <a:srgbClr val="333333"/>
+                </a:solidFill>
+                <a:latin typeface="Arial"/>
+              </a:rPr>
+              <a:t>. They catch a </a:t>
+            </a:r>
+            <a:r>
+              <a:rPr sz="1400" b="1">
+                <a:solidFill>
+                  <a:srgbClr val="000000"/>
+                </a:solidFill>
+                <a:latin typeface="Arial"/>
+              </a:rPr>
+              <a:t>slow decline over time</a:t>
+            </a:r>
+            <a:r>
+              <a:rPr sz="1400" b="0">
+                <a:solidFill>
+                  <a:srgbClr val="333333"/>
+                </a:solidFill>
+                <a:latin typeface="Arial"/>
+              </a:rPr>
+              <a:t>, estimate how long it can </a:t>
+            </a:r>
+            <a:r>
+              <a:rPr sz="1400" b="1">
+                <a:solidFill>
+                  <a:srgbClr val="000000"/>
+                </a:solidFill>
+                <a:latin typeface="Arial"/>
+              </a:rPr>
+              <a:t>keep running</a:t>
+            </a:r>
+            <a:r>
+              <a:rPr sz="1400" b="0">
+                <a:solidFill>
+                  <a:srgbClr val="333333"/>
+                </a:solidFill>
+                <a:latin typeface="Arial"/>
+              </a:rPr>
+              <a:t>, and spot when it </a:t>
+            </a:r>
+            <a:r>
+              <a:rPr sz="1400" b="1">
+                <a:solidFill>
+                  <a:srgbClr val="000000"/>
+                </a:solidFill>
+                <a:latin typeface="Arial"/>
+              </a:rPr>
+              <a:t>drifts from its usual behavior</a:t>
+            </a:r>
+            <a:r>
+              <a:rPr sz="1400" b="0">
+                <a:solidFill>
+                  <a:srgbClr val="333333"/>
+                </a:solidFill>
+                <a:latin typeface="Arial"/>
+              </a:rPr>
+              <a:t>.</a:t>
+            </a:r>
+          </a:p>
+        </p:txBody>
+      </p:sp>
+      <p:sp>
+        <p:nvSpPr>
+          <p:cNvPr id="18" name="Card 5"/>
+          <p:cNvSpPr/>
+          <p:nvPr/>
+        </p:nvSpPr>
+        <p:spPr>
+          <a:xfrm>
+            <a:off x="4261104" y="3931920"/>
+            <a:ext cx="3666744" cy="1645920"/>
+          </a:xfrm>
+          <a:prstGeom prst="roundRect">
+            <a:avLst>
+              <a:gd name="adj" fmla="val 12000"/>
+            </a:avLst>
+          </a:prstGeom>
+          <a:noFill/>
+          <a:ln w="25400">
+            <a:solidFill>
+              <a:srgbClr val="5B5243"/>
+            </a:solidFill>
+          </a:ln>
+          <a:effectLst/>
+        </p:spPr>
+        <p:style>
+          <a:lnRef idx="1">
+            <a:schemeClr val="accent1"/>
+          </a:lnRef>
+          <a:fillRef idx="3">
+            <a:schemeClr val="accent1"/>
+          </a:fillRef>
+          <a:effectRef idx="2">
+            <a:schemeClr val="accent1"/>
+          </a:effectRef>
+          <a:fontRef idx="minor">
+            <a:schemeClr val="lt1"/>
+          </a:fontRef>
+        </p:style>
+        <p:txBody>
+          <a:bodyPr rtlCol="0" anchor="ctr"/>
+          <a:lstStyle/>
+          <a:p>
+            <a:pPr algn="ctr"/>
+          </a:p>
+        </p:txBody>
+      </p:sp>
+      <p:sp>
+        <p:nvSpPr>
+          <p:cNvPr id="19" name="Chip 5"/>
+          <p:cNvSpPr/>
+          <p:nvPr/>
+        </p:nvSpPr>
+        <p:spPr>
+          <a:xfrm>
+            <a:off x="4722876" y="3726180"/>
+            <a:ext cx="2743200" cy="411480"/>
+          </a:xfrm>
+          <a:prstGeom prst="roundRect">
+            <a:avLst>
+              <a:gd name="adj" fmla="val 40000"/>
+            </a:avLst>
+          </a:prstGeom>
+          <a:solidFill>
+            <a:srgbClr val="FDE8E8"/>
+          </a:solidFill>
+          <a:ln>
+            <a:noFill/>
+          </a:ln>
+          <a:effectLst/>
+        </p:spPr>
+        <p:style>
+          <a:lnRef idx="1">
+            <a:schemeClr val="accent1"/>
+          </a:lnRef>
+          <a:fillRef idx="3">
+            <a:schemeClr val="accent1"/>
+          </a:fillRef>
+          <a:effectRef idx="2">
+            <a:schemeClr val="accent1"/>
+          </a:effectRef>
+          <a:fontRef idx="minor">
+            <a:schemeClr val="lt1"/>
+          </a:fontRef>
+        </p:style>
+        <p:txBody>
+          <a:bodyPr rtlCol="0" anchor="ctr" lIns="45720" rIns="45720"/>
+          <a:lstStyle/>
+          <a:p>
+            <a:pPr algn="ctr"/>
+            <a:r>
+              <a:rPr sz="1300" b="1">
+                <a:solidFill>
+                  <a:srgbClr val="000000"/>
+                </a:solidFill>
+                <a:latin typeface="Arial"/>
+              </a:rPr>
+              <a:t>5 · DST fusion</a:t>
+            </a:r>
+          </a:p>
+        </p:txBody>
+      </p:sp>
+      <p:sp>
+        <p:nvSpPr>
+          <p:cNvPr id="20" name="Card text 5"/>
+          <p:cNvSpPr txBox="1"/>
+          <p:nvPr/>
+        </p:nvSpPr>
+        <p:spPr>
+          <a:xfrm>
+            <a:off x="4352544" y="4183380"/>
+            <a:ext cx="3483864" cy="1348740"/>
+          </a:xfrm>
+          <a:prstGeom prst="rect">
+            <a:avLst/>
+          </a:prstGeom>
+          <a:noFill/>
+        </p:spPr>
+        <p:txBody>
+          <a:bodyPr wrap="square" lIns="45720" rIns="45720" tIns="18288" bIns="18288" anchor="ctr">
+            <a:spAutoFit/>
+          </a:bodyPr>
+          <a:lstStyle/>
+          <a:p>
+            <a:pPr algn="l"/>
+            <a:r>
+              <a:rPr sz="1400" b="0">
+                <a:solidFill>
+                  <a:srgbClr val="333333"/>
+                </a:solidFill>
+                <a:latin typeface="Arial"/>
+              </a:rPr>
+              <a:t>All the opinions are </a:t>
+            </a:r>
+            <a:r>
+              <a:rPr sz="1400" b="1">
+                <a:solidFill>
+                  <a:srgbClr val="000000"/>
+                </a:solidFill>
+                <a:latin typeface="Arial"/>
+              </a:rPr>
+              <a:t>combined into one health score</a:t>
+            </a:r>
+            <a:r>
+              <a:rPr sz="1400" b="0">
+                <a:solidFill>
+                  <a:srgbClr val="333333"/>
+                </a:solidFill>
+                <a:latin typeface="Arial"/>
+              </a:rPr>
+              <a:t> (0 to 100) and a verdict: Healthy, Degrading, Critical or </a:t>
+            </a:r>
+            <a:r>
+              <a:rPr sz="1400" b="1">
+                <a:solidFill>
+                  <a:srgbClr val="000000"/>
+                </a:solidFill>
+                <a:latin typeface="Arial"/>
+              </a:rPr>
+              <a:t>Unknown</a:t>
+            </a:r>
+            <a:r>
+              <a:rPr sz="1400" b="0">
+                <a:solidFill>
+                  <a:srgbClr val="333333"/>
+                </a:solidFill>
+                <a:latin typeface="Arial"/>
+              </a:rPr>
+              <a:t>. If the models strongly disagree, it says Unknown instead of guessing.</a:t>
+            </a:r>
+          </a:p>
+        </p:txBody>
+      </p:sp>
+      <p:sp>
+        <p:nvSpPr>
+          <p:cNvPr id="21" name="Card 6"/>
+          <p:cNvSpPr/>
+          <p:nvPr/>
+        </p:nvSpPr>
+        <p:spPr>
+          <a:xfrm>
+            <a:off x="8065008" y="3931920"/>
+            <a:ext cx="3666744" cy="1645920"/>
+          </a:xfrm>
+          <a:prstGeom prst="roundRect">
+            <a:avLst>
+              <a:gd name="adj" fmla="val 12000"/>
+            </a:avLst>
+          </a:prstGeom>
+          <a:noFill/>
+          <a:ln w="25400">
+            <a:solidFill>
+              <a:srgbClr val="5B5243"/>
+            </a:solidFill>
+          </a:ln>
+          <a:effectLst/>
+        </p:spPr>
+        <p:style>
+          <a:lnRef idx="1">
+            <a:schemeClr val="accent1"/>
+          </a:lnRef>
+          <a:fillRef idx="3">
+            <a:schemeClr val="accent1"/>
+          </a:fillRef>
+          <a:effectRef idx="2">
+            <a:schemeClr val="accent1"/>
+          </a:effectRef>
+          <a:fontRef idx="minor">
+            <a:schemeClr val="lt1"/>
+          </a:fontRef>
+        </p:style>
+        <p:txBody>
+          <a:bodyPr rtlCol="0" anchor="ctr"/>
+          <a:lstStyle/>
+          <a:p>
+            <a:pPr algn="ctr"/>
+          </a:p>
+        </p:txBody>
+      </p:sp>
+      <p:sp>
+        <p:nvSpPr>
+          <p:cNvPr id="22" name="Chip 6"/>
+          <p:cNvSpPr/>
+          <p:nvPr/>
+        </p:nvSpPr>
+        <p:spPr>
+          <a:xfrm>
+            <a:off x="8526780" y="3726180"/>
+            <a:ext cx="2743200" cy="411480"/>
+          </a:xfrm>
+          <a:prstGeom prst="roundRect">
+            <a:avLst>
+              <a:gd name="adj" fmla="val 40000"/>
+            </a:avLst>
+          </a:prstGeom>
+          <a:solidFill>
+            <a:srgbClr val="FDE8E8"/>
+          </a:solidFill>
+          <a:ln>
+            <a:noFill/>
+          </a:ln>
+          <a:effectLst/>
+        </p:spPr>
+        <p:style>
+          <a:lnRef idx="1">
+            <a:schemeClr val="accent1"/>
+          </a:lnRef>
+          <a:fillRef idx="3">
+            <a:schemeClr val="accent1"/>
+          </a:fillRef>
+          <a:effectRef idx="2">
+            <a:schemeClr val="accent1"/>
+          </a:effectRef>
+          <a:fontRef idx="minor">
+            <a:schemeClr val="lt1"/>
+          </a:fontRef>
+        </p:style>
+        <p:txBody>
+          <a:bodyPr rtlCol="0" anchor="ctr" lIns="45720" rIns="45720"/>
+          <a:lstStyle/>
+          <a:p>
+            <a:pPr algn="ctr"/>
+            <a:r>
+              <a:rPr sz="1300" b="1">
+                <a:solidFill>
+                  <a:srgbClr val="000000"/>
+                </a:solidFill>
+                <a:latin typeface="Arial"/>
+              </a:rPr>
+              <a:t>6 · Log &amp; render</a:t>
+            </a:r>
+          </a:p>
+        </p:txBody>
+      </p:sp>
+      <p:sp>
+        <p:nvSpPr>
+          <p:cNvPr id="23" name="Card text 6"/>
+          <p:cNvSpPr txBox="1"/>
+          <p:nvPr/>
+        </p:nvSpPr>
+        <p:spPr>
+          <a:xfrm>
+            <a:off x="8156448" y="4183380"/>
+            <a:ext cx="3483864" cy="1348740"/>
+          </a:xfrm>
+          <a:prstGeom prst="rect">
+            <a:avLst/>
+          </a:prstGeom>
+          <a:noFill/>
+        </p:spPr>
+        <p:txBody>
+          <a:bodyPr wrap="square" lIns="45720" rIns="45720" tIns="18288" bIns="18288" anchor="ctr">
+            <a:spAutoFit/>
+          </a:bodyPr>
+          <a:lstStyle/>
+          <a:p>
+            <a:pPr algn="l"/>
+            <a:r>
+              <a:rPr sz="1400" b="0">
+                <a:solidFill>
+                  <a:srgbClr val="333333"/>
+                </a:solidFill>
+                <a:latin typeface="Arial"/>
+              </a:rPr>
+              <a:t>The result is </a:t>
+            </a:r>
+            <a:r>
+              <a:rPr sz="1400" b="1">
+                <a:solidFill>
+                  <a:srgbClr val="000000"/>
+                </a:solidFill>
+                <a:latin typeface="Arial"/>
+              </a:rPr>
+              <a:t>saved</a:t>
+            </a:r>
+            <a:r>
+              <a:rPr sz="1400" b="0">
+                <a:solidFill>
+                  <a:srgbClr val="333333"/>
+                </a:solidFill>
+                <a:latin typeface="Arial"/>
+              </a:rPr>
+              <a:t>, so every prediction can be checked later against what really happened. Then the </a:t>
+            </a:r>
+            <a:r>
+              <a:rPr sz="1400" b="1">
+                <a:solidFill>
+                  <a:srgbClr val="000000"/>
+                </a:solidFill>
+                <a:latin typeface="Arial"/>
+              </a:rPr>
+              <a:t>panel updates</a:t>
+            </a:r>
+            <a:r>
+              <a:rPr sz="1400" b="0">
+                <a:solidFill>
+                  <a:srgbClr val="333333"/>
+                </a:solidFill>
+                <a:latin typeface="Arial"/>
+              </a:rPr>
+              <a:t> on screen.</a:t>
+            </a:r>
+          </a:p>
+        </p:txBody>
+      </p:sp>
+      <p:sp>
+        <p:nvSpPr>
+          <p:cNvPr id="24" name="Key takeaway"/>
+          <p:cNvSpPr txBox="1"/>
+          <p:nvPr/>
+        </p:nvSpPr>
+        <p:spPr>
+          <a:xfrm>
+            <a:off x="457200" y="5760720"/>
+            <a:ext cx="11274552" cy="411480"/>
+          </a:xfrm>
+          <a:prstGeom prst="rect">
+            <a:avLst/>
+          </a:prstGeom>
+          <a:noFill/>
+        </p:spPr>
+        <p:txBody>
+          <a:bodyPr wrap="square" lIns="45720" rIns="45720" tIns="18288" bIns="18288" anchor="ctr">
+            <a:spAutoFit/>
+          </a:bodyPr>
+          <a:lstStyle/>
+          <a:p>
+            <a:pPr algn="ctr"/>
+            <a:r>
+              <a:rPr sz="1300" b="1">
+                <a:solidFill>
+                  <a:srgbClr val="D0101A"/>
+                </a:solidFill>
+                <a:latin typeface="Arial"/>
+              </a:rPr>
+              <a:t>No data, no guessing:</a:t>
+            </a:r>
+            <a:r>
+              <a:rPr sz="1300" b="0">
+                <a:solidFill>
+                  <a:srgbClr val="000000"/>
+                </a:solidFill>
+                <a:latin typeface="Arial"/>
+              </a:rPr>
+              <a:t> without sensor readings, the score comes from maintenance history only, never from invented values.</a:t>
+            </a:r>
+          </a:p>
+        </p:txBody>
+      </p:sp>
+    </p:spTree>
+  </p:cSld>
+  <p:clrMapOvr>
+    <a:masterClrMapping/>
+  </p:clrMapOvr>
+</p:sld>
+</file>
+
+<file path=ppt/slides/slide39.xml><?xml version="1.0" encoding="utf-8"?>
 <p:sld xmlns:a="http://schemas.openxmlformats.org/drawingml/2006/main" xmlns:p="http://schemas.openxmlformats.org/presentationml/2006/main" xmlns:r="http://schemas.openxmlformats.org/officeDocument/2006/relationships">
   <p:cSld>
     <p:spTree>

</xml_diff>

<commit_message>
docs(presentation): plain-language conclusion and perspectives slides
Technical details moved to speaker notes.

Co-Authored-By: Claude Opus 5.5 <noreply@anthropic.com>
Claude-Session: https://claude.ai/code/session_01F96Sh6kL5Mvj9m6qX6kkqv
</commit_message>
<xml_diff>
--- a/presentation/technical_defense_final_v2.pptx
+++ b/presentation/technical_defense_final_v2.pptx
@@ -695,6 +695,146 @@
           <a:p>
             <a:r>
               <a:t>Two flows. Ingestion, once per document: an administrator uploads a file through the backend; it is stored first in MinIO (bucket rag-docs), then the RAG service splits it into chunks, embeds each chunk with BAAI/bge-m3 and stores the vectors in PostgreSQL with pgvector. If ingestion fails, the upload is rolled back. Query, on every chat message: the question arrives with the machine_id of the page it was asked from. Two fetches run in parallel: hybrid retrieval (vector search plus keyword search, then a cross-encoder reranker, bge-reranker-v2-m3) and a live ML snapshot of that machine (unified health score, verdict, risk, RUL, anomaly, priority, parts, latest sensors). The ML block is injected into the prompt just before the question and sent to the Groq LLM. The response carries ml_context_used to prove live data was included. If the ML service is down, a rule-based fallback score keeps the context block valid, so the assistant still answers.</a:t>
+            </a:r>
+          </a:p>
+        </p:txBody>
+      </p:sp>
+      <p:sp>
+        <p:nvSpPr>
+          <p:cNvPr id="4" name="Slide Number Placeholder 3"/>
+          <p:cNvSpPr>
+            <a:spLocks noGrp="1"/>
+          </p:cNvSpPr>
+          <p:nvPr>
+            <p:ph type="sldNum" idx="5" sz="quarter"/>
+          </p:nvPr>
+        </p:nvSpPr>
+        <p:spPr/>
+      </p:sp>
+    </p:spTree>
+  </p:cSld>
+  <p:clrMapOvr>
+    <a:masterClrMapping/>
+  </p:clrMapOvr>
+</p:notes>
+</file>
+
+<file path=ppt/notesSlides/notesSlide11.xml><?xml version="1.0" encoding="utf-8"?>
+<p:notes xmlns:a="http://schemas.openxmlformats.org/drawingml/2006/main" xmlns:p="http://schemas.openxmlformats.org/presentationml/2006/main" xmlns:r="http://schemas.openxmlformats.org/officeDocument/2006/relationships">
+  <p:cSld>
+    <p:spTree>
+      <p:nvGrpSpPr>
+        <p:cNvPr id="1" name=""/>
+        <p:cNvGrpSpPr/>
+        <p:nvPr/>
+      </p:nvGrpSpPr>
+      <p:grpSpPr>
+        <a:xfrm>
+          <a:off x="0" y="0"/>
+          <a:ext cx="0" cy="0"/>
+          <a:chOff x="0" y="0"/>
+          <a:chExt cx="0" cy="0"/>
+        </a:xfrm>
+      </p:grpSpPr>
+      <p:sp>
+        <p:nvSpPr>
+          <p:cNvPr id="2" name="Slide Image Placeholder 1"/>
+          <p:cNvSpPr>
+            <a:spLocks noGrp="1"/>
+          </p:cNvSpPr>
+          <p:nvPr>
+            <p:ph type="sldImg" idx="2"/>
+          </p:nvPr>
+        </p:nvSpPr>
+        <p:spPr/>
+      </p:sp>
+      <p:sp>
+        <p:nvSpPr>
+          <p:cNvPr id="3" name="Notes Placeholder 2"/>
+          <p:cNvSpPr>
+            <a:spLocks noGrp="1"/>
+          </p:cNvSpPr>
+          <p:nvPr>
+            <p:ph type="body" idx="3" sz="quarter"/>
+          </p:nvPr>
+        </p:nvSpPr>
+        <p:spPr/>
+        <p:txBody>
+          <a:bodyPr/>
+          <a:lstStyle/>
+          <a:p>
+            <a:r>
+              <a:t>Four take-aways. First, scope: a full EAM foundation (machines, work and intervention orders, planning, inventory) plus seven ML models (P1-P7) and the RAG assistant, in one platform. Second, method: every feature was specified, planned, implemented and then verified, with traceability from requirement to test. Third, honesty: label leakage was detected in P1, P2 and P5 (their labels are deterministic functions of an input feature), so their metrics are flagged as leaked and reported instead of being presented as real performance; only P3 has trustworthy holdout figures. Fourth, delivery: the code goes through a six-stage security and quality pipeline (secret scan, dependency audit, SAST, SonarQube, image scan, quality gate) and runs on AKS in the eam-staging and eam-prod namespaces.</a:t>
+            </a:r>
+          </a:p>
+        </p:txBody>
+      </p:sp>
+      <p:sp>
+        <p:nvSpPr>
+          <p:cNvPr id="4" name="Slide Number Placeholder 3"/>
+          <p:cNvSpPr>
+            <a:spLocks noGrp="1"/>
+          </p:cNvSpPr>
+          <p:nvPr>
+            <p:ph type="sldNum" idx="5" sz="quarter"/>
+          </p:nvPr>
+        </p:nvSpPr>
+        <p:spPr/>
+      </p:sp>
+    </p:spTree>
+  </p:cSld>
+  <p:clrMapOvr>
+    <a:masterClrMapping/>
+  </p:clrMapOvr>
+</p:notes>
+</file>
+
+<file path=ppt/notesSlides/notesSlide12.xml><?xml version="1.0" encoding="utf-8"?>
+<p:notes xmlns:a="http://schemas.openxmlformats.org/drawingml/2006/main" xmlns:p="http://schemas.openxmlformats.org/presentationml/2006/main" xmlns:r="http://schemas.openxmlformats.org/officeDocument/2006/relationships">
+  <p:cSld>
+    <p:spTree>
+      <p:nvGrpSpPr>
+        <p:cNvPr id="1" name=""/>
+        <p:cNvGrpSpPr/>
+        <p:nvPr/>
+      </p:nvGrpSpPr>
+      <p:grpSpPr>
+        <a:xfrm>
+          <a:off x="0" y="0"/>
+          <a:ext cx="0" cy="0"/>
+          <a:chOff x="0" y="0"/>
+          <a:chExt cx="0" cy="0"/>
+        </a:xfrm>
+      </p:grpSpPr>
+      <p:sp>
+        <p:nvSpPr>
+          <p:cNvPr id="2" name="Slide Image Placeholder 1"/>
+          <p:cNvSpPr>
+            <a:spLocks noGrp="1"/>
+          </p:cNvSpPr>
+          <p:nvPr>
+            <p:ph type="sldImg" idx="2"/>
+          </p:nvPr>
+        </p:nvSpPr>
+        <p:spPr/>
+      </p:sp>
+      <p:sp>
+        <p:nvSpPr>
+          <p:cNvPr id="3" name="Notes Placeholder 2"/>
+          <p:cNvSpPr>
+            <a:spLocks noGrp="1"/>
+          </p:cNvSpPr>
+          <p:nvPr>
+            <p:ph type="body" idx="3" sz="quarter"/>
+          </p:nvPr>
+        </p:nvSpPr>
+        <p:spPr/>
+        <p:txBody>
+          <a:bodyPr/>
+          <a:lstStyle/>
+          <a:p>
+            <a:r>
+              <a:t>Four next steps. Top left: collect real ground-truth data, technician-confirmed failure records, to retrain P1, P2 and P5 and resolve their leaked labels. Top right: a public inbound path on AKS, which means resolving the subscription-level Load Balancer quota so the ngrok tunnel is no longer needed. Bottom left: production hardening, with a high-availability database, autoscaling and centralized logging. Bottom right: move file storage from in-cluster MinIO to a managed object store, and add automatic secret rotation in Key Vault.</a:t>
             </a:r>
           </a:p>
         </p:txBody>
@@ -30761,7 +30901,7 @@
                 </a:solidFill>
                 <a:latin typeface="Arial Black"/>
               </a:rPr>
-              <a:t>A solid EAM foundation and an honest predictive AI, secured and deployable on Azure</a:t>
+              <a:t>A complete maintenance platform with honest AI predictions, secured and ready to run on Azure</a:t>
             </a:r>
           </a:p>
         </p:txBody>
@@ -30837,22 +30977,13 @@
           <a:p>
             <a:pPr algn="l"/>
             <a:r>
-              <a:rPr sz="1400" b="0" i="0">
+              <a:rPr sz="1400" b="1" i="0">
                 <a:solidFill>
                   <a:srgbClr val="000000"/>
                 </a:solidFill>
                 <a:latin typeface="Arial"/>
               </a:rPr>
-              <a:t>→  </a:t>
-            </a:r>
-            <a:r>
-              <a:rPr sz="1400" b="1" i="0">
-                <a:solidFill>
-                  <a:srgbClr val="000000"/>
-                </a:solidFill>
-                <a:latin typeface="Arial"/>
-              </a:rPr>
-              <a:t>Operational management + 7 ML models + RAG assistant, in one platform</a:t>
+              <a:t>→  One platform for daily maintenance work, 7 prediction models and an AI assistant</a:t>
             </a:r>
           </a:p>
         </p:txBody>
@@ -30928,22 +31059,13 @@
           <a:p>
             <a:pPr algn="l"/>
             <a:r>
-              <a:rPr sz="1400" b="0" i="0">
+              <a:rPr sz="1400" b="1" i="0">
                 <a:solidFill>
                   <a:srgbClr val="000000"/>
                 </a:solidFill>
                 <a:latin typeface="Arial"/>
               </a:rPr>
-              <a:t>→  </a:t>
-            </a:r>
-            <a:r>
-              <a:rPr sz="1400" b="1" i="0">
-                <a:solidFill>
-                  <a:srgbClr val="000000"/>
-                </a:solidFill>
-                <a:latin typeface="Arial"/>
-              </a:rPr>
-              <a:t>Every feature specified, planned, built, then verified, with full traceability</a:t>
+              <a:t>→  Every feature was specified, planned, built, then tested, and each step is traceable</a:t>
             </a:r>
           </a:p>
         </p:txBody>
@@ -31019,22 +31141,13 @@
           <a:p>
             <a:pPr algn="l"/>
             <a:r>
-              <a:rPr sz="1400" b="0" i="0">
+              <a:rPr sz="1400" b="1" i="0">
                 <a:solidFill>
                   <a:srgbClr val="000000"/>
                 </a:solidFill>
                 <a:latin typeface="Arial"/>
               </a:rPr>
-              <a:t>→  </a:t>
-            </a:r>
-            <a:r>
-              <a:rPr sz="1400" b="1" i="0">
-                <a:solidFill>
-                  <a:srgbClr val="000000"/>
-                </a:solidFill>
-                <a:latin typeface="Arial"/>
-              </a:rPr>
-              <a:t>Honest rigor: label leakage was detected and reported, not hidden</a:t>
+              <a:t>→  Honest results: models whose scores looked too good were flagged, not hidden</a:t>
             </a:r>
           </a:p>
         </p:txBody>
@@ -31110,22 +31223,13 @@
           <a:p>
             <a:pPr algn="l"/>
             <a:r>
-              <a:rPr sz="1400" b="0" i="0">
+              <a:rPr sz="1400" b="1" i="0">
                 <a:solidFill>
                   <a:srgbClr val="000000"/>
                 </a:solidFill>
                 <a:latin typeface="Arial"/>
               </a:rPr>
-              <a:t>→  </a:t>
-            </a:r>
-            <a:r>
-              <a:rPr sz="1400" b="1" i="0">
-                <a:solidFill>
-                  <a:srgbClr val="000000"/>
-                </a:solidFill>
-                <a:latin typeface="Arial"/>
-              </a:rPr>
-              <a:t>Secured by a 6-stage pipeline; staging and prod namespaces running on AKS</a:t>
+              <a:t>→  Every code change passes 6 security checks; test and live copies run on Azure</a:t>
             </a:r>
           </a:p>
         </p:txBody>
@@ -31500,7 +31604,7 @@
                 </a:solidFill>
                 <a:latin typeface="Arial"/>
               </a:rPr>
-              <a:t>Real ground-truth data to resolve the leaked labels (P1 / P2 / P5)</a:t>
+              <a:t>Retrain three models on real failures confirmed by technicians</a:t>
             </a:r>
           </a:p>
         </p:txBody>
@@ -31580,7 +31684,7 @@
                 </a:solidFill>
                 <a:latin typeface="Arial"/>
               </a:rPr>
-              <a:t>Public inbound path on AKS (resolve the Load Balancer quota)</a:t>
+              <a:t>Open a direct public entrance on Azure (lift the account limit)</a:t>
             </a:r>
           </a:p>
         </p:txBody>
@@ -31660,7 +31764,7 @@
                 </a:solidFill>
                 <a:latin typeface="Arial"/>
               </a:rPr>
-              <a:t>Production hardening: HA database, autoscaling, centralized logs</a:t>
+              <a:t>Sturdier production: a standby database, automatic scaling, logs in one place</a:t>
             </a:r>
           </a:p>
         </p:txBody>
@@ -31740,7 +31844,7 @@
                 </a:solidFill>
                 <a:latin typeface="Arial"/>
               </a:rPr>
-              <a:t>Managed object storage and secret rotation</a:t>
+              <a:t>Let Azure store our files, and change passwords automatically</a:t>
             </a:r>
           </a:p>
         </p:txBody>

</xml_diff>